<commit_message>
R Kurs bis Funktionen gesichtet und überarbeitet
</commit_message>
<xml_diff>
--- a/Präsentationen/Einführung in R.pptx
+++ b/Präsentationen/Einführung in R.pptx
@@ -18,33 +18,34 @@
     <p:sldId id="298" r:id="rId12"/>
     <p:sldId id="258" r:id="rId13"/>
     <p:sldId id="260" r:id="rId14"/>
-    <p:sldId id="274" r:id="rId15"/>
-    <p:sldId id="276" r:id="rId16"/>
-    <p:sldId id="275" r:id="rId17"/>
-    <p:sldId id="261" r:id="rId18"/>
-    <p:sldId id="277" r:id="rId19"/>
-    <p:sldId id="278" r:id="rId20"/>
-    <p:sldId id="269" r:id="rId21"/>
-    <p:sldId id="279" r:id="rId22"/>
-    <p:sldId id="283" r:id="rId23"/>
-    <p:sldId id="280" r:id="rId24"/>
-    <p:sldId id="282" r:id="rId25"/>
-    <p:sldId id="262" r:id="rId26"/>
-    <p:sldId id="284" r:id="rId27"/>
-    <p:sldId id="281" r:id="rId28"/>
-    <p:sldId id="263" r:id="rId29"/>
-    <p:sldId id="285" r:id="rId30"/>
-    <p:sldId id="287" r:id="rId31"/>
-    <p:sldId id="288" r:id="rId32"/>
-    <p:sldId id="289" r:id="rId33"/>
-    <p:sldId id="291" r:id="rId34"/>
-    <p:sldId id="290" r:id="rId35"/>
-    <p:sldId id="292" r:id="rId36"/>
-    <p:sldId id="293" r:id="rId37"/>
-    <p:sldId id="294" r:id="rId38"/>
-    <p:sldId id="295" r:id="rId39"/>
-    <p:sldId id="296" r:id="rId40"/>
-    <p:sldId id="297" r:id="rId41"/>
+    <p:sldId id="299" r:id="rId15"/>
+    <p:sldId id="274" r:id="rId16"/>
+    <p:sldId id="276" r:id="rId17"/>
+    <p:sldId id="275" r:id="rId18"/>
+    <p:sldId id="261" r:id="rId19"/>
+    <p:sldId id="277" r:id="rId20"/>
+    <p:sldId id="278" r:id="rId21"/>
+    <p:sldId id="269" r:id="rId22"/>
+    <p:sldId id="279" r:id="rId23"/>
+    <p:sldId id="283" r:id="rId24"/>
+    <p:sldId id="280" r:id="rId25"/>
+    <p:sldId id="282" r:id="rId26"/>
+    <p:sldId id="262" r:id="rId27"/>
+    <p:sldId id="284" r:id="rId28"/>
+    <p:sldId id="281" r:id="rId29"/>
+    <p:sldId id="263" r:id="rId30"/>
+    <p:sldId id="285" r:id="rId31"/>
+    <p:sldId id="287" r:id="rId32"/>
+    <p:sldId id="288" r:id="rId33"/>
+    <p:sldId id="289" r:id="rId34"/>
+    <p:sldId id="291" r:id="rId35"/>
+    <p:sldId id="290" r:id="rId36"/>
+    <p:sldId id="292" r:id="rId37"/>
+    <p:sldId id="293" r:id="rId38"/>
+    <p:sldId id="294" r:id="rId39"/>
+    <p:sldId id="295" r:id="rId40"/>
+    <p:sldId id="296" r:id="rId41"/>
+    <p:sldId id="297" r:id="rId42"/>
   </p:sldIdLst>
   <p:sldSz cx="12192000" cy="6858000"/>
   <p:notesSz cx="6858000" cy="9144000"/>
@@ -351,7 +352,7 @@
           <a:p>
             <a:fld id="{3F46AE61-50B3-4440-BB01-1FF85E3E82A7}" type="datetimeFigureOut">
               <a:rPr lang="de-DE" smtClean="0"/>
-              <a:t>28.06.2025</a:t>
+              <a:t>30.06.2025</a:t>
             </a:fld>
             <a:endParaRPr lang="de-DE"/>
           </a:p>
@@ -541,7 +542,7 @@
           <a:p>
             <a:fld id="{3F46AE61-50B3-4440-BB01-1FF85E3E82A7}" type="datetimeFigureOut">
               <a:rPr lang="de-DE" smtClean="0"/>
-              <a:t>28.06.2025</a:t>
+              <a:t>30.06.2025</a:t>
             </a:fld>
             <a:endParaRPr lang="de-DE"/>
           </a:p>
@@ -721,7 +722,7 @@
           <a:p>
             <a:fld id="{3F46AE61-50B3-4440-BB01-1FF85E3E82A7}" type="datetimeFigureOut">
               <a:rPr lang="de-DE" smtClean="0"/>
-              <a:t>28.06.2025</a:t>
+              <a:t>30.06.2025</a:t>
             </a:fld>
             <a:endParaRPr lang="de-DE"/>
           </a:p>
@@ -891,7 +892,7 @@
           <a:p>
             <a:fld id="{3F46AE61-50B3-4440-BB01-1FF85E3E82A7}" type="datetimeFigureOut">
               <a:rPr lang="de-DE" smtClean="0"/>
-              <a:t>28.06.2025</a:t>
+              <a:t>30.06.2025</a:t>
             </a:fld>
             <a:endParaRPr lang="de-DE"/>
           </a:p>
@@ -1147,7 +1148,7 @@
           <a:p>
             <a:fld id="{3F46AE61-50B3-4440-BB01-1FF85E3E82A7}" type="datetimeFigureOut">
               <a:rPr lang="de-DE" smtClean="0"/>
-              <a:t>28.06.2025</a:t>
+              <a:t>30.06.2025</a:t>
             </a:fld>
             <a:endParaRPr lang="de-DE"/>
           </a:p>
@@ -1435,7 +1436,7 @@
           <a:p>
             <a:fld id="{3F46AE61-50B3-4440-BB01-1FF85E3E82A7}" type="datetimeFigureOut">
               <a:rPr lang="de-DE" smtClean="0"/>
-              <a:t>28.06.2025</a:t>
+              <a:t>30.06.2025</a:t>
             </a:fld>
             <a:endParaRPr lang="de-DE"/>
           </a:p>
@@ -1873,7 +1874,7 @@
           <a:p>
             <a:fld id="{3F46AE61-50B3-4440-BB01-1FF85E3E82A7}" type="datetimeFigureOut">
               <a:rPr lang="de-DE" smtClean="0"/>
-              <a:t>28.06.2025</a:t>
+              <a:t>30.06.2025</a:t>
             </a:fld>
             <a:endParaRPr lang="de-DE"/>
           </a:p>
@@ -1991,7 +1992,7 @@
           <a:p>
             <a:fld id="{3F46AE61-50B3-4440-BB01-1FF85E3E82A7}" type="datetimeFigureOut">
               <a:rPr lang="de-DE" smtClean="0"/>
-              <a:t>28.06.2025</a:t>
+              <a:t>30.06.2025</a:t>
             </a:fld>
             <a:endParaRPr lang="de-DE"/>
           </a:p>
@@ -2086,7 +2087,7 @@
           <a:p>
             <a:fld id="{3F46AE61-50B3-4440-BB01-1FF85E3E82A7}" type="datetimeFigureOut">
               <a:rPr lang="de-DE" smtClean="0"/>
-              <a:t>28.06.2025</a:t>
+              <a:t>30.06.2025</a:t>
             </a:fld>
             <a:endParaRPr lang="de-DE"/>
           </a:p>
@@ -2442,7 +2443,7 @@
           <a:p>
             <a:fld id="{3F46AE61-50B3-4440-BB01-1FF85E3E82A7}" type="datetimeFigureOut">
               <a:rPr lang="de-DE" smtClean="0"/>
-              <a:t>28.06.2025</a:t>
+              <a:t>30.06.2025</a:t>
             </a:fld>
             <a:endParaRPr lang="de-DE"/>
           </a:p>
@@ -2758,7 +2759,7 @@
           <a:p>
             <a:fld id="{3F46AE61-50B3-4440-BB01-1FF85E3E82A7}" type="datetimeFigureOut">
               <a:rPr lang="de-DE" smtClean="0"/>
-              <a:t>28.06.2025</a:t>
+              <a:t>30.06.2025</a:t>
             </a:fld>
             <a:endParaRPr lang="de-DE"/>
           </a:p>
@@ -2991,7 +2992,7 @@
           <a:p>
             <a:fld id="{3F46AE61-50B3-4440-BB01-1FF85E3E82A7}" type="datetimeFigureOut">
               <a:rPr lang="de-DE" smtClean="0"/>
-              <a:t>28.06.2025</a:t>
+              <a:t>30.06.2025</a:t>
             </a:fld>
             <a:endParaRPr lang="de-DE"/>
           </a:p>
@@ -5198,7 +5199,7 @@
         </p:spPr>
         <p:txBody>
           <a:bodyPr>
-            <a:normAutofit fontScale="92500" lnSpcReduction="20000"/>
+            <a:normAutofit fontScale="70000" lnSpcReduction="20000"/>
           </a:bodyPr>
           <a:lstStyle/>
           <a:p>
@@ -5274,14 +5275,46 @@
             <a:pPr marL="4572" lvl="1" indent="0">
               <a:buNone/>
             </a:pPr>
-            <a:endParaRPr lang="de-DE" dirty="0"/>
+            <a:endParaRPr lang="de-DE" sz="2600" dirty="0"/>
           </a:p>
           <a:p>
             <a:pPr lvl="1">
               <a:buFont typeface="Arial" panose="020B0604020202020204" pitchFamily="34" charset="0"/>
               <a:buChar char="•"/>
             </a:pPr>
-            <a:endParaRPr lang="de-DE" dirty="0"/>
+            <a:r>
+              <a:rPr lang="de-DE" sz="2600" b="1" dirty="0"/>
+              <a:t>Verknüpfung logischer Abfragen</a:t>
+            </a:r>
+          </a:p>
+          <a:p>
+            <a:pPr marL="4572" lvl="1" indent="0">
+              <a:buNone/>
+            </a:pPr>
+            <a:r>
+              <a:rPr lang="de-DE" dirty="0"/>
+              <a:t>	</a:t>
+            </a:r>
+            <a:r>
+              <a:rPr lang="de-DE" sz="2600" dirty="0"/>
+              <a:t>Und: &amp;&amp;		gibt TRUE zurück wenn beide Bedingungen TRUE sind</a:t>
+            </a:r>
+          </a:p>
+          <a:p>
+            <a:pPr marL="4572" lvl="1" indent="0">
+              <a:buNone/>
+            </a:pPr>
+            <a:r>
+              <a:rPr lang="de-DE" sz="2600" dirty="0"/>
+              <a:t>	Oder: ||		gibt TRUE zurück wenn eine der beiden Bedingungen TRUE ist</a:t>
+            </a:r>
+          </a:p>
+          <a:p>
+            <a:pPr lvl="1">
+              <a:buFont typeface="Arial" panose="020B0604020202020204" pitchFamily="34" charset="0"/>
+              <a:buChar char="•"/>
+            </a:pPr>
+            <a:endParaRPr lang="de-DE" sz="2600" dirty="0"/>
           </a:p>
           <a:p>
             <a:pPr lvl="1">
@@ -5659,7 +5692,7 @@
                                         <p:tgtEl>
                                           <p:spTgt spid="3">
                                             <p:txEl>
-                                              <p:pRg st="10" end="10"/>
+                                              <p:pRg st="9" end="9"/>
                                             </p:txEl>
                                           </p:spTgt>
                                         </p:tgtEl>
@@ -5708,7 +5741,7 @@
                                         <p:tgtEl>
                                           <p:spTgt spid="3">
                                             <p:txEl>
-                                              <p:pRg st="11" end="11"/>
+                                              <p:pRg st="10" end="10"/>
                                             </p:txEl>
                                           </p:spTgt>
                                         </p:tgtEl>
@@ -5757,7 +5790,154 @@
                                         <p:tgtEl>
                                           <p:spTgt spid="3">
                                             <p:txEl>
-                                              <p:pRg st="12" end="12"/>
+                                              <p:pRg st="11" end="11"/>
+                                            </p:txEl>
+                                          </p:spTgt>
+                                        </p:tgtEl>
+                                        <p:attrNameLst>
+                                          <p:attrName>style.visibility</p:attrName>
+                                        </p:attrNameLst>
+                                      </p:cBhvr>
+                                      <p:to>
+                                        <p:strVal val="visible"/>
+                                      </p:to>
+                                    </p:set>
+                                  </p:childTnLst>
+                                </p:cTn>
+                              </p:par>
+                            </p:childTnLst>
+                          </p:cTn>
+                        </p:par>
+                      </p:childTnLst>
+                    </p:cTn>
+                  </p:par>
+                  <p:par>
+                    <p:cTn id="39" fill="hold">
+                      <p:stCondLst>
+                        <p:cond delay="indefinite"/>
+                      </p:stCondLst>
+                      <p:childTnLst>
+                        <p:par>
+                          <p:cTn id="40" fill="hold">
+                            <p:stCondLst>
+                              <p:cond delay="0"/>
+                            </p:stCondLst>
+                            <p:childTnLst>
+                              <p:par>
+                                <p:cTn id="41" presetID="1" presetClass="entr" presetSubtype="0" fill="hold" nodeType="clickEffect">
+                                  <p:stCondLst>
+                                    <p:cond delay="0"/>
+                                  </p:stCondLst>
+                                  <p:childTnLst>
+                                    <p:set>
+                                      <p:cBhvr>
+                                        <p:cTn id="42" dur="1" fill="hold">
+                                          <p:stCondLst>
+                                            <p:cond delay="0"/>
+                                          </p:stCondLst>
+                                        </p:cTn>
+                                        <p:tgtEl>
+                                          <p:spTgt spid="3">
+                                            <p:txEl>
+                                              <p:pRg st="13" end="13"/>
+                                            </p:txEl>
+                                          </p:spTgt>
+                                        </p:tgtEl>
+                                        <p:attrNameLst>
+                                          <p:attrName>style.visibility</p:attrName>
+                                        </p:attrNameLst>
+                                      </p:cBhvr>
+                                      <p:to>
+                                        <p:strVal val="visible"/>
+                                      </p:to>
+                                    </p:set>
+                                  </p:childTnLst>
+                                </p:cTn>
+                              </p:par>
+                            </p:childTnLst>
+                          </p:cTn>
+                        </p:par>
+                      </p:childTnLst>
+                    </p:cTn>
+                  </p:par>
+                  <p:par>
+                    <p:cTn id="43" fill="hold">
+                      <p:stCondLst>
+                        <p:cond delay="indefinite"/>
+                      </p:stCondLst>
+                      <p:childTnLst>
+                        <p:par>
+                          <p:cTn id="44" fill="hold">
+                            <p:stCondLst>
+                              <p:cond delay="0"/>
+                            </p:stCondLst>
+                            <p:childTnLst>
+                              <p:par>
+                                <p:cTn id="45" presetID="1" presetClass="entr" presetSubtype="0" fill="hold" nodeType="clickEffect">
+                                  <p:stCondLst>
+                                    <p:cond delay="0"/>
+                                  </p:stCondLst>
+                                  <p:childTnLst>
+                                    <p:set>
+                                      <p:cBhvr>
+                                        <p:cTn id="46" dur="1" fill="hold">
+                                          <p:stCondLst>
+                                            <p:cond delay="0"/>
+                                          </p:stCondLst>
+                                        </p:cTn>
+                                        <p:tgtEl>
+                                          <p:spTgt spid="3">
+                                            <p:txEl>
+                                              <p:pRg st="14" end="14"/>
+                                            </p:txEl>
+                                          </p:spTgt>
+                                        </p:tgtEl>
+                                        <p:attrNameLst>
+                                          <p:attrName>style.visibility</p:attrName>
+                                        </p:attrNameLst>
+                                      </p:cBhvr>
+                                      <p:to>
+                                        <p:strVal val="visible"/>
+                                      </p:to>
+                                    </p:set>
+                                  </p:childTnLst>
+                                </p:cTn>
+                              </p:par>
+                            </p:childTnLst>
+                          </p:cTn>
+                        </p:par>
+                      </p:childTnLst>
+                    </p:cTn>
+                  </p:par>
+                  <p:par>
+                    <p:cTn id="47" fill="hold">
+                      <p:stCondLst>
+                        <p:cond delay="indefinite"/>
+                      </p:stCondLst>
+                      <p:childTnLst>
+                        <p:par>
+                          <p:cTn id="48" fill="hold">
+                            <p:stCondLst>
+                              <p:cond delay="0"/>
+                            </p:stCondLst>
+                            <p:childTnLst>
+                              <p:par>
+                                <p:cTn id="49" presetID="1" presetClass="entr" presetSubtype="0" fill="hold" nodeType="clickEffect">
+                                  <p:stCondLst>
+                                    <p:cond delay="0"/>
+                                  </p:stCondLst>
+                                  <p:childTnLst>
+                                    <p:set>
+                                      <p:cBhvr>
+                                        <p:cTn id="50" dur="1" fill="hold">
+                                          <p:stCondLst>
+                                            <p:cond delay="0"/>
+                                          </p:stCondLst>
+                                        </p:cTn>
+                                        <p:tgtEl>
+                                          <p:spTgt spid="3">
+                                            <p:txEl>
+                                              <p:pRg st="15" end="15"/>
                                             </p:txEl>
                                           </p:spTgt>
                                         </p:tgtEl>
@@ -5843,7 +6023,7 @@
           <a:p>
             <a:r>
               <a:rPr lang="de-DE" b="1" dirty="0"/>
-              <a:t>Variablen</a:t>
+              <a:t>Werte</a:t>
             </a:r>
           </a:p>
         </p:txBody>
@@ -5864,10 +6044,15 @@
             <p:ph idx="1"/>
           </p:nvPr>
         </p:nvSpPr>
-        <p:spPr/>
+        <p:spPr>
+          <a:xfrm>
+            <a:off x="676656" y="2011681"/>
+            <a:ext cx="10753343" cy="3466836"/>
+          </a:xfrm>
+        </p:spPr>
         <p:txBody>
           <a:bodyPr>
-            <a:normAutofit/>
+            <a:normAutofit fontScale="92500"/>
           </a:bodyPr>
           <a:lstStyle/>
           <a:p>
@@ -5880,7 +6065,7 @@
             </a:pPr>
             <a:r>
               <a:rPr lang="de-DE" sz="2800" dirty="0"/>
-              <a:t>Speichern Werte wie Zahlen oder Wörter</a:t>
+              <a:t>Bestehen aus einer Zahl oder Text</a:t>
             </a:r>
           </a:p>
           <a:p>
@@ -5893,7 +6078,7 @@
             </a:pPr>
             <a:r>
               <a:rPr lang="de-DE" sz="2800" dirty="0"/>
-              <a:t>Erst als Variable ist ein Wert vom Rechner auffindbar</a:t>
+              <a:t>Auf Zahlen lassen sich mathematische und logische Operatoren anwenden</a:t>
             </a:r>
           </a:p>
           <a:p>
@@ -5906,7 +6091,7 @@
             </a:pPr>
             <a:r>
               <a:rPr lang="de-DE" sz="2800" dirty="0"/>
-              <a:t>Lassen sich wieder überschreiben</a:t>
+              <a:t>Auf Text nur logische Operatoren, und manchmal passiert Unerwartetes</a:t>
             </a:r>
           </a:p>
         </p:txBody>
@@ -6123,6 +6308,305 @@
           <p:cNvPr id="2" name="Titel 1">
             <a:extLst>
               <a:ext uri="{FF2B5EF4-FFF2-40B4-BE49-F238E27FC236}">
+                <a16:creationId xmlns:a16="http://schemas.microsoft.com/office/drawing/2014/main" id="{1ED96637-3F36-4C1D-801B-B0EDFA6C4EBA}"/>
+              </a:ext>
+            </a:extLst>
+          </p:cNvPr>
+          <p:cNvSpPr>
+            <a:spLocks noGrp="1"/>
+          </p:cNvSpPr>
+          <p:nvPr>
+            <p:ph type="title"/>
+          </p:nvPr>
+        </p:nvSpPr>
+        <p:spPr/>
+        <p:txBody>
+          <a:bodyPr/>
+          <a:lstStyle/>
+          <a:p>
+            <a:r>
+              <a:rPr lang="de-DE" b="1" dirty="0"/>
+              <a:t>Variablen</a:t>
+            </a:r>
+          </a:p>
+        </p:txBody>
+      </p:sp>
+      <p:sp>
+        <p:nvSpPr>
+          <p:cNvPr id="3" name="Inhaltsplatzhalter 2">
+            <a:extLst>
+              <a:ext uri="{FF2B5EF4-FFF2-40B4-BE49-F238E27FC236}">
+                <a16:creationId xmlns:a16="http://schemas.microsoft.com/office/drawing/2014/main" id="{D2354EA2-205F-4306-ACBB-57BA81043F32}"/>
+              </a:ext>
+            </a:extLst>
+          </p:cNvPr>
+          <p:cNvSpPr>
+            <a:spLocks noGrp="1"/>
+          </p:cNvSpPr>
+          <p:nvPr>
+            <p:ph idx="1"/>
+          </p:nvPr>
+        </p:nvSpPr>
+        <p:spPr/>
+        <p:txBody>
+          <a:bodyPr>
+            <a:normAutofit/>
+          </a:bodyPr>
+          <a:lstStyle/>
+          <a:p>
+            <a:pPr lvl="1">
+              <a:lnSpc>
+                <a:spcPct val="200000"/>
+              </a:lnSpc>
+              <a:buFont typeface="Arial" panose="020B0604020202020204" pitchFamily="34" charset="0"/>
+              <a:buChar char="•"/>
+            </a:pPr>
+            <a:r>
+              <a:rPr lang="de-DE" sz="2800" dirty="0"/>
+              <a:t>Speichern R Objekte wie Werte, Vektoren etc. aber auch Funktionen</a:t>
+            </a:r>
+            <a:endParaRPr lang="de-DE" sz="1800" dirty="0"/>
+          </a:p>
+          <a:p>
+            <a:pPr lvl="1">
+              <a:lnSpc>
+                <a:spcPct val="200000"/>
+              </a:lnSpc>
+              <a:buFont typeface="Arial" panose="020B0604020202020204" pitchFamily="34" charset="0"/>
+              <a:buChar char="•"/>
+            </a:pPr>
+            <a:r>
+              <a:rPr lang="de-DE" sz="2800" dirty="0"/>
+              <a:t>Erst als Variable ist ein R Objekt vom Rechner auffindbar</a:t>
+            </a:r>
+          </a:p>
+          <a:p>
+            <a:pPr lvl="1">
+              <a:lnSpc>
+                <a:spcPct val="200000"/>
+              </a:lnSpc>
+              <a:buFont typeface="Arial" panose="020B0604020202020204" pitchFamily="34" charset="0"/>
+              <a:buChar char="•"/>
+            </a:pPr>
+            <a:r>
+              <a:rPr lang="de-DE" sz="2800" dirty="0"/>
+              <a:t>Lassen sich wieder überschreiben</a:t>
+            </a:r>
+          </a:p>
+        </p:txBody>
+      </p:sp>
+    </p:spTree>
+    <p:extLst>
+      <p:ext uri="{BB962C8B-B14F-4D97-AF65-F5344CB8AC3E}">
+        <p14:creationId xmlns:p14="http://schemas.microsoft.com/office/powerpoint/2010/main" val="2293348802"/>
+      </p:ext>
+    </p:extLst>
+  </p:cSld>
+  <p:clrMapOvr>
+    <a:masterClrMapping/>
+  </p:clrMapOvr>
+  <p:timing>
+    <p:tnLst>
+      <p:par>
+        <p:cTn id="1" dur="indefinite" restart="never" nodeType="tmRoot">
+          <p:childTnLst>
+            <p:seq concurrent="1" nextAc="seek">
+              <p:cTn id="2" dur="indefinite" nodeType="mainSeq">
+                <p:childTnLst>
+                  <p:par>
+                    <p:cTn id="3" fill="hold">
+                      <p:stCondLst>
+                        <p:cond delay="indefinite"/>
+                      </p:stCondLst>
+                      <p:childTnLst>
+                        <p:par>
+                          <p:cTn id="4" fill="hold">
+                            <p:stCondLst>
+                              <p:cond delay="0"/>
+                            </p:stCondLst>
+                            <p:childTnLst>
+                              <p:par>
+                                <p:cTn id="5" presetID="1" presetClass="entr" presetSubtype="0" fill="hold" nodeType="clickEffect">
+                                  <p:stCondLst>
+                                    <p:cond delay="0"/>
+                                  </p:stCondLst>
+                                  <p:childTnLst>
+                                    <p:set>
+                                      <p:cBhvr>
+                                        <p:cTn id="6" dur="1" fill="hold">
+                                          <p:stCondLst>
+                                            <p:cond delay="0"/>
+                                          </p:stCondLst>
+                                        </p:cTn>
+                                        <p:tgtEl>
+                                          <p:spTgt spid="3">
+                                            <p:txEl>
+                                              <p:pRg st="0" end="0"/>
+                                            </p:txEl>
+                                          </p:spTgt>
+                                        </p:tgtEl>
+                                        <p:attrNameLst>
+                                          <p:attrName>style.visibility</p:attrName>
+                                        </p:attrNameLst>
+                                      </p:cBhvr>
+                                      <p:to>
+                                        <p:strVal val="visible"/>
+                                      </p:to>
+                                    </p:set>
+                                  </p:childTnLst>
+                                </p:cTn>
+                              </p:par>
+                            </p:childTnLst>
+                          </p:cTn>
+                        </p:par>
+                      </p:childTnLst>
+                    </p:cTn>
+                  </p:par>
+                  <p:par>
+                    <p:cTn id="7" fill="hold">
+                      <p:stCondLst>
+                        <p:cond delay="indefinite"/>
+                      </p:stCondLst>
+                      <p:childTnLst>
+                        <p:par>
+                          <p:cTn id="8" fill="hold">
+                            <p:stCondLst>
+                              <p:cond delay="0"/>
+                            </p:stCondLst>
+                            <p:childTnLst>
+                              <p:par>
+                                <p:cTn id="9" presetID="1" presetClass="entr" presetSubtype="0" fill="hold" nodeType="clickEffect">
+                                  <p:stCondLst>
+                                    <p:cond delay="0"/>
+                                  </p:stCondLst>
+                                  <p:childTnLst>
+                                    <p:set>
+                                      <p:cBhvr>
+                                        <p:cTn id="10" dur="1" fill="hold">
+                                          <p:stCondLst>
+                                            <p:cond delay="0"/>
+                                          </p:stCondLst>
+                                        </p:cTn>
+                                        <p:tgtEl>
+                                          <p:spTgt spid="3">
+                                            <p:txEl>
+                                              <p:pRg st="1" end="1"/>
+                                            </p:txEl>
+                                          </p:spTgt>
+                                        </p:tgtEl>
+                                        <p:attrNameLst>
+                                          <p:attrName>style.visibility</p:attrName>
+                                        </p:attrNameLst>
+                                      </p:cBhvr>
+                                      <p:to>
+                                        <p:strVal val="visible"/>
+                                      </p:to>
+                                    </p:set>
+                                  </p:childTnLst>
+                                </p:cTn>
+                              </p:par>
+                            </p:childTnLst>
+                          </p:cTn>
+                        </p:par>
+                      </p:childTnLst>
+                    </p:cTn>
+                  </p:par>
+                  <p:par>
+                    <p:cTn id="11" fill="hold">
+                      <p:stCondLst>
+                        <p:cond delay="indefinite"/>
+                      </p:stCondLst>
+                      <p:childTnLst>
+                        <p:par>
+                          <p:cTn id="12" fill="hold">
+                            <p:stCondLst>
+                              <p:cond delay="0"/>
+                            </p:stCondLst>
+                            <p:childTnLst>
+                              <p:par>
+                                <p:cTn id="13" presetID="1" presetClass="entr" presetSubtype="0" fill="hold" nodeType="clickEffect">
+                                  <p:stCondLst>
+                                    <p:cond delay="0"/>
+                                  </p:stCondLst>
+                                  <p:childTnLst>
+                                    <p:set>
+                                      <p:cBhvr>
+                                        <p:cTn id="14" dur="1" fill="hold">
+                                          <p:stCondLst>
+                                            <p:cond delay="0"/>
+                                          </p:stCondLst>
+                                        </p:cTn>
+                                        <p:tgtEl>
+                                          <p:spTgt spid="3">
+                                            <p:txEl>
+                                              <p:pRg st="2" end="2"/>
+                                            </p:txEl>
+                                          </p:spTgt>
+                                        </p:tgtEl>
+                                        <p:attrNameLst>
+                                          <p:attrName>style.visibility</p:attrName>
+                                        </p:attrNameLst>
+                                      </p:cBhvr>
+                                      <p:to>
+                                        <p:strVal val="visible"/>
+                                      </p:to>
+                                    </p:set>
+                                  </p:childTnLst>
+                                </p:cTn>
+                              </p:par>
+                            </p:childTnLst>
+                          </p:cTn>
+                        </p:par>
+                      </p:childTnLst>
+                    </p:cTn>
+                  </p:par>
+                </p:childTnLst>
+              </p:cTn>
+              <p:prevCondLst>
+                <p:cond evt="onPrev" delay="0">
+                  <p:tgtEl>
+                    <p:sldTgt/>
+                  </p:tgtEl>
+                </p:cond>
+              </p:prevCondLst>
+              <p:nextCondLst>
+                <p:cond evt="onNext" delay="0">
+                  <p:tgtEl>
+                    <p:sldTgt/>
+                  </p:tgtEl>
+                </p:cond>
+              </p:nextCondLst>
+            </p:seq>
+          </p:childTnLst>
+        </p:cTn>
+      </p:par>
+    </p:tnLst>
+  </p:timing>
+</p:sld>
+</file>
+
+<file path=ppt/slides/slide15.xml><?xml version="1.0" encoding="utf-8"?>
+<p:sld xmlns:a="http://schemas.openxmlformats.org/drawingml/2006/main" xmlns:r="http://schemas.openxmlformats.org/officeDocument/2006/relationships" xmlns:p="http://schemas.openxmlformats.org/presentationml/2006/main">
+  <p:cSld>
+    <p:spTree>
+      <p:nvGrpSpPr>
+        <p:cNvPr id="1" name=""/>
+        <p:cNvGrpSpPr/>
+        <p:nvPr/>
+      </p:nvGrpSpPr>
+      <p:grpSpPr>
+        <a:xfrm>
+          <a:off x="0" y="0"/>
+          <a:ext cx="0" cy="0"/>
+          <a:chOff x="0" y="0"/>
+          <a:chExt cx="0" cy="0"/>
+        </a:xfrm>
+      </p:grpSpPr>
+      <p:sp>
+        <p:nvSpPr>
+          <p:cNvPr id="2" name="Titel 1">
+            <a:extLst>
+              <a:ext uri="{FF2B5EF4-FFF2-40B4-BE49-F238E27FC236}">
                 <a16:creationId xmlns:a16="http://schemas.microsoft.com/office/drawing/2014/main" id="{A6CE7550-881F-4977-9D92-B620BA6CAF5F}"/>
               </a:ext>
             </a:extLst>
@@ -6137,15 +6621,17 @@
         <p:spPr>
           <a:xfrm>
             <a:off x="619902" y="223934"/>
-            <a:ext cx="10772775" cy="1112702"/>
+            <a:ext cx="10636677" cy="564342"/>
           </a:xfrm>
         </p:spPr>
         <p:txBody>
-          <a:bodyPr/>
+          <a:bodyPr>
+            <a:normAutofit fontScale="90000"/>
+          </a:bodyPr>
           <a:lstStyle/>
           <a:p>
             <a:r>
-              <a:rPr lang="de-DE" b="1" dirty="0"/>
+              <a:rPr lang="de-DE" sz="4000" b="1" dirty="0"/>
               <a:t>Übung: Operatoren und Variablen</a:t>
             </a:r>
           </a:p>
@@ -6169,19 +6655,21 @@
         </p:nvSpPr>
         <p:spPr>
           <a:xfrm>
-            <a:off x="676656" y="1380931"/>
-            <a:ext cx="11142120" cy="4802155"/>
+            <a:off x="676656" y="1213945"/>
+            <a:ext cx="11142120" cy="4969142"/>
           </a:xfrm>
         </p:spPr>
         <p:txBody>
           <a:bodyPr>
-            <a:normAutofit lnSpcReduction="10000"/>
+            <a:normAutofit fontScale="77500" lnSpcReduction="20000"/>
           </a:bodyPr>
           <a:lstStyle/>
           <a:p>
-            <a:pPr marL="457200" indent="-457200">
-              <a:buFont typeface="+mj-lt"/>
-              <a:buAutoNum type="arabicPeriod"/>
+            <a:pPr marL="0" indent="0">
+              <a:lnSpc>
+                <a:spcPct val="100000"/>
+              </a:lnSpc>
+              <a:buNone/>
             </a:pPr>
             <a:r>
               <a:rPr lang="de-DE" sz="2800" dirty="0"/>
@@ -6197,9 +6685,20 @@
             </a:r>
           </a:p>
           <a:p>
-            <a:pPr marL="457200" indent="-457200">
-              <a:buFont typeface="+mj-lt"/>
-              <a:buAutoNum type="arabicPeriod"/>
+            <a:pPr marL="0" indent="0">
+              <a:lnSpc>
+                <a:spcPct val="100000"/>
+              </a:lnSpc>
+              <a:buNone/>
+            </a:pPr>
+            <a:endParaRPr lang="de-DE" sz="2800" dirty="0"/>
+          </a:p>
+          <a:p>
+            <a:pPr marL="0" indent="0">
+              <a:lnSpc>
+                <a:spcPct val="120000"/>
+              </a:lnSpc>
+              <a:buNone/>
             </a:pPr>
             <a:r>
               <a:rPr lang="de-DE" sz="2800" dirty="0"/>
@@ -6247,9 +6746,20 @@
             </a:r>
           </a:p>
           <a:p>
-            <a:pPr marL="457200" indent="-457200">
-              <a:buFont typeface="+mj-lt"/>
-              <a:buAutoNum type="arabicPeriod"/>
+            <a:pPr marL="0" indent="0">
+              <a:lnSpc>
+                <a:spcPct val="100000"/>
+              </a:lnSpc>
+              <a:buNone/>
+            </a:pPr>
+            <a:endParaRPr lang="de-DE" sz="2800" dirty="0"/>
+          </a:p>
+          <a:p>
+            <a:pPr marL="0" indent="0">
+              <a:lnSpc>
+                <a:spcPct val="100000"/>
+              </a:lnSpc>
+              <a:buNone/>
             </a:pPr>
             <a:r>
               <a:rPr lang="de-DE" sz="2800" dirty="0"/>
@@ -6281,9 +6791,20 @@
             </a:r>
           </a:p>
           <a:p>
-            <a:pPr marL="457200" indent="-457200">
-              <a:buFont typeface="+mj-lt"/>
-              <a:buAutoNum type="arabicPeriod"/>
+            <a:pPr marL="0" indent="0">
+              <a:lnSpc>
+                <a:spcPct val="100000"/>
+              </a:lnSpc>
+              <a:buNone/>
+            </a:pPr>
+            <a:endParaRPr lang="de-DE" sz="2800" dirty="0"/>
+          </a:p>
+          <a:p>
+            <a:pPr marL="0" indent="0">
+              <a:lnSpc>
+                <a:spcPct val="100000"/>
+              </a:lnSpc>
+              <a:buNone/>
             </a:pPr>
             <a:r>
               <a:rPr lang="de-DE" sz="2800" dirty="0"/>
@@ -6299,9 +6820,20 @@
             </a:r>
           </a:p>
           <a:p>
-            <a:pPr marL="457200" indent="-457200">
-              <a:buFont typeface="+mj-lt"/>
-              <a:buAutoNum type="arabicPeriod"/>
+            <a:pPr marL="0" indent="0">
+              <a:lnSpc>
+                <a:spcPct val="100000"/>
+              </a:lnSpc>
+              <a:buNone/>
+            </a:pPr>
+            <a:endParaRPr lang="de-DE" sz="2800" dirty="0"/>
+          </a:p>
+          <a:p>
+            <a:pPr marL="0" indent="0">
+              <a:lnSpc>
+                <a:spcPct val="120000"/>
+              </a:lnSpc>
+              <a:buNone/>
             </a:pPr>
             <a:r>
               <a:rPr lang="de-DE" sz="2800" dirty="0"/>
@@ -6321,7 +6853,11 @@
             </a:r>
             <a:r>
               <a:rPr lang="de-DE" sz="2800" dirty="0"/>
-              <a:t> eine ungerade Zahl ist (Tipp: eine gerade Zahl hat keinen Rest wenn sie durch 2 geteilt wird)</a:t>
+              <a:t> eine ungerade Zahl ist </a:t>
+            </a:r>
+            <a:r>
+              <a:rPr lang="de-DE" sz="2800" i="1" dirty="0"/>
+              <a:t>(Tipp: eine gerade Zahl hat keinen Rest wenn sie durch 2 geteilt wird)</a:t>
             </a:r>
           </a:p>
         </p:txBody>
@@ -6339,7 +6875,7 @@
 </p:sld>
 </file>
 
-<file path=ppt/slides/slide15.xml><?xml version="1.0" encoding="utf-8"?>
+<file path=ppt/slides/slide16.xml><?xml version="1.0" encoding="utf-8"?>
 <p:sld xmlns:a="http://schemas.openxmlformats.org/drawingml/2006/main" xmlns:r="http://schemas.openxmlformats.org/officeDocument/2006/relationships" xmlns:p="http://schemas.openxmlformats.org/presentationml/2006/main">
   <p:cSld>
     <p:spTree>
@@ -7188,7 +7724,7 @@
 </p:sld>
 </file>
 
-<file path=ppt/slides/slide16.xml><?xml version="1.0" encoding="utf-8"?>
+<file path=ppt/slides/slide17.xml><?xml version="1.0" encoding="utf-8"?>
 <p:sld xmlns:a="http://schemas.openxmlformats.org/drawingml/2006/main" xmlns:r="http://schemas.openxmlformats.org/officeDocument/2006/relationships" xmlns:p="http://schemas.openxmlformats.org/presentationml/2006/main">
   <p:cSld>
     <p:bg>
@@ -7263,7 +7799,7 @@
 </p:sld>
 </file>
 
-<file path=ppt/slides/slide17.xml><?xml version="1.0" encoding="utf-8"?>
+<file path=ppt/slides/slide18.xml><?xml version="1.0" encoding="utf-8"?>
 <p:sld xmlns:a="http://schemas.openxmlformats.org/drawingml/2006/main" xmlns:r="http://schemas.openxmlformats.org/officeDocument/2006/relationships" xmlns:p="http://schemas.openxmlformats.org/presentationml/2006/main">
   <p:cSld>
     <p:spTree>
@@ -7336,7 +7872,9 @@
           </a:xfrm>
         </p:spPr>
         <p:txBody>
-          <a:bodyPr/>
+          <a:bodyPr>
+            <a:normAutofit lnSpcReduction="10000"/>
+          </a:bodyPr>
           <a:lstStyle/>
           <a:p>
             <a:pPr lvl="1">
@@ -7400,14 +7938,14 @@
           <a:p>
             <a:pPr lvl="1">
               <a:lnSpc>
-                <a:spcPct val="150000"/>
+                <a:spcPct val="100000"/>
               </a:lnSpc>
               <a:buFont typeface="Arial" panose="020B0604020202020204" pitchFamily="34" charset="0"/>
               <a:buChar char="•"/>
             </a:pPr>
             <a:r>
               <a:rPr lang="de-DE" sz="2800" dirty="0"/>
-              <a:t>Indizierung mit [ ] ermöglicht Elemente aus Vektor abzufragen</a:t>
+              <a:t>Indizierung mit [ ] ermöglicht Elemente aus Vektor abzufragen und zu verändern</a:t>
             </a:r>
           </a:p>
           <a:p>
@@ -7790,7 +8328,7 @@
 </p:sld>
 </file>
 
-<file path=ppt/slides/slide18.xml><?xml version="1.0" encoding="utf-8"?>
+<file path=ppt/slides/slide19.xml><?xml version="1.0" encoding="utf-8"?>
 <p:sld xmlns:a="http://schemas.openxmlformats.org/drawingml/2006/main" xmlns:r="http://schemas.openxmlformats.org/officeDocument/2006/relationships" xmlns:p="http://schemas.openxmlformats.org/presentationml/2006/main">
   <p:cSld>
     <p:spTree>
@@ -7826,15 +8364,17 @@
         <p:spPr>
           <a:xfrm>
             <a:off x="638174" y="259041"/>
-            <a:ext cx="10772775" cy="1077596"/>
+            <a:ext cx="10772775" cy="529235"/>
           </a:xfrm>
         </p:spPr>
         <p:txBody>
-          <a:bodyPr/>
+          <a:bodyPr>
+            <a:normAutofit fontScale="90000"/>
+          </a:bodyPr>
           <a:lstStyle/>
           <a:p>
             <a:r>
-              <a:rPr lang="de-DE" b="1" dirty="0"/>
+              <a:rPr lang="de-DE" sz="4000" b="1" dirty="0"/>
               <a:t>Übung: Vektoren</a:t>
             </a:r>
           </a:p>
@@ -7864,7 +8404,7 @@
         </p:spPr>
         <p:txBody>
           <a:bodyPr>
-            <a:normAutofit lnSpcReduction="10000"/>
+            <a:normAutofit fontScale="55000" lnSpcReduction="20000"/>
           </a:bodyPr>
           <a:lstStyle/>
           <a:p>
@@ -7886,6 +8426,12 @@
             </a:r>
           </a:p>
           <a:p>
+            <a:pPr marL="0" indent="0">
+              <a:buNone/>
+            </a:pPr>
+            <a:endParaRPr lang="de-DE" sz="2800" dirty="0"/>
+          </a:p>
+          <a:p>
             <a:pPr marL="457200" indent="-457200">
               <a:buFont typeface="+mj-lt"/>
               <a:buAutoNum type="arabicPeriod"/>
@@ -7896,6 +8442,12 @@
             </a:r>
           </a:p>
           <a:p>
+            <a:pPr marL="0" indent="0">
+              <a:buNone/>
+            </a:pPr>
+            <a:endParaRPr lang="de-DE" sz="2800" dirty="0"/>
+          </a:p>
+          <a:p>
             <a:pPr marL="457200" indent="-457200">
               <a:buFont typeface="+mj-lt"/>
               <a:buAutoNum type="arabicPeriod"/>
@@ -7906,6 +8458,12 @@
             </a:r>
           </a:p>
           <a:p>
+            <a:pPr marL="0" indent="0">
+              <a:buNone/>
+            </a:pPr>
+            <a:endParaRPr lang="de-DE" sz="2800" dirty="0"/>
+          </a:p>
+          <a:p>
             <a:pPr marL="457200" indent="-457200">
               <a:buFont typeface="+mj-lt"/>
               <a:buAutoNum type="arabicPeriod"/>
@@ -7916,6 +8474,12 @@
             </a:r>
           </a:p>
           <a:p>
+            <a:pPr marL="0" indent="0">
+              <a:buNone/>
+            </a:pPr>
+            <a:endParaRPr lang="de-DE" sz="2800" dirty="0"/>
+          </a:p>
+          <a:p>
             <a:pPr marL="457200" indent="-457200">
               <a:buFont typeface="+mj-lt"/>
               <a:buAutoNum type="arabicPeriod"/>
@@ -7926,6 +8490,12 @@
             </a:r>
           </a:p>
           <a:p>
+            <a:pPr marL="0" indent="0">
+              <a:buNone/>
+            </a:pPr>
+            <a:endParaRPr lang="de-DE" sz="2800" dirty="0"/>
+          </a:p>
+          <a:p>
             <a:pPr marL="457200" indent="-457200">
               <a:buFont typeface="+mj-lt"/>
               <a:buAutoNum type="arabicPeriod"/>
@@ -7936,6 +8506,12 @@
             </a:r>
           </a:p>
           <a:p>
+            <a:pPr marL="0" indent="0">
+              <a:buNone/>
+            </a:pPr>
+            <a:endParaRPr lang="de-DE" sz="2800" dirty="0"/>
+          </a:p>
+          <a:p>
             <a:pPr marL="457200" indent="-457200">
               <a:buFont typeface="+mj-lt"/>
               <a:buAutoNum type="arabicPeriod"/>
@@ -7946,6 +8522,12 @@
             </a:r>
           </a:p>
           <a:p>
+            <a:pPr marL="0" indent="0">
+              <a:buNone/>
+            </a:pPr>
+            <a:endParaRPr lang="de-DE" sz="2800" dirty="0"/>
+          </a:p>
+          <a:p>
             <a:pPr marL="457200" indent="-457200">
               <a:buFont typeface="+mj-lt"/>
               <a:buAutoNum type="arabicPeriod"/>
@@ -7961,81 +8543,6 @@
     <p:extLst>
       <p:ext uri="{BB962C8B-B14F-4D97-AF65-F5344CB8AC3E}">
         <p14:creationId xmlns:p14="http://schemas.microsoft.com/office/powerpoint/2010/main" val="354115994"/>
-      </p:ext>
-    </p:extLst>
-  </p:cSld>
-  <p:clrMapOvr>
-    <a:masterClrMapping/>
-  </p:clrMapOvr>
-</p:sld>
-</file>
-
-<file path=ppt/slides/slide19.xml><?xml version="1.0" encoding="utf-8"?>
-<p:sld xmlns:a="http://schemas.openxmlformats.org/drawingml/2006/main" xmlns:r="http://schemas.openxmlformats.org/officeDocument/2006/relationships" xmlns:p="http://schemas.openxmlformats.org/presentationml/2006/main">
-  <p:cSld>
-    <p:bg>
-      <p:bgPr>
-        <a:solidFill>
-          <a:srgbClr val="4F81BD"/>
-        </a:solidFill>
-        <a:effectLst/>
-      </p:bgPr>
-    </p:bg>
-    <p:spTree>
-      <p:nvGrpSpPr>
-        <p:cNvPr id="1" name=""/>
-        <p:cNvGrpSpPr/>
-        <p:nvPr/>
-      </p:nvGrpSpPr>
-      <p:grpSpPr>
-        <a:xfrm>
-          <a:off x="0" y="0"/>
-          <a:ext cx="0" cy="0"/>
-          <a:chOff x="0" y="0"/>
-          <a:chExt cx="0" cy="0"/>
-        </a:xfrm>
-      </p:grpSpPr>
-      <p:sp>
-        <p:nvSpPr>
-          <p:cNvPr id="2" name="Titel 1">
-            <a:extLst>
-              <a:ext uri="{FF2B5EF4-FFF2-40B4-BE49-F238E27FC236}">
-                <a16:creationId xmlns:a16="http://schemas.microsoft.com/office/drawing/2014/main" id="{AE82C04D-C07E-4106-B772-CE20CFE0DA43}"/>
-              </a:ext>
-            </a:extLst>
-          </p:cNvPr>
-          <p:cNvSpPr>
-            <a:spLocks noGrp="1"/>
-          </p:cNvSpPr>
-          <p:nvPr>
-            <p:ph type="title"/>
-          </p:nvPr>
-        </p:nvSpPr>
-        <p:spPr>
-          <a:xfrm>
-            <a:off x="653902" y="2328333"/>
-            <a:ext cx="11153553" cy="1658198"/>
-          </a:xfrm>
-        </p:spPr>
-        <p:txBody>
-          <a:bodyPr/>
-          <a:lstStyle/>
-          <a:p>
-            <a:r>
-              <a:rPr lang="de-DE" b="1" dirty="0">
-                <a:solidFill>
-                  <a:schemeClr val="bg1"/>
-                </a:solidFill>
-              </a:rPr>
-              <a:t>Live Coding: Funktionen</a:t>
-            </a:r>
-          </a:p>
-        </p:txBody>
-      </p:sp>
-    </p:spTree>
-    <p:extLst>
-      <p:ext uri="{BB962C8B-B14F-4D97-AF65-F5344CB8AC3E}">
-        <p14:creationId xmlns:p14="http://schemas.microsoft.com/office/powerpoint/2010/main" val="1447280535"/>
       </p:ext>
     </p:extLst>
   </p:cSld>
@@ -8627,6 +9134,81 @@
 </file>
 
 <file path=ppt/slides/slide20.xml><?xml version="1.0" encoding="utf-8"?>
+<p:sld xmlns:a="http://schemas.openxmlformats.org/drawingml/2006/main" xmlns:r="http://schemas.openxmlformats.org/officeDocument/2006/relationships" xmlns:p="http://schemas.openxmlformats.org/presentationml/2006/main">
+  <p:cSld>
+    <p:bg>
+      <p:bgPr>
+        <a:solidFill>
+          <a:srgbClr val="4F81BD"/>
+        </a:solidFill>
+        <a:effectLst/>
+      </p:bgPr>
+    </p:bg>
+    <p:spTree>
+      <p:nvGrpSpPr>
+        <p:cNvPr id="1" name=""/>
+        <p:cNvGrpSpPr/>
+        <p:nvPr/>
+      </p:nvGrpSpPr>
+      <p:grpSpPr>
+        <a:xfrm>
+          <a:off x="0" y="0"/>
+          <a:ext cx="0" cy="0"/>
+          <a:chOff x="0" y="0"/>
+          <a:chExt cx="0" cy="0"/>
+        </a:xfrm>
+      </p:grpSpPr>
+      <p:sp>
+        <p:nvSpPr>
+          <p:cNvPr id="2" name="Titel 1">
+            <a:extLst>
+              <a:ext uri="{FF2B5EF4-FFF2-40B4-BE49-F238E27FC236}">
+                <a16:creationId xmlns:a16="http://schemas.microsoft.com/office/drawing/2014/main" id="{AE82C04D-C07E-4106-B772-CE20CFE0DA43}"/>
+              </a:ext>
+            </a:extLst>
+          </p:cNvPr>
+          <p:cNvSpPr>
+            <a:spLocks noGrp="1"/>
+          </p:cNvSpPr>
+          <p:nvPr>
+            <p:ph type="title"/>
+          </p:nvPr>
+        </p:nvSpPr>
+        <p:spPr>
+          <a:xfrm>
+            <a:off x="653902" y="2328333"/>
+            <a:ext cx="11153553" cy="1658198"/>
+          </a:xfrm>
+        </p:spPr>
+        <p:txBody>
+          <a:bodyPr/>
+          <a:lstStyle/>
+          <a:p>
+            <a:r>
+              <a:rPr lang="de-DE" b="1" dirty="0">
+                <a:solidFill>
+                  <a:schemeClr val="bg1"/>
+                </a:solidFill>
+              </a:rPr>
+              <a:t>Live Coding: Funktionen</a:t>
+            </a:r>
+          </a:p>
+        </p:txBody>
+      </p:sp>
+    </p:spTree>
+    <p:extLst>
+      <p:ext uri="{BB962C8B-B14F-4D97-AF65-F5344CB8AC3E}">
+        <p14:creationId xmlns:p14="http://schemas.microsoft.com/office/powerpoint/2010/main" val="1447280535"/>
+      </p:ext>
+    </p:extLst>
+  </p:cSld>
+  <p:clrMapOvr>
+    <a:masterClrMapping/>
+  </p:clrMapOvr>
+</p:sld>
+</file>
+
+<file path=ppt/slides/slide21.xml><?xml version="1.0" encoding="utf-8"?>
 <p:sld xmlns:a="http://schemas.openxmlformats.org/drawingml/2006/main" xmlns:r="http://schemas.openxmlformats.org/officeDocument/2006/relationships" xmlns:p="http://schemas.openxmlformats.org/presentationml/2006/main">
   <p:cSld>
     <p:spTree>
@@ -9167,7 +9749,7 @@
 </p:sld>
 </file>
 
-<file path=ppt/slides/slide21.xml><?xml version="1.0" encoding="utf-8"?>
+<file path=ppt/slides/slide22.xml><?xml version="1.0" encoding="utf-8"?>
 <p:sld xmlns:a="http://schemas.openxmlformats.org/drawingml/2006/main" xmlns:r="http://schemas.openxmlformats.org/officeDocument/2006/relationships" xmlns:p="http://schemas.openxmlformats.org/presentationml/2006/main">
   <p:cSld>
     <p:spTree>
@@ -9302,7 +9884,7 @@
 </p:sld>
 </file>
 
-<file path=ppt/slides/slide22.xml><?xml version="1.0" encoding="utf-8"?>
+<file path=ppt/slides/slide23.xml><?xml version="1.0" encoding="utf-8"?>
 <p:sld xmlns:a="http://schemas.openxmlformats.org/drawingml/2006/main" xmlns:r="http://schemas.openxmlformats.org/officeDocument/2006/relationships" xmlns:p="http://schemas.openxmlformats.org/presentationml/2006/main">
   <p:cSld>
     <p:spTree>
@@ -10151,7 +10733,7 @@
 </p:sld>
 </file>
 
-<file path=ppt/slides/slide23.xml><?xml version="1.0" encoding="utf-8"?>
+<file path=ppt/slides/slide24.xml><?xml version="1.0" encoding="utf-8"?>
 <p:sld xmlns:a="http://schemas.openxmlformats.org/drawingml/2006/main" xmlns:r="http://schemas.openxmlformats.org/officeDocument/2006/relationships" xmlns:p="http://schemas.openxmlformats.org/presentationml/2006/main">
   <p:cSld>
     <p:bg>
@@ -10226,7 +10808,7 @@
 </p:sld>
 </file>
 
-<file path=ppt/slides/slide24.xml><?xml version="1.0" encoding="utf-8"?>
+<file path=ppt/slides/slide25.xml><?xml version="1.0" encoding="utf-8"?>
 <p:sld xmlns:a="http://schemas.openxmlformats.org/drawingml/2006/main" xmlns:r="http://schemas.openxmlformats.org/officeDocument/2006/relationships" xmlns:p="http://schemas.openxmlformats.org/presentationml/2006/main">
   <p:cSld>
     <p:spTree>
@@ -10409,7 +10991,7 @@
 </p:sld>
 </file>
 
-<file path=ppt/slides/slide25.xml><?xml version="1.0" encoding="utf-8"?>
+<file path=ppt/slides/slide26.xml><?xml version="1.0" encoding="utf-8"?>
 <p:sld xmlns:a="http://schemas.openxmlformats.org/drawingml/2006/main" xmlns:r="http://schemas.openxmlformats.org/officeDocument/2006/relationships" xmlns:p="http://schemas.openxmlformats.org/presentationml/2006/main">
   <p:cSld>
     <p:spTree>
@@ -10827,7 +11409,7 @@
 </p:sld>
 </file>
 
-<file path=ppt/slides/slide26.xml><?xml version="1.0" encoding="utf-8"?>
+<file path=ppt/slides/slide27.xml><?xml version="1.0" encoding="utf-8"?>
 <p:sld xmlns:a="http://schemas.openxmlformats.org/drawingml/2006/main" xmlns:r="http://schemas.openxmlformats.org/officeDocument/2006/relationships" xmlns:p="http://schemas.openxmlformats.org/presentationml/2006/main">
   <p:cSld>
     <p:spTree>
@@ -11676,7 +12258,7 @@
 </p:sld>
 </file>
 
-<file path=ppt/slides/slide27.xml><?xml version="1.0" encoding="utf-8"?>
+<file path=ppt/slides/slide28.xml><?xml version="1.0" encoding="utf-8"?>
 <p:sld xmlns:a="http://schemas.openxmlformats.org/drawingml/2006/main" xmlns:r="http://schemas.openxmlformats.org/officeDocument/2006/relationships" xmlns:p="http://schemas.openxmlformats.org/presentationml/2006/main">
   <p:cSld>
     <p:bg>
@@ -11751,7 +12333,7 @@
 </p:sld>
 </file>
 
-<file path=ppt/slides/slide28.xml><?xml version="1.0" encoding="utf-8"?>
+<file path=ppt/slides/slide29.xml><?xml version="1.0" encoding="utf-8"?>
 <p:sld xmlns:a="http://schemas.openxmlformats.org/drawingml/2006/main" xmlns:r="http://schemas.openxmlformats.org/officeDocument/2006/relationships" xmlns:p="http://schemas.openxmlformats.org/presentationml/2006/main">
   <p:cSld>
     <p:spTree>
@@ -12304,228 +12886,6 @@
       </p:par>
     </p:tnLst>
   </p:timing>
-</p:sld>
-</file>
-
-<file path=ppt/slides/slide29.xml><?xml version="1.0" encoding="utf-8"?>
-<p:sld xmlns:a="http://schemas.openxmlformats.org/drawingml/2006/main" xmlns:r="http://schemas.openxmlformats.org/officeDocument/2006/relationships" xmlns:p="http://schemas.openxmlformats.org/presentationml/2006/main">
-  <p:cSld>
-    <p:spTree>
-      <p:nvGrpSpPr>
-        <p:cNvPr id="1" name=""/>
-        <p:cNvGrpSpPr/>
-        <p:nvPr/>
-      </p:nvGrpSpPr>
-      <p:grpSpPr>
-        <a:xfrm>
-          <a:off x="0" y="0"/>
-          <a:ext cx="0" cy="0"/>
-          <a:chOff x="0" y="0"/>
-          <a:chExt cx="0" cy="0"/>
-        </a:xfrm>
-      </p:grpSpPr>
-      <p:sp>
-        <p:nvSpPr>
-          <p:cNvPr id="2" name="Titel 1">
-            <a:extLst>
-              <a:ext uri="{FF2B5EF4-FFF2-40B4-BE49-F238E27FC236}">
-                <a16:creationId xmlns:a16="http://schemas.microsoft.com/office/drawing/2014/main" id="{9E752B50-311C-4FC9-9B3E-E7F32C2E1150}"/>
-              </a:ext>
-            </a:extLst>
-          </p:cNvPr>
-          <p:cNvSpPr>
-            <a:spLocks noGrp="1"/>
-          </p:cNvSpPr>
-          <p:nvPr>
-            <p:ph type="title"/>
-          </p:nvPr>
-        </p:nvSpPr>
-        <p:spPr>
-          <a:xfrm>
-            <a:off x="676656" y="175339"/>
-            <a:ext cx="10772775" cy="861434"/>
-          </a:xfrm>
-        </p:spPr>
-        <p:txBody>
-          <a:bodyPr/>
-          <a:lstStyle/>
-          <a:p>
-            <a:r>
-              <a:rPr lang="de-DE" b="1" dirty="0"/>
-              <a:t>Übung: Dataframes</a:t>
-            </a:r>
-          </a:p>
-        </p:txBody>
-      </p:sp>
-      <p:sp>
-        <p:nvSpPr>
-          <p:cNvPr id="3" name="Inhaltsplatzhalter 2">
-            <a:extLst>
-              <a:ext uri="{FF2B5EF4-FFF2-40B4-BE49-F238E27FC236}">
-                <a16:creationId xmlns:a16="http://schemas.microsoft.com/office/drawing/2014/main" id="{9D8D5F8B-2B79-4023-9636-42E270F563E0}"/>
-              </a:ext>
-            </a:extLst>
-          </p:cNvPr>
-          <p:cNvSpPr>
-            <a:spLocks noGrp="1"/>
-          </p:cNvSpPr>
-          <p:nvPr>
-            <p:ph idx="1"/>
-          </p:nvPr>
-        </p:nvSpPr>
-        <p:spPr>
-          <a:xfrm>
-            <a:off x="676656" y="1036773"/>
-            <a:ext cx="10902200" cy="5480985"/>
-          </a:xfrm>
-        </p:spPr>
-        <p:txBody>
-          <a:bodyPr>
-            <a:normAutofit lnSpcReduction="10000"/>
-          </a:bodyPr>
-          <a:lstStyle/>
-          <a:p>
-            <a:pPr marL="457200" indent="-457200">
-              <a:buFont typeface="+mj-lt"/>
-              <a:buAutoNum type="arabicPeriod"/>
-            </a:pPr>
-            <a:r>
-              <a:rPr lang="de-DE" sz="2800" dirty="0"/>
-              <a:t>Lesen sie den Datensatz pirates.csv in R mittels Funktion read.csv() ein oder über ‚</a:t>
-            </a:r>
-            <a:r>
-              <a:rPr lang="de-DE" sz="2800" dirty="0" err="1"/>
-              <a:t>import</a:t>
-            </a:r>
-            <a:r>
-              <a:rPr lang="de-DE" sz="2800" dirty="0"/>
-              <a:t> Dataset‘ in der Environment</a:t>
-            </a:r>
-          </a:p>
-          <a:p>
-            <a:pPr marL="457200" indent="-457200">
-              <a:buFont typeface="+mj-lt"/>
-              <a:buAutoNum type="arabicPeriod"/>
-            </a:pPr>
-            <a:r>
-              <a:rPr lang="de-DE" sz="2800" dirty="0"/>
-              <a:t>Berechnen Sie die mittlere Anzahl an Tattoos pro </a:t>
-            </a:r>
-            <a:r>
-              <a:rPr lang="de-DE" sz="2800" dirty="0" err="1"/>
-              <a:t>Pirat:in</a:t>
-            </a:r>
-            <a:endParaRPr lang="de-DE" sz="2800" dirty="0"/>
-          </a:p>
-          <a:p>
-            <a:pPr marL="457200" indent="-457200">
-              <a:buFont typeface="+mj-lt"/>
-              <a:buAutoNum type="arabicPeriod"/>
-            </a:pPr>
-            <a:r>
-              <a:rPr lang="de-DE" sz="2800" dirty="0"/>
-              <a:t>Wie viele Papageien gibt es insgesamt im Datensatz?</a:t>
-            </a:r>
-          </a:p>
-          <a:p>
-            <a:pPr marL="457200" indent="-457200">
-              <a:buFont typeface="+mj-lt"/>
-              <a:buAutoNum type="arabicPeriod"/>
-            </a:pPr>
-            <a:r>
-              <a:rPr lang="de-DE" sz="2800" dirty="0"/>
-              <a:t>Wie viele </a:t>
-            </a:r>
-            <a:r>
-              <a:rPr lang="de-DE" sz="2800" dirty="0" err="1"/>
-              <a:t>Pirat:innen</a:t>
-            </a:r>
-            <a:r>
-              <a:rPr lang="de-DE" sz="2800" dirty="0"/>
-              <a:t> tragen eine Augenklappe?</a:t>
-            </a:r>
-          </a:p>
-          <a:p>
-            <a:pPr marL="457200" indent="-457200">
-              <a:buFont typeface="+mj-lt"/>
-              <a:buAutoNum type="arabicPeriod"/>
-            </a:pPr>
-            <a:r>
-              <a:rPr lang="de-DE" sz="2800" dirty="0"/>
-              <a:t>Welche Lieblingspiraten gibt es? Finden Sie hierfür eine geeignete Funktion die eindeutige Werte in einem Vektor auflistet</a:t>
-            </a:r>
-          </a:p>
-          <a:p>
-            <a:pPr marL="457200" indent="-457200">
-              <a:buFont typeface="+mj-lt"/>
-              <a:buAutoNum type="arabicPeriod"/>
-            </a:pPr>
-            <a:r>
-              <a:rPr lang="de-DE" sz="2800" dirty="0"/>
-              <a:t>Legen Sie eine neue Spalte mit Namen </a:t>
-            </a:r>
-            <a:r>
-              <a:rPr lang="de-DE" sz="2800" b="1" dirty="0"/>
-              <a:t>BMI</a:t>
-            </a:r>
-            <a:r>
-              <a:rPr lang="de-DE" sz="2800" dirty="0"/>
-              <a:t> an (Body </a:t>
-            </a:r>
-            <a:r>
-              <a:rPr lang="de-DE" sz="2800" dirty="0" err="1"/>
-              <a:t>Mass</a:t>
-            </a:r>
-            <a:r>
-              <a:rPr lang="de-DE" sz="2800" dirty="0"/>
-              <a:t> Index) und speichern Sie in diese Spalte das jeweilige Ergebnis von Gewicht geteilt durch Höhe</a:t>
-            </a:r>
-          </a:p>
-          <a:p>
-            <a:pPr marL="457200" indent="-457200">
-              <a:buFont typeface="+mj-lt"/>
-              <a:buAutoNum type="arabicPeriod"/>
-            </a:pPr>
-            <a:r>
-              <a:rPr lang="de-DE" sz="2800" dirty="0"/>
-              <a:t>Welche </a:t>
-            </a:r>
-            <a:r>
-              <a:rPr lang="de-DE" sz="2800" dirty="0" err="1"/>
-              <a:t>Pirat:in</a:t>
-            </a:r>
-            <a:r>
-              <a:rPr lang="de-DE" sz="2800" dirty="0"/>
-              <a:t> hat den größten BMI? Welche den Kleinsten?</a:t>
-            </a:r>
-          </a:p>
-          <a:p>
-            <a:pPr marL="457200" indent="-457200">
-              <a:buFont typeface="+mj-lt"/>
-              <a:buAutoNum type="arabicPeriod"/>
-            </a:pPr>
-            <a:r>
-              <a:rPr lang="de-DE" sz="2800" dirty="0"/>
-              <a:t>Gibt es signifikante Unterschiede der mittleren BMI zwischen weiblichen und männlichen </a:t>
-            </a:r>
-            <a:r>
-              <a:rPr lang="de-DE" sz="2800" dirty="0" err="1"/>
-              <a:t>Pirat:innen</a:t>
-            </a:r>
-            <a:endParaRPr lang="de-DE" sz="2800" dirty="0"/>
-          </a:p>
-        </p:txBody>
-      </p:sp>
-    </p:spTree>
-    <p:extLst>
-      <p:ext uri="{BB962C8B-B14F-4D97-AF65-F5344CB8AC3E}">
-        <p14:creationId xmlns:p14="http://schemas.microsoft.com/office/powerpoint/2010/main" val="444158418"/>
-      </p:ext>
-    </p:extLst>
-  </p:cSld>
-  <p:clrMapOvr>
-    <a:masterClrMapping/>
-  </p:clrMapOvr>
 </p:sld>
 </file>
 
@@ -13282,6 +13642,228 @@
 <file path=ppt/slides/slide30.xml><?xml version="1.0" encoding="utf-8"?>
 <p:sld xmlns:a="http://schemas.openxmlformats.org/drawingml/2006/main" xmlns:r="http://schemas.openxmlformats.org/officeDocument/2006/relationships" xmlns:p="http://schemas.openxmlformats.org/presentationml/2006/main">
   <p:cSld>
+    <p:spTree>
+      <p:nvGrpSpPr>
+        <p:cNvPr id="1" name=""/>
+        <p:cNvGrpSpPr/>
+        <p:nvPr/>
+      </p:nvGrpSpPr>
+      <p:grpSpPr>
+        <a:xfrm>
+          <a:off x="0" y="0"/>
+          <a:ext cx="0" cy="0"/>
+          <a:chOff x="0" y="0"/>
+          <a:chExt cx="0" cy="0"/>
+        </a:xfrm>
+      </p:grpSpPr>
+      <p:sp>
+        <p:nvSpPr>
+          <p:cNvPr id="2" name="Titel 1">
+            <a:extLst>
+              <a:ext uri="{FF2B5EF4-FFF2-40B4-BE49-F238E27FC236}">
+                <a16:creationId xmlns:a16="http://schemas.microsoft.com/office/drawing/2014/main" id="{9E752B50-311C-4FC9-9B3E-E7F32C2E1150}"/>
+              </a:ext>
+            </a:extLst>
+          </p:cNvPr>
+          <p:cNvSpPr>
+            <a:spLocks noGrp="1"/>
+          </p:cNvSpPr>
+          <p:nvPr>
+            <p:ph type="title"/>
+          </p:nvPr>
+        </p:nvSpPr>
+        <p:spPr>
+          <a:xfrm>
+            <a:off x="676656" y="175339"/>
+            <a:ext cx="10772775" cy="861434"/>
+          </a:xfrm>
+        </p:spPr>
+        <p:txBody>
+          <a:bodyPr/>
+          <a:lstStyle/>
+          <a:p>
+            <a:r>
+              <a:rPr lang="de-DE" b="1" dirty="0"/>
+              <a:t>Übung: Dataframes</a:t>
+            </a:r>
+          </a:p>
+        </p:txBody>
+      </p:sp>
+      <p:sp>
+        <p:nvSpPr>
+          <p:cNvPr id="3" name="Inhaltsplatzhalter 2">
+            <a:extLst>
+              <a:ext uri="{FF2B5EF4-FFF2-40B4-BE49-F238E27FC236}">
+                <a16:creationId xmlns:a16="http://schemas.microsoft.com/office/drawing/2014/main" id="{9D8D5F8B-2B79-4023-9636-42E270F563E0}"/>
+              </a:ext>
+            </a:extLst>
+          </p:cNvPr>
+          <p:cNvSpPr>
+            <a:spLocks noGrp="1"/>
+          </p:cNvSpPr>
+          <p:nvPr>
+            <p:ph idx="1"/>
+          </p:nvPr>
+        </p:nvSpPr>
+        <p:spPr>
+          <a:xfrm>
+            <a:off x="676656" y="1036773"/>
+            <a:ext cx="10902200" cy="5480985"/>
+          </a:xfrm>
+        </p:spPr>
+        <p:txBody>
+          <a:bodyPr>
+            <a:normAutofit lnSpcReduction="10000"/>
+          </a:bodyPr>
+          <a:lstStyle/>
+          <a:p>
+            <a:pPr marL="457200" indent="-457200">
+              <a:buFont typeface="+mj-lt"/>
+              <a:buAutoNum type="arabicPeriod"/>
+            </a:pPr>
+            <a:r>
+              <a:rPr lang="de-DE" sz="2800" dirty="0"/>
+              <a:t>Lesen sie den Datensatz pirates.csv in R mittels Funktion read.csv() ein oder über ‚</a:t>
+            </a:r>
+            <a:r>
+              <a:rPr lang="de-DE" sz="2800" dirty="0" err="1"/>
+              <a:t>import</a:t>
+            </a:r>
+            <a:r>
+              <a:rPr lang="de-DE" sz="2800" dirty="0"/>
+              <a:t> Dataset‘ in der Environment</a:t>
+            </a:r>
+          </a:p>
+          <a:p>
+            <a:pPr marL="457200" indent="-457200">
+              <a:buFont typeface="+mj-lt"/>
+              <a:buAutoNum type="arabicPeriod"/>
+            </a:pPr>
+            <a:r>
+              <a:rPr lang="de-DE" sz="2800" dirty="0"/>
+              <a:t>Berechnen Sie die mittlere Anzahl an Tattoos pro </a:t>
+            </a:r>
+            <a:r>
+              <a:rPr lang="de-DE" sz="2800" dirty="0" err="1"/>
+              <a:t>Pirat:in</a:t>
+            </a:r>
+            <a:endParaRPr lang="de-DE" sz="2800" dirty="0"/>
+          </a:p>
+          <a:p>
+            <a:pPr marL="457200" indent="-457200">
+              <a:buFont typeface="+mj-lt"/>
+              <a:buAutoNum type="arabicPeriod"/>
+            </a:pPr>
+            <a:r>
+              <a:rPr lang="de-DE" sz="2800" dirty="0"/>
+              <a:t>Wie viele Papageien gibt es insgesamt im Datensatz?</a:t>
+            </a:r>
+          </a:p>
+          <a:p>
+            <a:pPr marL="457200" indent="-457200">
+              <a:buFont typeface="+mj-lt"/>
+              <a:buAutoNum type="arabicPeriod"/>
+            </a:pPr>
+            <a:r>
+              <a:rPr lang="de-DE" sz="2800" dirty="0"/>
+              <a:t>Wie viele </a:t>
+            </a:r>
+            <a:r>
+              <a:rPr lang="de-DE" sz="2800" dirty="0" err="1"/>
+              <a:t>Pirat:innen</a:t>
+            </a:r>
+            <a:r>
+              <a:rPr lang="de-DE" sz="2800" dirty="0"/>
+              <a:t> tragen eine Augenklappe?</a:t>
+            </a:r>
+          </a:p>
+          <a:p>
+            <a:pPr marL="457200" indent="-457200">
+              <a:buFont typeface="+mj-lt"/>
+              <a:buAutoNum type="arabicPeriod"/>
+            </a:pPr>
+            <a:r>
+              <a:rPr lang="de-DE" sz="2800" dirty="0"/>
+              <a:t>Welche Lieblingspiraten gibt es? Finden Sie hierfür eine geeignete Funktion die eindeutige Werte in einem Vektor auflistet</a:t>
+            </a:r>
+          </a:p>
+          <a:p>
+            <a:pPr marL="457200" indent="-457200">
+              <a:buFont typeface="+mj-lt"/>
+              <a:buAutoNum type="arabicPeriod"/>
+            </a:pPr>
+            <a:r>
+              <a:rPr lang="de-DE" sz="2800" dirty="0"/>
+              <a:t>Legen Sie eine neue Spalte mit Namen </a:t>
+            </a:r>
+            <a:r>
+              <a:rPr lang="de-DE" sz="2800" b="1" dirty="0"/>
+              <a:t>BMI</a:t>
+            </a:r>
+            <a:r>
+              <a:rPr lang="de-DE" sz="2800" dirty="0"/>
+              <a:t> an (Body </a:t>
+            </a:r>
+            <a:r>
+              <a:rPr lang="de-DE" sz="2800" dirty="0" err="1"/>
+              <a:t>Mass</a:t>
+            </a:r>
+            <a:r>
+              <a:rPr lang="de-DE" sz="2800" dirty="0"/>
+              <a:t> Index) und speichern Sie in diese Spalte das jeweilige Ergebnis von Gewicht geteilt durch Höhe</a:t>
+            </a:r>
+          </a:p>
+          <a:p>
+            <a:pPr marL="457200" indent="-457200">
+              <a:buFont typeface="+mj-lt"/>
+              <a:buAutoNum type="arabicPeriod"/>
+            </a:pPr>
+            <a:r>
+              <a:rPr lang="de-DE" sz="2800" dirty="0"/>
+              <a:t>Welche </a:t>
+            </a:r>
+            <a:r>
+              <a:rPr lang="de-DE" sz="2800" dirty="0" err="1"/>
+              <a:t>Pirat:in</a:t>
+            </a:r>
+            <a:r>
+              <a:rPr lang="de-DE" sz="2800" dirty="0"/>
+              <a:t> hat den größten BMI? Welche den Kleinsten?</a:t>
+            </a:r>
+          </a:p>
+          <a:p>
+            <a:pPr marL="457200" indent="-457200">
+              <a:buFont typeface="+mj-lt"/>
+              <a:buAutoNum type="arabicPeriod"/>
+            </a:pPr>
+            <a:r>
+              <a:rPr lang="de-DE" sz="2800" dirty="0"/>
+              <a:t>Gibt es signifikante Unterschiede der mittleren BMI zwischen weiblichen und männlichen </a:t>
+            </a:r>
+            <a:r>
+              <a:rPr lang="de-DE" sz="2800" dirty="0" err="1"/>
+              <a:t>Pirat:innen</a:t>
+            </a:r>
+            <a:endParaRPr lang="de-DE" sz="2800" dirty="0"/>
+          </a:p>
+        </p:txBody>
+      </p:sp>
+    </p:spTree>
+    <p:extLst>
+      <p:ext uri="{BB962C8B-B14F-4D97-AF65-F5344CB8AC3E}">
+        <p14:creationId xmlns:p14="http://schemas.microsoft.com/office/powerpoint/2010/main" val="444158418"/>
+      </p:ext>
+    </p:extLst>
+  </p:cSld>
+  <p:clrMapOvr>
+    <a:masterClrMapping/>
+  </p:clrMapOvr>
+</p:sld>
+</file>
+
+<file path=ppt/slides/slide31.xml><?xml version="1.0" encoding="utf-8"?>
+<p:sld xmlns:a="http://schemas.openxmlformats.org/drawingml/2006/main" xmlns:r="http://schemas.openxmlformats.org/officeDocument/2006/relationships" xmlns:p="http://schemas.openxmlformats.org/presentationml/2006/main">
+  <p:cSld>
     <p:bg>
       <p:bgPr>
         <a:solidFill>
@@ -13345,213 +13927,6 @@
     <p:extLst>
       <p:ext uri="{BB962C8B-B14F-4D97-AF65-F5344CB8AC3E}">
         <p14:creationId xmlns:p14="http://schemas.microsoft.com/office/powerpoint/2010/main" val="2393596856"/>
-      </p:ext>
-    </p:extLst>
-  </p:cSld>
-  <p:clrMapOvr>
-    <a:masterClrMapping/>
-  </p:clrMapOvr>
-</p:sld>
-</file>
-
-<file path=ppt/slides/slide31.xml><?xml version="1.0" encoding="utf-8"?>
-<p:sld xmlns:a="http://schemas.openxmlformats.org/drawingml/2006/main" xmlns:r="http://schemas.openxmlformats.org/officeDocument/2006/relationships" xmlns:p="http://schemas.openxmlformats.org/presentationml/2006/main">
-  <p:cSld>
-    <p:spTree>
-      <p:nvGrpSpPr>
-        <p:cNvPr id="1" name=""/>
-        <p:cNvGrpSpPr/>
-        <p:nvPr/>
-      </p:nvGrpSpPr>
-      <p:grpSpPr>
-        <a:xfrm>
-          <a:off x="0" y="0"/>
-          <a:ext cx="0" cy="0"/>
-          <a:chOff x="0" y="0"/>
-          <a:chExt cx="0" cy="0"/>
-        </a:xfrm>
-      </p:grpSpPr>
-      <p:sp>
-        <p:nvSpPr>
-          <p:cNvPr id="2" name="Titel 1">
-            <a:extLst>
-              <a:ext uri="{FF2B5EF4-FFF2-40B4-BE49-F238E27FC236}">
-                <a16:creationId xmlns:a16="http://schemas.microsoft.com/office/drawing/2014/main" id="{08E930B5-825A-4182-B473-4F834C777D77}"/>
-              </a:ext>
-            </a:extLst>
-          </p:cNvPr>
-          <p:cNvSpPr>
-            <a:spLocks noGrp="1"/>
-          </p:cNvSpPr>
-          <p:nvPr>
-            <p:ph type="title"/>
-          </p:nvPr>
-        </p:nvSpPr>
-        <p:spPr>
-          <a:xfrm>
-            <a:off x="657606" y="564795"/>
-            <a:ext cx="10772775" cy="1030680"/>
-          </a:xfrm>
-        </p:spPr>
-        <p:txBody>
-          <a:bodyPr/>
-          <a:lstStyle/>
-          <a:p>
-            <a:r>
-              <a:rPr lang="de-DE" b="1" dirty="0"/>
-              <a:t>Übung Histogramm</a:t>
-            </a:r>
-          </a:p>
-        </p:txBody>
-      </p:sp>
-      <p:sp>
-        <p:nvSpPr>
-          <p:cNvPr id="3" name="Inhaltsplatzhalter 2">
-            <a:extLst>
-              <a:ext uri="{FF2B5EF4-FFF2-40B4-BE49-F238E27FC236}">
-                <a16:creationId xmlns:a16="http://schemas.microsoft.com/office/drawing/2014/main" id="{AEB01630-4D3C-4E88-AC29-25204C1F7989}"/>
-              </a:ext>
-            </a:extLst>
-          </p:cNvPr>
-          <p:cNvSpPr>
-            <a:spLocks noGrp="1"/>
-          </p:cNvSpPr>
-          <p:nvPr>
-            <p:ph idx="1"/>
-          </p:nvPr>
-        </p:nvSpPr>
-        <p:spPr>
-          <a:xfrm>
-            <a:off x="676656" y="1655380"/>
-            <a:ext cx="10753725" cy="4122486"/>
-          </a:xfrm>
-        </p:spPr>
-        <p:txBody>
-          <a:bodyPr/>
-          <a:lstStyle/>
-          <a:p>
-            <a:pPr marL="457200" indent="-457200">
-              <a:lnSpc>
-                <a:spcPct val="100000"/>
-              </a:lnSpc>
-              <a:buFont typeface="+mj-lt"/>
-              <a:buAutoNum type="arabicPeriod"/>
-            </a:pPr>
-            <a:r>
-              <a:rPr lang="de-DE" sz="2800" dirty="0"/>
-              <a:t>Erstellen Sie ein Histogramm, das die Verteilung von BMI darstellt</a:t>
-            </a:r>
-          </a:p>
-          <a:p>
-            <a:pPr marL="457200" indent="-457200">
-              <a:lnSpc>
-                <a:spcPct val="100000"/>
-              </a:lnSpc>
-              <a:buFont typeface="+mj-lt"/>
-              <a:buAutoNum type="arabicPeriod"/>
-            </a:pPr>
-            <a:r>
-              <a:rPr lang="de-DE" sz="2800" dirty="0"/>
-              <a:t>Fügen Sie einen Titel und Achsenbeschriftungen hinzu</a:t>
-            </a:r>
-          </a:p>
-          <a:p>
-            <a:pPr marL="457200" indent="-457200">
-              <a:lnSpc>
-                <a:spcPct val="100000"/>
-              </a:lnSpc>
-              <a:buFont typeface="+mj-lt"/>
-              <a:buAutoNum type="arabicPeriod"/>
-            </a:pPr>
-            <a:r>
-              <a:rPr lang="de-DE" sz="2800" dirty="0"/>
-              <a:t>Zeichnen Sie den Mittelwert von BMI mittels </a:t>
-            </a:r>
-            <a:r>
-              <a:rPr lang="de-DE" sz="2800" dirty="0" err="1"/>
-              <a:t>abline</a:t>
-            </a:r>
-            <a:r>
-              <a:rPr lang="de-DE" sz="2800" dirty="0"/>
-              <a:t>() ins Histogramm</a:t>
-            </a:r>
-          </a:p>
-          <a:p>
-            <a:pPr marL="457200" indent="-457200">
-              <a:lnSpc>
-                <a:spcPct val="100000"/>
-              </a:lnSpc>
-              <a:buFont typeface="+mj-lt"/>
-              <a:buAutoNum type="arabicPeriod"/>
-            </a:pPr>
-            <a:r>
-              <a:rPr lang="de-DE" sz="2800" dirty="0"/>
-              <a:t>Toben Sie sich aus mit den Farben! (</a:t>
-            </a:r>
-            <a:r>
-              <a:rPr lang="de-DE" sz="2800" dirty="0" err="1"/>
-              <a:t>colors</a:t>
-            </a:r>
-            <a:r>
-              <a:rPr lang="de-DE" sz="2800" dirty="0"/>
-              <a:t>() für einen Überblick)</a:t>
-            </a:r>
-          </a:p>
-          <a:p>
-            <a:pPr marL="457200" indent="-457200">
-              <a:lnSpc>
-                <a:spcPct val="100000"/>
-              </a:lnSpc>
-              <a:buFont typeface="+mj-lt"/>
-              <a:buAutoNum type="arabicPeriod"/>
-            </a:pPr>
-            <a:r>
-              <a:rPr lang="de-DE" sz="2800" dirty="0"/>
-              <a:t>Fügen Sie ebenfalls mit </a:t>
-            </a:r>
-            <a:r>
-              <a:rPr lang="de-DE" sz="2800" dirty="0" err="1"/>
-              <a:t>abline</a:t>
-            </a:r>
-            <a:r>
-              <a:rPr lang="de-DE" sz="2800" dirty="0"/>
-              <a:t>() horizontale Linien im Abstand von 50 dem Diagramm in der Farbe „grey90“ hinzu</a:t>
-            </a:r>
-          </a:p>
-          <a:p>
-            <a:pPr marL="457200" indent="-457200">
-              <a:lnSpc>
-                <a:spcPct val="100000"/>
-              </a:lnSpc>
-              <a:buFont typeface="+mj-lt"/>
-              <a:buAutoNum type="arabicPeriod"/>
-            </a:pPr>
-            <a:r>
-              <a:rPr lang="de-DE" sz="2800" dirty="0"/>
-              <a:t>Exportieren Sie das Histogramm als </a:t>
-            </a:r>
-            <a:r>
-              <a:rPr lang="de-DE" sz="2800" dirty="0" err="1"/>
-              <a:t>png</a:t>
-            </a:r>
-            <a:r>
-              <a:rPr lang="de-DE" sz="2800" dirty="0"/>
-              <a:t> Datei</a:t>
-            </a:r>
-          </a:p>
-          <a:p>
-            <a:pPr marL="457200" indent="-457200">
-              <a:buFont typeface="+mj-lt"/>
-              <a:buAutoNum type="arabicPeriod"/>
-            </a:pPr>
-            <a:endParaRPr lang="de-DE" dirty="0"/>
-          </a:p>
-        </p:txBody>
-      </p:sp>
-    </p:spTree>
-    <p:extLst>
-      <p:ext uri="{BB962C8B-B14F-4D97-AF65-F5344CB8AC3E}">
-        <p14:creationId xmlns:p14="http://schemas.microsoft.com/office/powerpoint/2010/main" val="437693465"/>
       </p:ext>
     </p:extLst>
   </p:cSld>
@@ -13583,7 +13958,7 @@
           <p:cNvPr id="2" name="Titel 1">
             <a:extLst>
               <a:ext uri="{FF2B5EF4-FFF2-40B4-BE49-F238E27FC236}">
-                <a16:creationId xmlns:a16="http://schemas.microsoft.com/office/drawing/2014/main" id="{8BDD5EAD-7FF6-4D46-A636-A2300BFF8604}"/>
+                <a16:creationId xmlns:a16="http://schemas.microsoft.com/office/drawing/2014/main" id="{08E930B5-825A-4182-B473-4F834C777D77}"/>
               </a:ext>
             </a:extLst>
           </p:cNvPr>
@@ -13596,8 +13971,8 @@
         </p:nvSpPr>
         <p:spPr>
           <a:xfrm>
-            <a:off x="657224" y="499533"/>
-            <a:ext cx="10772775" cy="962444"/>
+            <a:off x="657606" y="564795"/>
+            <a:ext cx="10772775" cy="1030680"/>
           </a:xfrm>
         </p:spPr>
         <p:txBody>
@@ -13606,7 +13981,7 @@
           <a:p>
             <a:r>
               <a:rPr lang="de-DE" b="1" dirty="0"/>
-              <a:t>Übung Dichtediagramm</a:t>
+              <a:t>Übung Histogramm</a:t>
             </a:r>
           </a:p>
         </p:txBody>
@@ -13616,7 +13991,7 @@
           <p:cNvPr id="3" name="Inhaltsplatzhalter 2">
             <a:extLst>
               <a:ext uri="{FF2B5EF4-FFF2-40B4-BE49-F238E27FC236}">
-                <a16:creationId xmlns:a16="http://schemas.microsoft.com/office/drawing/2014/main" id="{EB53CCCD-2653-4D70-84E4-4FF62208D816}"/>
+                <a16:creationId xmlns:a16="http://schemas.microsoft.com/office/drawing/2014/main" id="{AEB01630-4D3C-4E88-AC29-25204C1F7989}"/>
               </a:ext>
             </a:extLst>
           </p:cNvPr>
@@ -13629,28 +14004,13 @@
         </p:nvSpPr>
         <p:spPr>
           <a:xfrm>
-            <a:off x="658553" y="1371600"/>
-            <a:ext cx="10753725" cy="4779335"/>
+            <a:off x="676656" y="1655380"/>
+            <a:ext cx="10753725" cy="4122486"/>
           </a:xfrm>
         </p:spPr>
         <p:txBody>
-          <a:bodyPr>
-            <a:normAutofit fontScale="92500"/>
-          </a:bodyPr>
+          <a:bodyPr/>
           <a:lstStyle/>
-          <a:p>
-            <a:pPr marL="457200" indent="-457200">
-              <a:lnSpc>
-                <a:spcPct val="150000"/>
-              </a:lnSpc>
-              <a:buFont typeface="+mj-lt"/>
-              <a:buAutoNum type="arabicPeriod"/>
-            </a:pPr>
-            <a:r>
-              <a:rPr lang="de-DE" sz="2800" dirty="0"/>
-              <a:t>Erstellen Sie ein Dichtediagramm mit dem BMI der männlichen Piraten</a:t>
-            </a:r>
-          </a:p>
           <a:p>
             <a:pPr marL="457200" indent="-457200">
               <a:lnSpc>
@@ -13661,15 +14021,7 @@
             </a:pPr>
             <a:r>
               <a:rPr lang="de-DE" sz="2800" dirty="0"/>
-              <a:t>Fügen Sie mit </a:t>
-            </a:r>
-            <a:r>
-              <a:rPr lang="de-DE" sz="2800" dirty="0" err="1"/>
-              <a:t>lines</a:t>
-            </a:r>
-            <a:r>
-              <a:rPr lang="de-DE" sz="2800" dirty="0"/>
-              <a:t>() eine Dichtekurve des BMI der weiblichen Piratinnen hinzu</a:t>
+              <a:t>Erstellen Sie ein Histogramm, das die Verteilung von BMI darstellt</a:t>
             </a:r>
           </a:p>
           <a:p>
@@ -13682,7 +14034,7 @@
             </a:pPr>
             <a:r>
               <a:rPr lang="de-DE" sz="2800" dirty="0"/>
-              <a:t>Passen Sie Farbe, Titel, Achsenbeschriftung und ggf. die Achsenlimitierung an</a:t>
+              <a:t>Fügen Sie einen Titel und Achsenbeschriftungen hinzu</a:t>
             </a:r>
           </a:p>
           <a:p>
@@ -13695,33 +14047,70 @@
             </a:pPr>
             <a:r>
               <a:rPr lang="de-DE" sz="2800" dirty="0"/>
-              <a:t>Zeichnen Sie die jeweiligen BMI Mittelwerte der Piratinnen und Piraten ein</a:t>
+              <a:t>Zeichnen Sie den Mittelwert von BMI mittels </a:t>
+            </a:r>
+            <a:r>
+              <a:rPr lang="de-DE" sz="2800" dirty="0" err="1"/>
+              <a:t>abline</a:t>
+            </a:r>
+            <a:r>
+              <a:rPr lang="de-DE" sz="2800" dirty="0"/>
+              <a:t>() ins Histogramm</a:t>
             </a:r>
           </a:p>
           <a:p>
             <a:pPr marL="457200" indent="-457200">
               <a:lnSpc>
-                <a:spcPct val="150000"/>
+                <a:spcPct val="100000"/>
               </a:lnSpc>
               <a:buFont typeface="+mj-lt"/>
               <a:buAutoNum type="arabicPeriod"/>
             </a:pPr>
             <a:r>
               <a:rPr lang="de-DE" sz="2800" dirty="0"/>
-              <a:t>Fügen Sie eine passende Legende hinzu</a:t>
+              <a:t>Toben Sie sich aus mit den Farben! (</a:t>
+            </a:r>
+            <a:r>
+              <a:rPr lang="de-DE" sz="2800" dirty="0" err="1"/>
+              <a:t>colors</a:t>
+            </a:r>
+            <a:r>
+              <a:rPr lang="de-DE" sz="2800" dirty="0"/>
+              <a:t>() für einen Überblick)</a:t>
             </a:r>
           </a:p>
           <a:p>
             <a:pPr marL="457200" indent="-457200">
               <a:lnSpc>
-                <a:spcPct val="150000"/>
+                <a:spcPct val="100000"/>
               </a:lnSpc>
               <a:buFont typeface="+mj-lt"/>
               <a:buAutoNum type="arabicPeriod"/>
             </a:pPr>
             <a:r>
               <a:rPr lang="de-DE" sz="2800" dirty="0"/>
-              <a:t>Exportieren Sie den Plot als </a:t>
+              <a:t>Fügen Sie ebenfalls mit </a:t>
+            </a:r>
+            <a:r>
+              <a:rPr lang="de-DE" sz="2800" dirty="0" err="1"/>
+              <a:t>abline</a:t>
+            </a:r>
+            <a:r>
+              <a:rPr lang="de-DE" sz="2800" dirty="0"/>
+              <a:t>() horizontale Linien im Abstand von 50 dem Diagramm in der Farbe „grey90“ hinzu</a:t>
+            </a:r>
+          </a:p>
+          <a:p>
+            <a:pPr marL="457200" indent="-457200">
+              <a:lnSpc>
+                <a:spcPct val="100000"/>
+              </a:lnSpc>
+              <a:buFont typeface="+mj-lt"/>
+              <a:buAutoNum type="arabicPeriod"/>
+            </a:pPr>
+            <a:r>
+              <a:rPr lang="de-DE" sz="2800" dirty="0"/>
+              <a:t>Exportieren Sie das Histogramm als </a:t>
             </a:r>
             <a:r>
               <a:rPr lang="de-DE" sz="2800" dirty="0" err="1"/>
@@ -13731,13 +14120,20 @@
               <a:rPr lang="de-DE" sz="2800" dirty="0"/>
               <a:t> Datei</a:t>
             </a:r>
+          </a:p>
+          <a:p>
+            <a:pPr marL="457200" indent="-457200">
+              <a:buFont typeface="+mj-lt"/>
+              <a:buAutoNum type="arabicPeriod"/>
+            </a:pPr>
+            <a:endParaRPr lang="de-DE" dirty="0"/>
           </a:p>
         </p:txBody>
       </p:sp>
     </p:spTree>
     <p:extLst>
       <p:ext uri="{BB962C8B-B14F-4D97-AF65-F5344CB8AC3E}">
-        <p14:creationId xmlns:p14="http://schemas.microsoft.com/office/powerpoint/2010/main" val="629477332"/>
+        <p14:creationId xmlns:p14="http://schemas.microsoft.com/office/powerpoint/2010/main" val="437693465"/>
       </p:ext>
     </p:extLst>
   </p:cSld>
@@ -13769,7 +14165,7 @@
           <p:cNvPr id="2" name="Titel 1">
             <a:extLst>
               <a:ext uri="{FF2B5EF4-FFF2-40B4-BE49-F238E27FC236}">
-                <a16:creationId xmlns:a16="http://schemas.microsoft.com/office/drawing/2014/main" id="{496F125F-4F09-4130-9999-82212092E56A}"/>
+                <a16:creationId xmlns:a16="http://schemas.microsoft.com/office/drawing/2014/main" id="{8BDD5EAD-7FF6-4D46-A636-A2300BFF8604}"/>
               </a:ext>
             </a:extLst>
           </p:cNvPr>
@@ -13783,7 +14179,7 @@
         <p:spPr>
           <a:xfrm>
             <a:off x="657224" y="499533"/>
-            <a:ext cx="10772775" cy="978393"/>
+            <a:ext cx="10772775" cy="962444"/>
           </a:xfrm>
         </p:spPr>
         <p:txBody>
@@ -13792,7 +14188,7 @@
           <a:p>
             <a:r>
               <a:rPr lang="de-DE" b="1" dirty="0"/>
-              <a:t>Übung Boxplot</a:t>
+              <a:t>Übung Dichtediagramm</a:t>
             </a:r>
           </a:p>
         </p:txBody>
@@ -13802,7 +14198,7 @@
           <p:cNvPr id="3" name="Inhaltsplatzhalter 2">
             <a:extLst>
               <a:ext uri="{FF2B5EF4-FFF2-40B4-BE49-F238E27FC236}">
-                <a16:creationId xmlns:a16="http://schemas.microsoft.com/office/drawing/2014/main" id="{6E9C5726-98EE-4E55-ACF4-D2405C5D031F}"/>
+                <a16:creationId xmlns:a16="http://schemas.microsoft.com/office/drawing/2014/main" id="{EB53CCCD-2653-4D70-84E4-4FF62208D816}"/>
               </a:ext>
             </a:extLst>
           </p:cNvPr>
@@ -13815,13 +14211,13 @@
         </p:nvSpPr>
         <p:spPr>
           <a:xfrm>
-            <a:off x="676656" y="1584252"/>
-            <a:ext cx="10753725" cy="4193614"/>
+            <a:off x="658553" y="1371600"/>
+            <a:ext cx="10753725" cy="4779335"/>
           </a:xfrm>
         </p:spPr>
         <p:txBody>
           <a:bodyPr>
-            <a:normAutofit/>
+            <a:normAutofit fontScale="92500"/>
           </a:bodyPr>
           <a:lstStyle/>
           <a:p>
@@ -13834,7 +14230,54 @@
             </a:pPr>
             <a:r>
               <a:rPr lang="de-DE" sz="2800" dirty="0"/>
-              <a:t>Lesen Sie den MM.txt Datensatz ein</a:t>
+              <a:t>Erstellen Sie ein Dichtediagramm mit dem BMI der männlichen Piraten</a:t>
+            </a:r>
+          </a:p>
+          <a:p>
+            <a:pPr marL="457200" indent="-457200">
+              <a:lnSpc>
+                <a:spcPct val="100000"/>
+              </a:lnSpc>
+              <a:buFont typeface="+mj-lt"/>
+              <a:buAutoNum type="arabicPeriod"/>
+            </a:pPr>
+            <a:r>
+              <a:rPr lang="de-DE" sz="2800" dirty="0"/>
+              <a:t>Fügen Sie mit </a:t>
+            </a:r>
+            <a:r>
+              <a:rPr lang="de-DE" sz="2800" dirty="0" err="1"/>
+              <a:t>lines</a:t>
+            </a:r>
+            <a:r>
+              <a:rPr lang="de-DE" sz="2800" dirty="0"/>
+              <a:t>() eine Dichtekurve des BMI der weiblichen Piratinnen hinzu</a:t>
+            </a:r>
+          </a:p>
+          <a:p>
+            <a:pPr marL="457200" indent="-457200">
+              <a:lnSpc>
+                <a:spcPct val="100000"/>
+              </a:lnSpc>
+              <a:buFont typeface="+mj-lt"/>
+              <a:buAutoNum type="arabicPeriod"/>
+            </a:pPr>
+            <a:r>
+              <a:rPr lang="de-DE" sz="2800" dirty="0"/>
+              <a:t>Passen Sie Farbe, Titel, Achsenbeschriftung und ggf. die Achsenlimitierung an</a:t>
+            </a:r>
+          </a:p>
+          <a:p>
+            <a:pPr marL="457200" indent="-457200">
+              <a:lnSpc>
+                <a:spcPct val="100000"/>
+              </a:lnSpc>
+              <a:buFont typeface="+mj-lt"/>
+              <a:buAutoNum type="arabicPeriod"/>
+            </a:pPr>
+            <a:r>
+              <a:rPr lang="de-DE" sz="2800" dirty="0"/>
+              <a:t>Zeichnen Sie die jeweiligen BMI Mittelwerte der Piratinnen und Piraten ein</a:t>
             </a:r>
           </a:p>
           <a:p>
@@ -13847,15 +14290,7 @@
             </a:pPr>
             <a:r>
               <a:rPr lang="de-DE" sz="2800" dirty="0"/>
-              <a:t>Erstellen Sie einen Boxplot der ausschließlich die Verteilung der M&amp;Ms nach Farbe darstellt. Passen Sie eventuell das </a:t>
-            </a:r>
-            <a:r>
-              <a:rPr lang="de-DE" sz="2800" i="1" dirty="0" err="1"/>
-              <a:t>outline</a:t>
-            </a:r>
-            <a:r>
-              <a:rPr lang="de-DE" sz="2800" dirty="0"/>
-              <a:t> Argument an</a:t>
+              <a:t>Fügen Sie eine passende Legende hinzu</a:t>
             </a:r>
           </a:p>
           <a:p>
@@ -13868,20 +14303,15 @@
             </a:pPr>
             <a:r>
               <a:rPr lang="de-DE" sz="2800" dirty="0"/>
-              <a:t>Färben Sie die Boxen entsprechend der M&amp;M Farben an</a:t>
-            </a:r>
-          </a:p>
-          <a:p>
-            <a:pPr marL="457200" indent="-457200">
-              <a:lnSpc>
-                <a:spcPct val="150000"/>
-              </a:lnSpc>
-              <a:buFont typeface="+mj-lt"/>
-              <a:buAutoNum type="arabicPeriod"/>
-            </a:pPr>
+              <a:t>Exportieren Sie den Plot als </a:t>
+            </a:r>
+            <a:r>
+              <a:rPr lang="de-DE" sz="2800" dirty="0" err="1"/>
+              <a:t>png</a:t>
+            </a:r>
             <a:r>
               <a:rPr lang="de-DE" sz="2800" dirty="0"/>
-              <a:t>Exportieren Sie die Grafik</a:t>
+              <a:t> Datei</a:t>
             </a:r>
           </a:p>
         </p:txBody>
@@ -13889,7 +14319,7 @@
     </p:spTree>
     <p:extLst>
       <p:ext uri="{BB962C8B-B14F-4D97-AF65-F5344CB8AC3E}">
-        <p14:creationId xmlns:p14="http://schemas.microsoft.com/office/powerpoint/2010/main" val="4016134650"/>
+        <p14:creationId xmlns:p14="http://schemas.microsoft.com/office/powerpoint/2010/main" val="629477332"/>
       </p:ext>
     </p:extLst>
   </p:cSld>
@@ -13921,7 +14351,7 @@
           <p:cNvPr id="2" name="Titel 1">
             <a:extLst>
               <a:ext uri="{FF2B5EF4-FFF2-40B4-BE49-F238E27FC236}">
-                <a16:creationId xmlns:a16="http://schemas.microsoft.com/office/drawing/2014/main" id="{BAB2BF70-F744-49F7-ABC6-4C7ADFFDAE05}"/>
+                <a16:creationId xmlns:a16="http://schemas.microsoft.com/office/drawing/2014/main" id="{496F125F-4F09-4130-9999-82212092E56A}"/>
               </a:ext>
             </a:extLst>
           </p:cNvPr>
@@ -13935,7 +14365,7 @@
         <p:spPr>
           <a:xfrm>
             <a:off x="657224" y="499533"/>
-            <a:ext cx="10772775" cy="994341"/>
+            <a:ext cx="10772775" cy="978393"/>
           </a:xfrm>
         </p:spPr>
         <p:txBody>
@@ -13944,13 +14374,8 @@
           <a:p>
             <a:r>
               <a:rPr lang="de-DE" b="1" dirty="0"/>
-              <a:t>Übung </a:t>
-            </a:r>
-            <a:r>
-              <a:rPr lang="de-DE" b="1" dirty="0" err="1"/>
-              <a:t>Barplot</a:t>
-            </a:r>
-            <a:endParaRPr lang="de-DE" b="1" dirty="0"/>
+              <a:t>Übung Boxplot</a:t>
+            </a:r>
           </a:p>
         </p:txBody>
       </p:sp>
@@ -13959,7 +14384,7 @@
           <p:cNvPr id="3" name="Inhaltsplatzhalter 2">
             <a:extLst>
               <a:ext uri="{FF2B5EF4-FFF2-40B4-BE49-F238E27FC236}">
-                <a16:creationId xmlns:a16="http://schemas.microsoft.com/office/drawing/2014/main" id="{A75420BA-BAEC-4AB1-87D8-BF813BC3BFA7}"/>
+                <a16:creationId xmlns:a16="http://schemas.microsoft.com/office/drawing/2014/main" id="{6E9C5726-98EE-4E55-ACF4-D2405C5D031F}"/>
               </a:ext>
             </a:extLst>
           </p:cNvPr>
@@ -13972,8 +14397,8 @@
         </p:nvSpPr>
         <p:spPr>
           <a:xfrm>
-            <a:off x="676656" y="1642730"/>
-            <a:ext cx="10753725" cy="4864396"/>
+            <a:off x="676656" y="1584252"/>
+            <a:ext cx="10753725" cy="4193614"/>
           </a:xfrm>
         </p:spPr>
         <p:txBody>
@@ -13990,55 +14415,8 @@
               <a:buAutoNum type="arabicPeriod"/>
             </a:pPr>
             <a:r>
-              <a:rPr lang="de-DE" dirty="0"/>
+              <a:rPr lang="de-DE" sz="2800" dirty="0"/>
               <a:t>Lesen Sie den MM.txt Datensatz ein</a:t>
-            </a:r>
-          </a:p>
-          <a:p>
-            <a:pPr marL="457200" indent="-457200">
-              <a:lnSpc>
-                <a:spcPct val="100000"/>
-              </a:lnSpc>
-              <a:buFont typeface="+mj-lt"/>
-              <a:buAutoNum type="arabicPeriod"/>
-            </a:pPr>
-            <a:r>
-              <a:rPr lang="de-DE" dirty="0"/>
-              <a:t>Erstellen Sie einen </a:t>
-            </a:r>
-            <a:r>
-              <a:rPr lang="de-DE" dirty="0" err="1"/>
-              <a:t>Barplot</a:t>
-            </a:r>
-            <a:r>
-              <a:rPr lang="de-DE" dirty="0"/>
-              <a:t> der die Gesamtzahl M&amp;Ms pro Farbe zeigt. (Tipp: Finden Sie im Vorfeld eine geeignete Funktion, die die Summe pro Spalte berechnet)</a:t>
-            </a:r>
-          </a:p>
-          <a:p>
-            <a:pPr marL="457200" indent="-457200">
-              <a:lnSpc>
-                <a:spcPct val="110000"/>
-              </a:lnSpc>
-              <a:buFont typeface="+mj-lt"/>
-              <a:buAutoNum type="arabicPeriod"/>
-            </a:pPr>
-            <a:r>
-              <a:rPr lang="de-DE" dirty="0"/>
-              <a:t>Passen Sie gegebenenfalls die Ränder des Plot-Fensters und drehen Sie ggf. die Achsenbeschriftung um 90°</a:t>
-            </a:r>
-          </a:p>
-          <a:p>
-            <a:pPr marL="457200" indent="-457200">
-              <a:lnSpc>
-                <a:spcPct val="100000"/>
-              </a:lnSpc>
-              <a:buFont typeface="+mj-lt"/>
-              <a:buAutoNum type="arabicPeriod"/>
-            </a:pPr>
-            <a:r>
-              <a:rPr lang="de-DE" dirty="0"/>
-              <a:t>Färben Sie die Balken entsprechend der M&amp;M Farbe ein und fügen Sie einen Titel hinzu</a:t>
             </a:r>
           </a:p>
           <a:p>
@@ -14050,31 +14428,50 @@
               <a:buAutoNum type="arabicPeriod"/>
             </a:pPr>
             <a:r>
-              <a:rPr lang="de-DE" dirty="0"/>
-              <a:t>Exportieren Sie die Grafik als </a:t>
-            </a:r>
-            <a:r>
-              <a:rPr lang="de-DE" dirty="0" err="1"/>
-              <a:t>png</a:t>
-            </a:r>
-            <a:r>
-              <a:rPr lang="de-DE" dirty="0"/>
-              <a:t> Datei</a:t>
+              <a:rPr lang="de-DE" sz="2800" dirty="0"/>
+              <a:t>Erstellen Sie einen Boxplot der ausschließlich die Verteilung der M&amp;Ms nach Farbe darstellt. Passen Sie eventuell das </a:t>
+            </a:r>
+            <a:r>
+              <a:rPr lang="de-DE" sz="2800" i="1" dirty="0" err="1"/>
+              <a:t>outline</a:t>
+            </a:r>
+            <a:r>
+              <a:rPr lang="de-DE" sz="2800" dirty="0"/>
+              <a:t> Argument an</a:t>
             </a:r>
           </a:p>
           <a:p>
             <a:pPr marL="457200" indent="-457200">
+              <a:lnSpc>
+                <a:spcPct val="150000"/>
+              </a:lnSpc>
               <a:buFont typeface="+mj-lt"/>
               <a:buAutoNum type="arabicPeriod"/>
             </a:pPr>
-            <a:endParaRPr lang="de-DE" dirty="0"/>
+            <a:r>
+              <a:rPr lang="de-DE" sz="2800" dirty="0"/>
+              <a:t>Färben Sie die Boxen entsprechend der M&amp;M Farben an</a:t>
+            </a:r>
+          </a:p>
+          <a:p>
+            <a:pPr marL="457200" indent="-457200">
+              <a:lnSpc>
+                <a:spcPct val="150000"/>
+              </a:lnSpc>
+              <a:buFont typeface="+mj-lt"/>
+              <a:buAutoNum type="arabicPeriod"/>
+            </a:pPr>
+            <a:r>
+              <a:rPr lang="de-DE" sz="2800" dirty="0"/>
+              <a:t>Exportieren Sie die Grafik</a:t>
+            </a:r>
           </a:p>
         </p:txBody>
       </p:sp>
     </p:spTree>
     <p:extLst>
       <p:ext uri="{BB962C8B-B14F-4D97-AF65-F5344CB8AC3E}">
-        <p14:creationId xmlns:p14="http://schemas.microsoft.com/office/powerpoint/2010/main" val="2249418622"/>
+        <p14:creationId xmlns:p14="http://schemas.microsoft.com/office/powerpoint/2010/main" val="4016134650"/>
       </p:ext>
     </p:extLst>
   </p:cSld>
@@ -14106,6 +14503,191 @@
           <p:cNvPr id="2" name="Titel 1">
             <a:extLst>
               <a:ext uri="{FF2B5EF4-FFF2-40B4-BE49-F238E27FC236}">
+                <a16:creationId xmlns:a16="http://schemas.microsoft.com/office/drawing/2014/main" id="{BAB2BF70-F744-49F7-ABC6-4C7ADFFDAE05}"/>
+              </a:ext>
+            </a:extLst>
+          </p:cNvPr>
+          <p:cNvSpPr>
+            <a:spLocks noGrp="1"/>
+          </p:cNvSpPr>
+          <p:nvPr>
+            <p:ph type="title"/>
+          </p:nvPr>
+        </p:nvSpPr>
+        <p:spPr>
+          <a:xfrm>
+            <a:off x="657224" y="499533"/>
+            <a:ext cx="10772775" cy="994341"/>
+          </a:xfrm>
+        </p:spPr>
+        <p:txBody>
+          <a:bodyPr/>
+          <a:lstStyle/>
+          <a:p>
+            <a:r>
+              <a:rPr lang="de-DE" b="1" dirty="0"/>
+              <a:t>Übung </a:t>
+            </a:r>
+            <a:r>
+              <a:rPr lang="de-DE" b="1" dirty="0" err="1"/>
+              <a:t>Barplot</a:t>
+            </a:r>
+            <a:endParaRPr lang="de-DE" b="1" dirty="0"/>
+          </a:p>
+        </p:txBody>
+      </p:sp>
+      <p:sp>
+        <p:nvSpPr>
+          <p:cNvPr id="3" name="Inhaltsplatzhalter 2">
+            <a:extLst>
+              <a:ext uri="{FF2B5EF4-FFF2-40B4-BE49-F238E27FC236}">
+                <a16:creationId xmlns:a16="http://schemas.microsoft.com/office/drawing/2014/main" id="{A75420BA-BAEC-4AB1-87D8-BF813BC3BFA7}"/>
+              </a:ext>
+            </a:extLst>
+          </p:cNvPr>
+          <p:cNvSpPr>
+            <a:spLocks noGrp="1"/>
+          </p:cNvSpPr>
+          <p:nvPr>
+            <p:ph idx="1"/>
+          </p:nvPr>
+        </p:nvSpPr>
+        <p:spPr>
+          <a:xfrm>
+            <a:off x="676656" y="1642730"/>
+            <a:ext cx="10753725" cy="4864396"/>
+          </a:xfrm>
+        </p:spPr>
+        <p:txBody>
+          <a:bodyPr>
+            <a:normAutofit/>
+          </a:bodyPr>
+          <a:lstStyle/>
+          <a:p>
+            <a:pPr marL="457200" indent="-457200">
+              <a:lnSpc>
+                <a:spcPct val="150000"/>
+              </a:lnSpc>
+              <a:buFont typeface="+mj-lt"/>
+              <a:buAutoNum type="arabicPeriod"/>
+            </a:pPr>
+            <a:r>
+              <a:rPr lang="de-DE" dirty="0"/>
+              <a:t>Lesen Sie den MM.txt Datensatz ein</a:t>
+            </a:r>
+          </a:p>
+          <a:p>
+            <a:pPr marL="457200" indent="-457200">
+              <a:lnSpc>
+                <a:spcPct val="100000"/>
+              </a:lnSpc>
+              <a:buFont typeface="+mj-lt"/>
+              <a:buAutoNum type="arabicPeriod"/>
+            </a:pPr>
+            <a:r>
+              <a:rPr lang="de-DE" dirty="0"/>
+              <a:t>Erstellen Sie einen </a:t>
+            </a:r>
+            <a:r>
+              <a:rPr lang="de-DE" dirty="0" err="1"/>
+              <a:t>Barplot</a:t>
+            </a:r>
+            <a:r>
+              <a:rPr lang="de-DE" dirty="0"/>
+              <a:t> der die Gesamtzahl M&amp;Ms pro Farbe zeigt. (Tipp: Finden Sie im Vorfeld eine geeignete Funktion, die die Summe pro Spalte berechnet)</a:t>
+            </a:r>
+          </a:p>
+          <a:p>
+            <a:pPr marL="457200" indent="-457200">
+              <a:lnSpc>
+                <a:spcPct val="110000"/>
+              </a:lnSpc>
+              <a:buFont typeface="+mj-lt"/>
+              <a:buAutoNum type="arabicPeriod"/>
+            </a:pPr>
+            <a:r>
+              <a:rPr lang="de-DE" dirty="0"/>
+              <a:t>Passen Sie gegebenenfalls die Ränder des Plot-Fensters und drehen Sie ggf. die Achsenbeschriftung um 90°</a:t>
+            </a:r>
+          </a:p>
+          <a:p>
+            <a:pPr marL="457200" indent="-457200">
+              <a:lnSpc>
+                <a:spcPct val="100000"/>
+              </a:lnSpc>
+              <a:buFont typeface="+mj-lt"/>
+              <a:buAutoNum type="arabicPeriod"/>
+            </a:pPr>
+            <a:r>
+              <a:rPr lang="de-DE" dirty="0"/>
+              <a:t>Färben Sie die Balken entsprechend der M&amp;M Farbe ein und fügen Sie einen Titel hinzu</a:t>
+            </a:r>
+          </a:p>
+          <a:p>
+            <a:pPr marL="457200" indent="-457200">
+              <a:lnSpc>
+                <a:spcPct val="150000"/>
+              </a:lnSpc>
+              <a:buFont typeface="+mj-lt"/>
+              <a:buAutoNum type="arabicPeriod"/>
+            </a:pPr>
+            <a:r>
+              <a:rPr lang="de-DE" dirty="0"/>
+              <a:t>Exportieren Sie die Grafik als </a:t>
+            </a:r>
+            <a:r>
+              <a:rPr lang="de-DE" dirty="0" err="1"/>
+              <a:t>png</a:t>
+            </a:r>
+            <a:r>
+              <a:rPr lang="de-DE" dirty="0"/>
+              <a:t> Datei</a:t>
+            </a:r>
+          </a:p>
+          <a:p>
+            <a:pPr marL="457200" indent="-457200">
+              <a:buFont typeface="+mj-lt"/>
+              <a:buAutoNum type="arabicPeriod"/>
+            </a:pPr>
+            <a:endParaRPr lang="de-DE" dirty="0"/>
+          </a:p>
+        </p:txBody>
+      </p:sp>
+    </p:spTree>
+    <p:extLst>
+      <p:ext uri="{BB962C8B-B14F-4D97-AF65-F5344CB8AC3E}">
+        <p14:creationId xmlns:p14="http://schemas.microsoft.com/office/powerpoint/2010/main" val="2249418622"/>
+      </p:ext>
+    </p:extLst>
+  </p:cSld>
+  <p:clrMapOvr>
+    <a:masterClrMapping/>
+  </p:clrMapOvr>
+</p:sld>
+</file>
+
+<file path=ppt/slides/slide36.xml><?xml version="1.0" encoding="utf-8"?>
+<p:sld xmlns:a="http://schemas.openxmlformats.org/drawingml/2006/main" xmlns:r="http://schemas.openxmlformats.org/officeDocument/2006/relationships" xmlns:p="http://schemas.openxmlformats.org/presentationml/2006/main">
+  <p:cSld>
+    <p:spTree>
+      <p:nvGrpSpPr>
+        <p:cNvPr id="1" name=""/>
+        <p:cNvGrpSpPr/>
+        <p:nvPr/>
+      </p:nvGrpSpPr>
+      <p:grpSpPr>
+        <a:xfrm>
+          <a:off x="0" y="0"/>
+          <a:ext cx="0" cy="0"/>
+          <a:chOff x="0" y="0"/>
+          <a:chExt cx="0" cy="0"/>
+        </a:xfrm>
+      </p:grpSpPr>
+      <p:sp>
+        <p:nvSpPr>
+          <p:cNvPr id="2" name="Titel 1">
+            <a:extLst>
+              <a:ext uri="{FF2B5EF4-FFF2-40B4-BE49-F238E27FC236}">
                 <a16:creationId xmlns:a16="http://schemas.microsoft.com/office/drawing/2014/main" id="{EBA5FD4C-F113-468D-929C-88B36AADE3F9}"/>
               </a:ext>
             </a:extLst>
@@ -14278,7 +14860,7 @@
 </p:sld>
 </file>
 
-<file path=ppt/slides/slide36.xml><?xml version="1.0" encoding="utf-8"?>
+<file path=ppt/slides/slide37.xml><?xml version="1.0" encoding="utf-8"?>
 <p:sld xmlns:a="http://schemas.openxmlformats.org/drawingml/2006/main" xmlns:r="http://schemas.openxmlformats.org/officeDocument/2006/relationships" xmlns:p="http://schemas.openxmlformats.org/presentationml/2006/main">
   <p:cSld>
     <p:bg>
@@ -14353,7 +14935,7 @@
 </p:sld>
 </file>
 
-<file path=ppt/slides/slide37.xml><?xml version="1.0" encoding="utf-8"?>
+<file path=ppt/slides/slide38.xml><?xml version="1.0" encoding="utf-8"?>
 <p:sld xmlns:a="http://schemas.openxmlformats.org/drawingml/2006/main" xmlns:r="http://schemas.openxmlformats.org/officeDocument/2006/relationships" xmlns:p="http://schemas.openxmlformats.org/presentationml/2006/main" show="0">
   <p:cSld>
     <p:spTree>
@@ -14517,178 +15099,6 @@
     <p:extLst>
       <p:ext uri="{BB962C8B-B14F-4D97-AF65-F5344CB8AC3E}">
         <p14:creationId xmlns:p14="http://schemas.microsoft.com/office/powerpoint/2010/main" val="3530125378"/>
-      </p:ext>
-    </p:extLst>
-  </p:cSld>
-  <p:clrMapOvr>
-    <a:masterClrMapping/>
-  </p:clrMapOvr>
-</p:sld>
-</file>
-
-<file path=ppt/slides/slide38.xml><?xml version="1.0" encoding="utf-8"?>
-<p:sld xmlns:a="http://schemas.openxmlformats.org/drawingml/2006/main" xmlns:r="http://schemas.openxmlformats.org/officeDocument/2006/relationships" xmlns:p="http://schemas.openxmlformats.org/presentationml/2006/main">
-  <p:cSld>
-    <p:spTree>
-      <p:nvGrpSpPr>
-        <p:cNvPr id="1" name=""/>
-        <p:cNvGrpSpPr/>
-        <p:nvPr/>
-      </p:nvGrpSpPr>
-      <p:grpSpPr>
-        <a:xfrm>
-          <a:off x="0" y="0"/>
-          <a:ext cx="0" cy="0"/>
-          <a:chOff x="0" y="0"/>
-          <a:chExt cx="0" cy="0"/>
-        </a:xfrm>
-      </p:grpSpPr>
-      <p:sp>
-        <p:nvSpPr>
-          <p:cNvPr id="2" name="Titel 1">
-            <a:extLst>
-              <a:ext uri="{FF2B5EF4-FFF2-40B4-BE49-F238E27FC236}">
-                <a16:creationId xmlns:a16="http://schemas.microsoft.com/office/drawing/2014/main" id="{C4237B4F-0744-4883-AAB0-293CC3A7ED88}"/>
-              </a:ext>
-            </a:extLst>
-          </p:cNvPr>
-          <p:cNvSpPr>
-            <a:spLocks noGrp="1"/>
-          </p:cNvSpPr>
-          <p:nvPr>
-            <p:ph type="title"/>
-          </p:nvPr>
-        </p:nvSpPr>
-        <p:spPr>
-          <a:xfrm>
-            <a:off x="657224" y="499533"/>
-            <a:ext cx="10772775" cy="861434"/>
-          </a:xfrm>
-        </p:spPr>
-        <p:txBody>
-          <a:bodyPr/>
-          <a:lstStyle/>
-          <a:p>
-            <a:r>
-              <a:rPr lang="de-DE" dirty="0"/>
-              <a:t>Übung Schleife mit </a:t>
-            </a:r>
-            <a:r>
-              <a:rPr lang="de-DE" dirty="0" err="1"/>
-              <a:t>if-else</a:t>
-            </a:r>
-            <a:endParaRPr lang="de-DE" dirty="0"/>
-          </a:p>
-        </p:txBody>
-      </p:sp>
-      <p:sp>
-        <p:nvSpPr>
-          <p:cNvPr id="3" name="Inhaltsplatzhalter 2">
-            <a:extLst>
-              <a:ext uri="{FF2B5EF4-FFF2-40B4-BE49-F238E27FC236}">
-                <a16:creationId xmlns:a16="http://schemas.microsoft.com/office/drawing/2014/main" id="{EBC88ED8-5F13-4AFE-AD62-F1AE70FA6DE0}"/>
-              </a:ext>
-            </a:extLst>
-          </p:cNvPr>
-          <p:cNvSpPr>
-            <a:spLocks noGrp="1"/>
-          </p:cNvSpPr>
-          <p:nvPr>
-            <p:ph idx="1"/>
-          </p:nvPr>
-        </p:nvSpPr>
-        <p:spPr>
-          <a:xfrm>
-            <a:off x="676656" y="1440712"/>
-            <a:ext cx="10997893" cy="5002618"/>
-          </a:xfrm>
-        </p:spPr>
-        <p:txBody>
-          <a:bodyPr>
-            <a:normAutofit fontScale="92500" lnSpcReduction="20000"/>
-          </a:bodyPr>
-          <a:lstStyle/>
-          <a:p>
-            <a:pPr marL="457200" indent="-457200">
-              <a:lnSpc>
-                <a:spcPct val="150000"/>
-              </a:lnSpc>
-              <a:buFont typeface="+mj-lt"/>
-              <a:buAutoNum type="arabicPeriod"/>
-            </a:pPr>
-            <a:r>
-              <a:rPr lang="de-DE" sz="2800" dirty="0"/>
-              <a:t>Berechnen Sie die ersten 100 Stellen einer Folge mit den folgenden Eigenschaften:</a:t>
-            </a:r>
-          </a:p>
-          <a:p>
-            <a:pPr marL="713232" lvl="1" indent="-457200">
-              <a:lnSpc>
-                <a:spcPct val="150000"/>
-              </a:lnSpc>
-              <a:buFont typeface="Arial" panose="020B0604020202020204" pitchFamily="34" charset="0"/>
-              <a:buChar char="•"/>
-            </a:pPr>
-            <a:r>
-              <a:rPr lang="de-DE" sz="2800" dirty="0"/>
-              <a:t>Sie startet mit dem Wert 3</a:t>
-            </a:r>
-          </a:p>
-          <a:p>
-            <a:pPr marL="713232" lvl="1" indent="-457200">
-              <a:lnSpc>
-                <a:spcPct val="120000"/>
-              </a:lnSpc>
-              <a:buFont typeface="Arial" panose="020B0604020202020204" pitchFamily="34" charset="0"/>
-              <a:buChar char="•"/>
-            </a:pPr>
-            <a:r>
-              <a:rPr lang="de-DE" sz="2800" dirty="0"/>
-              <a:t>Bei der Berechnung der nächsten Zahl soll geprüft werden ob die vorherige Zahl teilbar durch 3 ist. </a:t>
-            </a:r>
-          </a:p>
-          <a:p>
-            <a:pPr marL="256032" lvl="1" indent="0">
-              <a:lnSpc>
-                <a:spcPct val="120000"/>
-              </a:lnSpc>
-              <a:buNone/>
-            </a:pPr>
-            <a:r>
-              <a:rPr lang="de-DE" sz="2800" dirty="0"/>
-              <a:t>	-&gt; Wenn ja, dann soll der nächste Wert berechnet werden aus dem 			vorherigen Wert + 7</a:t>
-            </a:r>
-          </a:p>
-          <a:p>
-            <a:pPr marL="256032" lvl="1" indent="0">
-              <a:lnSpc>
-                <a:spcPct val="120000"/>
-              </a:lnSpc>
-              <a:buNone/>
-            </a:pPr>
-            <a:r>
-              <a:rPr lang="de-DE" sz="2800" dirty="0"/>
-              <a:t>	-&gt; ansonsten soll der nächste Wert berechnet werden aus dem vorherigen 		Wert – 2</a:t>
-            </a:r>
-          </a:p>
-          <a:p>
-            <a:pPr marL="256032" lvl="1" indent="0">
-              <a:lnSpc>
-                <a:spcPct val="150000"/>
-              </a:lnSpc>
-              <a:buNone/>
-            </a:pPr>
-            <a:r>
-              <a:rPr lang="de-DE" sz="2800" dirty="0"/>
-              <a:t>2. Stellen Sie die Folge grafisch dar </a:t>
-            </a:r>
-          </a:p>
-        </p:txBody>
-      </p:sp>
-    </p:spTree>
-    <p:extLst>
-      <p:ext uri="{BB962C8B-B14F-4D97-AF65-F5344CB8AC3E}">
-        <p14:creationId xmlns:p14="http://schemas.microsoft.com/office/powerpoint/2010/main" val="3529331888"/>
       </p:ext>
     </p:extLst>
   </p:cSld>
@@ -14720,7 +15130,7 @@
           <p:cNvPr id="2" name="Titel 1">
             <a:extLst>
               <a:ext uri="{FF2B5EF4-FFF2-40B4-BE49-F238E27FC236}">
-                <a16:creationId xmlns:a16="http://schemas.microsoft.com/office/drawing/2014/main" id="{2F8442BA-4AF9-4F3C-A1DE-0472859C5193}"/>
+                <a16:creationId xmlns:a16="http://schemas.microsoft.com/office/drawing/2014/main" id="{C4237B4F-0744-4883-AAB0-293CC3A7ED88}"/>
               </a:ext>
             </a:extLst>
           </p:cNvPr>
@@ -14733,23 +15143,21 @@
         </p:nvSpPr>
         <p:spPr>
           <a:xfrm>
-            <a:off x="638174" y="340045"/>
-            <a:ext cx="10772775" cy="654100"/>
+            <a:off x="657224" y="499533"/>
+            <a:ext cx="10772775" cy="861434"/>
           </a:xfrm>
         </p:spPr>
         <p:txBody>
-          <a:bodyPr>
-            <a:normAutofit fontScale="90000"/>
-          </a:bodyPr>
+          <a:bodyPr/>
           <a:lstStyle/>
           <a:p>
             <a:r>
               <a:rPr lang="de-DE" dirty="0"/>
-              <a:t>Übung </a:t>
+              <a:t>Übung Schleife mit </a:t>
             </a:r>
             <a:r>
               <a:rPr lang="de-DE" dirty="0" err="1"/>
-              <a:t>Babynames</a:t>
+              <a:t>if-else</a:t>
             </a:r>
             <a:endParaRPr lang="de-DE" dirty="0"/>
           </a:p>
@@ -14760,7 +15168,7 @@
           <p:cNvPr id="3" name="Inhaltsplatzhalter 2">
             <a:extLst>
               <a:ext uri="{FF2B5EF4-FFF2-40B4-BE49-F238E27FC236}">
-                <a16:creationId xmlns:a16="http://schemas.microsoft.com/office/drawing/2014/main" id="{B134B269-5E99-40A2-8851-AA5EE490B9DC}"/>
+                <a16:creationId xmlns:a16="http://schemas.microsoft.com/office/drawing/2014/main" id="{EBC88ED8-5F13-4AFE-AD62-F1AE70FA6DE0}"/>
               </a:ext>
             </a:extLst>
           </p:cNvPr>
@@ -14773,8 +15181,8 @@
         </p:nvSpPr>
         <p:spPr>
           <a:xfrm>
-            <a:off x="676656" y="1313121"/>
-            <a:ext cx="10753725" cy="4768701"/>
+            <a:off x="676656" y="1440712"/>
+            <a:ext cx="10997893" cy="5002618"/>
           </a:xfrm>
         </p:spPr>
         <p:txBody>
@@ -14792,67 +15200,69 @@
             </a:pPr>
             <a:r>
               <a:rPr lang="de-DE" sz="2800" dirty="0"/>
-              <a:t>Lesen Sie den Datensatz </a:t>
-            </a:r>
-            <a:r>
-              <a:rPr lang="de-DE" sz="2800" dirty="0" err="1"/>
-              <a:t>babyNamesUS</a:t>
-            </a:r>
-            <a:r>
-              <a:rPr lang="de-DE" sz="2800" dirty="0"/>
-              <a:t> ein</a:t>
-            </a:r>
-          </a:p>
-          <a:p>
-            <a:pPr marL="457200" indent="-457200">
+              <a:t>Berechnen Sie die ersten 100 Stellen einer Folge mit den folgenden Eigenschaften:</a:t>
+            </a:r>
+          </a:p>
+          <a:p>
+            <a:pPr marL="713232" lvl="1" indent="-457200">
               <a:lnSpc>
                 <a:spcPct val="150000"/>
               </a:lnSpc>
-              <a:buFont typeface="+mj-lt"/>
-              <a:buAutoNum type="arabicPeriod"/>
+              <a:buFont typeface="Arial" panose="020B0604020202020204" pitchFamily="34" charset="0"/>
+              <a:buChar char="•"/>
             </a:pPr>
             <a:r>
               <a:rPr lang="de-DE" sz="2800" dirty="0"/>
-              <a:t>Erstellen Sie einen Vektor mit eindeutigen Jahreszahlen im Datensatz</a:t>
-            </a:r>
-          </a:p>
-          <a:p>
-            <a:pPr marL="457200" indent="-457200">
-              <a:lnSpc>
-                <a:spcPct val="110000"/>
-              </a:lnSpc>
-              <a:buFont typeface="+mj-lt"/>
-              <a:buAutoNum type="arabicPeriod"/>
-            </a:pPr>
-            <a:r>
-              <a:rPr lang="de-DE" sz="2800" dirty="0"/>
-              <a:t>Extrahieren Sie mittels Schleife den populärsten Namen und die Anzahl der Geburten pro Jahr. Erstellen Sie dafür vor der Schleife entsprechende leere Vektoren und nutzen Sie den Vektor mit den Jahreszahlen.</a:t>
-            </a:r>
-          </a:p>
-          <a:p>
-            <a:pPr marL="457200" indent="-457200">
+              <a:t>Sie startet mit dem Wert 3</a:t>
+            </a:r>
+          </a:p>
+          <a:p>
+            <a:pPr marL="713232" lvl="1" indent="-457200">
               <a:lnSpc>
                 <a:spcPct val="120000"/>
               </a:lnSpc>
-              <a:buFont typeface="+mj-lt"/>
-              <a:buAutoNum type="arabicPeriod"/>
+              <a:buFont typeface="Arial" panose="020B0604020202020204" pitchFamily="34" charset="0"/>
+              <a:buChar char="•"/>
             </a:pPr>
             <a:r>
               <a:rPr lang="de-DE" sz="2800" dirty="0"/>
-              <a:t>Stellen Sie grafisch dar wie häufig die populärsten Namen über die Jahre vorkamen</a:t>
-            </a:r>
-          </a:p>
-          <a:p>
-            <a:pPr marL="457200" indent="-457200">
+              <a:t>Bei der Berechnung der nächsten Zahl soll geprüft werden ob die vorherige Zahl teilbar durch 3 ist. </a:t>
+            </a:r>
+          </a:p>
+          <a:p>
+            <a:pPr marL="256032" lvl="1" indent="0">
               <a:lnSpc>
                 <a:spcPct val="120000"/>
               </a:lnSpc>
-              <a:buFont typeface="+mj-lt"/>
-              <a:buAutoNum type="arabicPeriod"/>
+              <a:buNone/>
             </a:pPr>
             <a:r>
               <a:rPr lang="de-DE" sz="2800" dirty="0"/>
-              <a:t>Erstellen Sie einen Plot mit der Entwicklung der Geburtenzahlen im Laufe der Jahre</a:t>
+              <a:t>	-&gt; Wenn ja, dann soll der nächste Wert berechnet werden aus dem 			vorherigen Wert + 7</a:t>
+            </a:r>
+          </a:p>
+          <a:p>
+            <a:pPr marL="256032" lvl="1" indent="0">
+              <a:lnSpc>
+                <a:spcPct val="120000"/>
+              </a:lnSpc>
+              <a:buNone/>
+            </a:pPr>
+            <a:r>
+              <a:rPr lang="de-DE" sz="2800" dirty="0"/>
+              <a:t>	-&gt; ansonsten soll der nächste Wert berechnet werden aus dem vorherigen 		Wert – 2</a:t>
+            </a:r>
+          </a:p>
+          <a:p>
+            <a:pPr marL="256032" lvl="1" indent="0">
+              <a:lnSpc>
+                <a:spcPct val="150000"/>
+              </a:lnSpc>
+              <a:buNone/>
+            </a:pPr>
+            <a:r>
+              <a:rPr lang="de-DE" sz="2800" dirty="0"/>
+              <a:t>2. Stellen Sie die Folge grafisch dar </a:t>
             </a:r>
           </a:p>
         </p:txBody>
@@ -14860,7 +15270,7 @@
     </p:spTree>
     <p:extLst>
       <p:ext uri="{BB962C8B-B14F-4D97-AF65-F5344CB8AC3E}">
-        <p14:creationId xmlns:p14="http://schemas.microsoft.com/office/powerpoint/2010/main" val="1150970870"/>
+        <p14:creationId xmlns:p14="http://schemas.microsoft.com/office/powerpoint/2010/main" val="3529331888"/>
       </p:ext>
     </p:extLst>
   </p:cSld>
@@ -14991,6 +15401,178 @@
 </file>
 
 <file path=ppt/slides/slide40.xml><?xml version="1.0" encoding="utf-8"?>
+<p:sld xmlns:a="http://schemas.openxmlformats.org/drawingml/2006/main" xmlns:r="http://schemas.openxmlformats.org/officeDocument/2006/relationships" xmlns:p="http://schemas.openxmlformats.org/presentationml/2006/main">
+  <p:cSld>
+    <p:spTree>
+      <p:nvGrpSpPr>
+        <p:cNvPr id="1" name=""/>
+        <p:cNvGrpSpPr/>
+        <p:nvPr/>
+      </p:nvGrpSpPr>
+      <p:grpSpPr>
+        <a:xfrm>
+          <a:off x="0" y="0"/>
+          <a:ext cx="0" cy="0"/>
+          <a:chOff x="0" y="0"/>
+          <a:chExt cx="0" cy="0"/>
+        </a:xfrm>
+      </p:grpSpPr>
+      <p:sp>
+        <p:nvSpPr>
+          <p:cNvPr id="2" name="Titel 1">
+            <a:extLst>
+              <a:ext uri="{FF2B5EF4-FFF2-40B4-BE49-F238E27FC236}">
+                <a16:creationId xmlns:a16="http://schemas.microsoft.com/office/drawing/2014/main" id="{2F8442BA-4AF9-4F3C-A1DE-0472859C5193}"/>
+              </a:ext>
+            </a:extLst>
+          </p:cNvPr>
+          <p:cNvSpPr>
+            <a:spLocks noGrp="1"/>
+          </p:cNvSpPr>
+          <p:nvPr>
+            <p:ph type="title"/>
+          </p:nvPr>
+        </p:nvSpPr>
+        <p:spPr>
+          <a:xfrm>
+            <a:off x="638174" y="340045"/>
+            <a:ext cx="10772775" cy="654100"/>
+          </a:xfrm>
+        </p:spPr>
+        <p:txBody>
+          <a:bodyPr>
+            <a:normAutofit fontScale="90000"/>
+          </a:bodyPr>
+          <a:lstStyle/>
+          <a:p>
+            <a:r>
+              <a:rPr lang="de-DE" dirty="0"/>
+              <a:t>Übung </a:t>
+            </a:r>
+            <a:r>
+              <a:rPr lang="de-DE" dirty="0" err="1"/>
+              <a:t>Babynames</a:t>
+            </a:r>
+            <a:endParaRPr lang="de-DE" dirty="0"/>
+          </a:p>
+        </p:txBody>
+      </p:sp>
+      <p:sp>
+        <p:nvSpPr>
+          <p:cNvPr id="3" name="Inhaltsplatzhalter 2">
+            <a:extLst>
+              <a:ext uri="{FF2B5EF4-FFF2-40B4-BE49-F238E27FC236}">
+                <a16:creationId xmlns:a16="http://schemas.microsoft.com/office/drawing/2014/main" id="{B134B269-5E99-40A2-8851-AA5EE490B9DC}"/>
+              </a:ext>
+            </a:extLst>
+          </p:cNvPr>
+          <p:cNvSpPr>
+            <a:spLocks noGrp="1"/>
+          </p:cNvSpPr>
+          <p:nvPr>
+            <p:ph idx="1"/>
+          </p:nvPr>
+        </p:nvSpPr>
+        <p:spPr>
+          <a:xfrm>
+            <a:off x="676656" y="1313121"/>
+            <a:ext cx="10753725" cy="4768701"/>
+          </a:xfrm>
+        </p:spPr>
+        <p:txBody>
+          <a:bodyPr>
+            <a:normAutofit fontScale="92500" lnSpcReduction="20000"/>
+          </a:bodyPr>
+          <a:lstStyle/>
+          <a:p>
+            <a:pPr marL="457200" indent="-457200">
+              <a:lnSpc>
+                <a:spcPct val="150000"/>
+              </a:lnSpc>
+              <a:buFont typeface="+mj-lt"/>
+              <a:buAutoNum type="arabicPeriod"/>
+            </a:pPr>
+            <a:r>
+              <a:rPr lang="de-DE" sz="2800" dirty="0"/>
+              <a:t>Lesen Sie den Datensatz </a:t>
+            </a:r>
+            <a:r>
+              <a:rPr lang="de-DE" sz="2800" dirty="0" err="1"/>
+              <a:t>babyNamesUS</a:t>
+            </a:r>
+            <a:r>
+              <a:rPr lang="de-DE" sz="2800" dirty="0"/>
+              <a:t> ein</a:t>
+            </a:r>
+          </a:p>
+          <a:p>
+            <a:pPr marL="457200" indent="-457200">
+              <a:lnSpc>
+                <a:spcPct val="150000"/>
+              </a:lnSpc>
+              <a:buFont typeface="+mj-lt"/>
+              <a:buAutoNum type="arabicPeriod"/>
+            </a:pPr>
+            <a:r>
+              <a:rPr lang="de-DE" sz="2800" dirty="0"/>
+              <a:t>Erstellen Sie einen Vektor mit eindeutigen Jahreszahlen im Datensatz</a:t>
+            </a:r>
+          </a:p>
+          <a:p>
+            <a:pPr marL="457200" indent="-457200">
+              <a:lnSpc>
+                <a:spcPct val="110000"/>
+              </a:lnSpc>
+              <a:buFont typeface="+mj-lt"/>
+              <a:buAutoNum type="arabicPeriod"/>
+            </a:pPr>
+            <a:r>
+              <a:rPr lang="de-DE" sz="2800" dirty="0"/>
+              <a:t>Extrahieren Sie mittels Schleife den populärsten Namen und die Anzahl der Geburten pro Jahr. Erstellen Sie dafür vor der Schleife entsprechende leere Vektoren und nutzen Sie den Vektor mit den Jahreszahlen.</a:t>
+            </a:r>
+          </a:p>
+          <a:p>
+            <a:pPr marL="457200" indent="-457200">
+              <a:lnSpc>
+                <a:spcPct val="120000"/>
+              </a:lnSpc>
+              <a:buFont typeface="+mj-lt"/>
+              <a:buAutoNum type="arabicPeriod"/>
+            </a:pPr>
+            <a:r>
+              <a:rPr lang="de-DE" sz="2800" dirty="0"/>
+              <a:t>Stellen Sie grafisch dar wie häufig die populärsten Namen über die Jahre vorkamen</a:t>
+            </a:r>
+          </a:p>
+          <a:p>
+            <a:pPr marL="457200" indent="-457200">
+              <a:lnSpc>
+                <a:spcPct val="120000"/>
+              </a:lnSpc>
+              <a:buFont typeface="+mj-lt"/>
+              <a:buAutoNum type="arabicPeriod"/>
+            </a:pPr>
+            <a:r>
+              <a:rPr lang="de-DE" sz="2800" dirty="0"/>
+              <a:t>Erstellen Sie einen Plot mit der Entwicklung der Geburtenzahlen im Laufe der Jahre</a:t>
+            </a:r>
+          </a:p>
+        </p:txBody>
+      </p:sp>
+    </p:spTree>
+    <p:extLst>
+      <p:ext uri="{BB962C8B-B14F-4D97-AF65-F5344CB8AC3E}">
+        <p14:creationId xmlns:p14="http://schemas.microsoft.com/office/powerpoint/2010/main" val="1150970870"/>
+      </p:ext>
+    </p:extLst>
+  </p:cSld>
+  <p:clrMapOvr>
+    <a:masterClrMapping/>
+  </p:clrMapOvr>
+</p:sld>
+</file>
+
+<file path=ppt/slides/slide41.xml><?xml version="1.0" encoding="utf-8"?>
 <p:sld xmlns:a="http://schemas.openxmlformats.org/drawingml/2006/main" xmlns:r="http://schemas.openxmlformats.org/officeDocument/2006/relationships" xmlns:p="http://schemas.openxmlformats.org/presentationml/2006/main">
   <p:cSld>
     <p:spTree>

</xml_diff>

<commit_message>
Plots als Grafiken in Powerpoint eingefügt
</commit_message>
<xml_diff>
--- a/Präsentationen/Einführung in R.pptx
+++ b/Präsentationen/Einführung in R.pptx
@@ -29,23 +29,28 @@
     <p:sldId id="279" r:id="rId23"/>
     <p:sldId id="283" r:id="rId24"/>
     <p:sldId id="280" r:id="rId25"/>
-    <p:sldId id="282" r:id="rId26"/>
-    <p:sldId id="262" r:id="rId27"/>
+    <p:sldId id="262" r:id="rId26"/>
+    <p:sldId id="282" r:id="rId27"/>
     <p:sldId id="284" r:id="rId28"/>
     <p:sldId id="281" r:id="rId29"/>
     <p:sldId id="263" r:id="rId30"/>
     <p:sldId id="285" r:id="rId31"/>
     <p:sldId id="287" r:id="rId32"/>
-    <p:sldId id="288" r:id="rId33"/>
-    <p:sldId id="289" r:id="rId34"/>
-    <p:sldId id="291" r:id="rId35"/>
-    <p:sldId id="290" r:id="rId36"/>
-    <p:sldId id="292" r:id="rId37"/>
-    <p:sldId id="293" r:id="rId38"/>
-    <p:sldId id="294" r:id="rId39"/>
-    <p:sldId id="295" r:id="rId40"/>
-    <p:sldId id="296" r:id="rId41"/>
-    <p:sldId id="297" r:id="rId42"/>
+    <p:sldId id="300" r:id="rId33"/>
+    <p:sldId id="288" r:id="rId34"/>
+    <p:sldId id="301" r:id="rId35"/>
+    <p:sldId id="289" r:id="rId36"/>
+    <p:sldId id="302" r:id="rId37"/>
+    <p:sldId id="291" r:id="rId38"/>
+    <p:sldId id="303" r:id="rId39"/>
+    <p:sldId id="290" r:id="rId40"/>
+    <p:sldId id="304" r:id="rId41"/>
+    <p:sldId id="292" r:id="rId42"/>
+    <p:sldId id="293" r:id="rId43"/>
+    <p:sldId id="294" r:id="rId44"/>
+    <p:sldId id="295" r:id="rId45"/>
+    <p:sldId id="296" r:id="rId46"/>
+    <p:sldId id="297" r:id="rId47"/>
   </p:sldIdLst>
   <p:sldSz cx="12192000" cy="6858000"/>
   <p:notesSz cx="6858000" cy="9144000"/>
@@ -10830,189 +10835,6 @@
           <p:cNvPr id="2" name="Titel 1">
             <a:extLst>
               <a:ext uri="{FF2B5EF4-FFF2-40B4-BE49-F238E27FC236}">
-                <a16:creationId xmlns:a16="http://schemas.microsoft.com/office/drawing/2014/main" id="{5A835445-EAC6-4597-B652-BE08B7478B0E}"/>
-              </a:ext>
-            </a:extLst>
-          </p:cNvPr>
-          <p:cNvSpPr>
-            <a:spLocks noGrp="1"/>
-          </p:cNvSpPr>
-          <p:nvPr>
-            <p:ph type="title"/>
-          </p:nvPr>
-        </p:nvSpPr>
-        <p:spPr/>
-        <p:txBody>
-          <a:bodyPr/>
-          <a:lstStyle/>
-          <a:p>
-            <a:r>
-              <a:rPr lang="de-DE" b="1" dirty="0"/>
-              <a:t>Übung: Matrizen</a:t>
-            </a:r>
-          </a:p>
-        </p:txBody>
-      </p:sp>
-      <p:sp>
-        <p:nvSpPr>
-          <p:cNvPr id="3" name="Inhaltsplatzhalter 2">
-            <a:extLst>
-              <a:ext uri="{FF2B5EF4-FFF2-40B4-BE49-F238E27FC236}">
-                <a16:creationId xmlns:a16="http://schemas.microsoft.com/office/drawing/2014/main" id="{C377893B-9CA7-49BE-AD7E-22008EBF7734}"/>
-              </a:ext>
-            </a:extLst>
-          </p:cNvPr>
-          <p:cNvSpPr>
-            <a:spLocks noGrp="1"/>
-          </p:cNvSpPr>
-          <p:nvPr>
-            <p:ph idx="1"/>
-          </p:nvPr>
-        </p:nvSpPr>
-        <p:spPr/>
-        <p:txBody>
-          <a:bodyPr/>
-          <a:lstStyle/>
-          <a:p>
-            <a:pPr marL="457200" indent="-457200">
-              <a:buFont typeface="+mj-lt"/>
-              <a:buAutoNum type="arabicPeriod"/>
-            </a:pPr>
-            <a:r>
-              <a:rPr lang="de-DE" dirty="0"/>
-              <a:t>Erzeugen Sie eine Matrix mit 0 mit den Dimensionen 5 Zeilen und 5 Spalten</a:t>
-            </a:r>
-          </a:p>
-          <a:p>
-            <a:pPr marL="457200" indent="-457200">
-              <a:buFont typeface="+mj-lt"/>
-              <a:buAutoNum type="arabicPeriod"/>
-            </a:pPr>
-            <a:r>
-              <a:rPr lang="de-DE" dirty="0"/>
-              <a:t>Füllen Sie Zellen der Matrix </a:t>
-            </a:r>
-            <a:r>
-              <a:rPr lang="de-DE"/>
-              <a:t>wie dargestellt</a:t>
-            </a:r>
-            <a:endParaRPr lang="de-DE" dirty="0"/>
-          </a:p>
-          <a:p>
-            <a:pPr marL="457200" indent="-457200">
-              <a:buFont typeface="+mj-lt"/>
-              <a:buAutoNum type="arabicPeriod"/>
-            </a:pPr>
-            <a:r>
-              <a:rPr lang="de-DE" dirty="0"/>
-              <a:t>Löschen Sie alle Zellen mit den Werten 5 aus der</a:t>
-            </a:r>
-          </a:p>
-          <a:p>
-            <a:pPr marL="0" indent="0">
-              <a:buNone/>
-            </a:pPr>
-            <a:r>
-              <a:rPr lang="de-DE" dirty="0"/>
-              <a:t>	Matrix. Die Matrix soll danach nur noch</a:t>
-            </a:r>
-          </a:p>
-          <a:p>
-            <a:pPr marL="0" indent="0">
-              <a:buNone/>
-            </a:pPr>
-            <a:r>
-              <a:rPr lang="de-DE" dirty="0"/>
-              <a:t>	3 Zeilen und 3 Spalten besitzen</a:t>
-            </a:r>
-          </a:p>
-          <a:p>
-            <a:pPr marL="457200" indent="-457200">
-              <a:buFont typeface="+mj-lt"/>
-              <a:buAutoNum type="arabicPeriod"/>
-            </a:pPr>
-            <a:endParaRPr lang="de-DE" dirty="0"/>
-          </a:p>
-          <a:p>
-            <a:pPr marL="457200" indent="-457200">
-              <a:buFont typeface="+mj-lt"/>
-              <a:buAutoNum type="arabicPeriod"/>
-            </a:pPr>
-            <a:endParaRPr lang="de-DE" dirty="0"/>
-          </a:p>
-        </p:txBody>
-      </p:sp>
-      <p:pic>
-        <p:nvPicPr>
-          <p:cNvPr id="5" name="Grafik 4">
-            <a:extLst>
-              <a:ext uri="{FF2B5EF4-FFF2-40B4-BE49-F238E27FC236}">
-                <a16:creationId xmlns:a16="http://schemas.microsoft.com/office/drawing/2014/main" id="{CC057750-FEE5-407E-9EEA-71F34CEE4D9A}"/>
-              </a:ext>
-            </a:extLst>
-          </p:cNvPr>
-          <p:cNvPicPr>
-            <a:picLocks noChangeAspect="1"/>
-          </p:cNvPicPr>
-          <p:nvPr/>
-        </p:nvPicPr>
-        <p:blipFill>
-          <a:blip r:embed="rId2">
-            <a:extLst>
-              <a:ext uri="{28A0092B-C50C-407E-A947-70E740481C1C}">
-                <a14:useLocalDpi xmlns:a14="http://schemas.microsoft.com/office/drawing/2010/main" val="0"/>
-              </a:ext>
-            </a:extLst>
-          </a:blip>
-          <a:stretch>
-            <a:fillRect/>
-          </a:stretch>
-        </p:blipFill>
-        <p:spPr>
-          <a:xfrm>
-            <a:off x="7366311" y="2484006"/>
-            <a:ext cx="3289247" cy="2423143"/>
-          </a:xfrm>
-          <a:prstGeom prst="rect">
-            <a:avLst/>
-          </a:prstGeom>
-        </p:spPr>
-      </p:pic>
-    </p:spTree>
-    <p:extLst>
-      <p:ext uri="{BB962C8B-B14F-4D97-AF65-F5344CB8AC3E}">
-        <p14:creationId xmlns:p14="http://schemas.microsoft.com/office/powerpoint/2010/main" val="3480588357"/>
-      </p:ext>
-    </p:extLst>
-  </p:cSld>
-  <p:clrMapOvr>
-    <a:masterClrMapping/>
-  </p:clrMapOvr>
-</p:sld>
-</file>
-
-<file path=ppt/slides/slide26.xml><?xml version="1.0" encoding="utf-8"?>
-<p:sld xmlns:a="http://schemas.openxmlformats.org/drawingml/2006/main" xmlns:r="http://schemas.openxmlformats.org/officeDocument/2006/relationships" xmlns:p="http://schemas.openxmlformats.org/presentationml/2006/main">
-  <p:cSld>
-    <p:spTree>
-      <p:nvGrpSpPr>
-        <p:cNvPr id="1" name=""/>
-        <p:cNvGrpSpPr/>
-        <p:nvPr/>
-      </p:nvGrpSpPr>
-      <p:grpSpPr>
-        <a:xfrm>
-          <a:off x="0" y="0"/>
-          <a:ext cx="0" cy="0"/>
-          <a:chOff x="0" y="0"/>
-          <a:chExt cx="0" cy="0"/>
-        </a:xfrm>
-      </p:grpSpPr>
-      <p:sp>
-        <p:nvSpPr>
-          <p:cNvPr id="2" name="Titel 1">
-            <a:extLst>
-              <a:ext uri="{FF2B5EF4-FFF2-40B4-BE49-F238E27FC236}">
                 <a16:creationId xmlns:a16="http://schemas.microsoft.com/office/drawing/2014/main" id="{AC027F97-6EC1-4A37-B082-BDDE5E5BAF69}"/>
               </a:ext>
             </a:extLst>
@@ -11081,7 +10903,7 @@
             </a:pPr>
             <a:r>
               <a:rPr lang="de-DE" sz="2800" dirty="0"/>
-              <a:t>Bei Indizierung mit [] muss jetzt Zeile </a:t>
+              <a:t>Bei Indizierung mit [ , ] gibt es Zeile </a:t>
             </a:r>
             <a:r>
               <a:rPr lang="de-DE" sz="2800" b="1" dirty="0"/>
@@ -11116,7 +10938,16 @@
             </a:pPr>
             <a:r>
               <a:rPr lang="de-DE" sz="2800" dirty="0"/>
-              <a:t>	-&gt; Matrix[Zeile, Spalte]</a:t>
+              <a:t>	Bsp.: Matrix[Zeile, Spalte]</a:t>
+            </a:r>
+          </a:p>
+          <a:p>
+            <a:pPr marL="0" indent="0">
+              <a:buNone/>
+            </a:pPr>
+            <a:r>
+              <a:rPr lang="de-DE" sz="2800" dirty="0"/>
+              <a:t>-&gt; Keine Angabe von Zeilen- oder Spaltenindex bedeutet gesamte 	Zeile/Spalte</a:t>
             </a:r>
           </a:p>
         </p:txBody>
@@ -11384,6 +11215,55 @@
                       </p:childTnLst>
                     </p:cTn>
                   </p:par>
+                  <p:par>
+                    <p:cTn id="23" fill="hold">
+                      <p:stCondLst>
+                        <p:cond delay="indefinite"/>
+                      </p:stCondLst>
+                      <p:childTnLst>
+                        <p:par>
+                          <p:cTn id="24" fill="hold">
+                            <p:stCondLst>
+                              <p:cond delay="0"/>
+                            </p:stCondLst>
+                            <p:childTnLst>
+                              <p:par>
+                                <p:cTn id="25" presetID="1" presetClass="entr" presetSubtype="0" fill="hold" nodeType="clickEffect">
+                                  <p:stCondLst>
+                                    <p:cond delay="0"/>
+                                  </p:stCondLst>
+                                  <p:childTnLst>
+                                    <p:set>
+                                      <p:cBhvr>
+                                        <p:cTn id="26" dur="1" fill="hold">
+                                          <p:stCondLst>
+                                            <p:cond delay="0"/>
+                                          </p:stCondLst>
+                                        </p:cTn>
+                                        <p:tgtEl>
+                                          <p:spTgt spid="3">
+                                            <p:txEl>
+                                              <p:pRg st="6" end="6"/>
+                                            </p:txEl>
+                                          </p:spTgt>
+                                        </p:tgtEl>
+                                        <p:attrNameLst>
+                                          <p:attrName>style.visibility</p:attrName>
+                                        </p:attrNameLst>
+                                      </p:cBhvr>
+                                      <p:to>
+                                        <p:strVal val="visible"/>
+                                      </p:to>
+                                    </p:set>
+                                  </p:childTnLst>
+                                </p:cTn>
+                              </p:par>
+                            </p:childTnLst>
+                          </p:cTn>
+                        </p:par>
+                      </p:childTnLst>
+                    </p:cTn>
+                  </p:par>
                 </p:childTnLst>
               </p:cTn>
               <p:prevCondLst>
@@ -11406,6 +11286,193 @@
       </p:par>
     </p:tnLst>
   </p:timing>
+</p:sld>
+</file>
+
+<file path=ppt/slides/slide26.xml><?xml version="1.0" encoding="utf-8"?>
+<p:sld xmlns:a="http://schemas.openxmlformats.org/drawingml/2006/main" xmlns:r="http://schemas.openxmlformats.org/officeDocument/2006/relationships" xmlns:p="http://schemas.openxmlformats.org/presentationml/2006/main">
+  <p:cSld>
+    <p:spTree>
+      <p:nvGrpSpPr>
+        <p:cNvPr id="1" name=""/>
+        <p:cNvGrpSpPr/>
+        <p:nvPr/>
+      </p:nvGrpSpPr>
+      <p:grpSpPr>
+        <a:xfrm>
+          <a:off x="0" y="0"/>
+          <a:ext cx="0" cy="0"/>
+          <a:chOff x="0" y="0"/>
+          <a:chExt cx="0" cy="0"/>
+        </a:xfrm>
+      </p:grpSpPr>
+      <p:sp>
+        <p:nvSpPr>
+          <p:cNvPr id="2" name="Titel 1">
+            <a:extLst>
+              <a:ext uri="{FF2B5EF4-FFF2-40B4-BE49-F238E27FC236}">
+                <a16:creationId xmlns:a16="http://schemas.microsoft.com/office/drawing/2014/main" id="{5A835445-EAC6-4597-B652-BE08B7478B0E}"/>
+              </a:ext>
+            </a:extLst>
+          </p:cNvPr>
+          <p:cNvSpPr>
+            <a:spLocks noGrp="1"/>
+          </p:cNvSpPr>
+          <p:nvPr>
+            <p:ph type="title"/>
+          </p:nvPr>
+        </p:nvSpPr>
+        <p:spPr/>
+        <p:txBody>
+          <a:bodyPr/>
+          <a:lstStyle/>
+          <a:p>
+            <a:r>
+              <a:rPr lang="de-DE" b="1" dirty="0"/>
+              <a:t>Übung: Matrizen</a:t>
+            </a:r>
+          </a:p>
+        </p:txBody>
+      </p:sp>
+      <p:sp>
+        <p:nvSpPr>
+          <p:cNvPr id="3" name="Inhaltsplatzhalter 2">
+            <a:extLst>
+              <a:ext uri="{FF2B5EF4-FFF2-40B4-BE49-F238E27FC236}">
+                <a16:creationId xmlns:a16="http://schemas.microsoft.com/office/drawing/2014/main" id="{C377893B-9CA7-49BE-AD7E-22008EBF7734}"/>
+              </a:ext>
+            </a:extLst>
+          </p:cNvPr>
+          <p:cNvSpPr>
+            <a:spLocks noGrp="1"/>
+          </p:cNvSpPr>
+          <p:nvPr>
+            <p:ph idx="1"/>
+          </p:nvPr>
+        </p:nvSpPr>
+        <p:spPr/>
+        <p:txBody>
+          <a:bodyPr/>
+          <a:lstStyle/>
+          <a:p>
+            <a:pPr marL="0" indent="0">
+              <a:buNone/>
+            </a:pPr>
+            <a:r>
+              <a:rPr lang="de-DE" dirty="0"/>
+              <a:t>Erzeugen Sie eine Matrix aus 0 mit den Dimensionen 5 Zeilen und 5 Spalten</a:t>
+            </a:r>
+          </a:p>
+          <a:p>
+            <a:pPr marL="0" indent="0">
+              <a:buNone/>
+            </a:pPr>
+            <a:endParaRPr lang="de-DE" dirty="0"/>
+          </a:p>
+          <a:p>
+            <a:pPr marL="0" indent="0">
+              <a:buNone/>
+            </a:pPr>
+            <a:r>
+              <a:rPr lang="de-DE" dirty="0"/>
+              <a:t>Füllen Sie Zellen der Matrix wie dargestellt</a:t>
+            </a:r>
+          </a:p>
+          <a:p>
+            <a:pPr marL="0" indent="0">
+              <a:buNone/>
+            </a:pPr>
+            <a:endParaRPr lang="de-DE" dirty="0"/>
+          </a:p>
+          <a:p>
+            <a:pPr marL="0" indent="0">
+              <a:buNone/>
+            </a:pPr>
+            <a:r>
+              <a:rPr lang="de-DE" dirty="0"/>
+              <a:t>Löschen Sie alle Zellen mit den Werten 5 aus der</a:t>
+            </a:r>
+          </a:p>
+          <a:p>
+            <a:pPr marL="0" indent="0">
+              <a:buNone/>
+            </a:pPr>
+            <a:r>
+              <a:rPr lang="de-DE" dirty="0"/>
+              <a:t>Matrix. Die Matrix soll danach nur noch 3 Zeilen </a:t>
+            </a:r>
+          </a:p>
+          <a:p>
+            <a:pPr marL="0" indent="0">
+              <a:buNone/>
+            </a:pPr>
+            <a:r>
+              <a:rPr lang="de-DE" dirty="0"/>
+              <a:t>und 3 Spalten besitzen</a:t>
+            </a:r>
+          </a:p>
+          <a:p>
+            <a:pPr marL="457200" indent="-457200">
+              <a:buFont typeface="+mj-lt"/>
+              <a:buAutoNum type="arabicPeriod"/>
+            </a:pPr>
+            <a:endParaRPr lang="de-DE" dirty="0"/>
+          </a:p>
+          <a:p>
+            <a:pPr marL="457200" indent="-457200">
+              <a:buFont typeface="+mj-lt"/>
+              <a:buAutoNum type="arabicPeriod"/>
+            </a:pPr>
+            <a:endParaRPr lang="de-DE" dirty="0"/>
+          </a:p>
+        </p:txBody>
+      </p:sp>
+      <p:pic>
+        <p:nvPicPr>
+          <p:cNvPr id="5" name="Grafik 4">
+            <a:extLst>
+              <a:ext uri="{FF2B5EF4-FFF2-40B4-BE49-F238E27FC236}">
+                <a16:creationId xmlns:a16="http://schemas.microsoft.com/office/drawing/2014/main" id="{CC057750-FEE5-407E-9EEA-71F34CEE4D9A}"/>
+              </a:ext>
+            </a:extLst>
+          </p:cNvPr>
+          <p:cNvPicPr>
+            <a:picLocks noChangeAspect="1"/>
+          </p:cNvPicPr>
+          <p:nvPr/>
+        </p:nvPicPr>
+        <p:blipFill>
+          <a:blip r:embed="rId2">
+            <a:extLst>
+              <a:ext uri="{28A0092B-C50C-407E-A947-70E740481C1C}">
+                <a14:useLocalDpi xmlns:a14="http://schemas.microsoft.com/office/drawing/2010/main" val="0"/>
+              </a:ext>
+            </a:extLst>
+          </a:blip>
+          <a:stretch>
+            <a:fillRect/>
+          </a:stretch>
+        </p:blipFill>
+        <p:spPr>
+          <a:xfrm>
+            <a:off x="7397842" y="3161924"/>
+            <a:ext cx="3289247" cy="2423143"/>
+          </a:xfrm>
+          <a:prstGeom prst="rect">
+            <a:avLst/>
+          </a:prstGeom>
+        </p:spPr>
+      </p:pic>
+    </p:spTree>
+    <p:extLst>
+      <p:ext uri="{BB962C8B-B14F-4D97-AF65-F5344CB8AC3E}">
+        <p14:creationId xmlns:p14="http://schemas.microsoft.com/office/powerpoint/2010/main" val="3480588357"/>
+      </p:ext>
+    </p:extLst>
+  </p:cSld>
+  <p:clrMapOvr>
+    <a:masterClrMapping/>
+  </p:clrMapOvr>
 </p:sld>
 </file>
 
@@ -12407,7 +12474,7 @@
         </p:spPr>
         <p:txBody>
           <a:bodyPr>
-            <a:normAutofit/>
+            <a:normAutofit fontScale="92500"/>
           </a:bodyPr>
           <a:lstStyle/>
           <a:p>
@@ -12498,7 +12565,15 @@
             </a:pPr>
             <a:r>
               <a:rPr lang="de-DE" sz="2800" dirty="0"/>
-              <a:t>Einlesen von Dataframes über ‚Import Dataset‘</a:t>
+              <a:t>Einlesen von Dataframes über ‚Import Dataset‘ oder </a:t>
+            </a:r>
+            <a:r>
+              <a:rPr lang="de-DE" sz="2800" dirty="0" err="1"/>
+              <a:t>read.table</a:t>
+            </a:r>
+            <a:r>
+              <a:rPr lang="de-DE" sz="2800" dirty="0"/>
+              <a:t>(), read.csv()</a:t>
             </a:r>
           </a:p>
         </p:txBody>
@@ -13675,15 +13750,17 @@
         <p:spPr>
           <a:xfrm>
             <a:off x="676656" y="175339"/>
-            <a:ext cx="10772775" cy="861434"/>
+            <a:ext cx="10772775" cy="439516"/>
           </a:xfrm>
         </p:spPr>
         <p:txBody>
-          <a:bodyPr/>
+          <a:bodyPr>
+            <a:normAutofit fontScale="90000"/>
+          </a:bodyPr>
           <a:lstStyle/>
           <a:p>
             <a:r>
-              <a:rPr lang="de-DE" b="1" dirty="0"/>
+              <a:rPr lang="de-DE" sz="4400" b="1" dirty="0"/>
               <a:t>Übung: Dataframes</a:t>
             </a:r>
           </a:p>
@@ -13707,8 +13784,8 @@
         </p:nvSpPr>
         <p:spPr>
           <a:xfrm>
-            <a:off x="676656" y="1036773"/>
-            <a:ext cx="10902200" cy="5480985"/>
+            <a:off x="676656" y="733097"/>
+            <a:ext cx="10902200" cy="5784661"/>
           </a:xfrm>
         </p:spPr>
         <p:txBody>
@@ -13756,7 +13833,15 @@
             </a:pPr>
             <a:r>
               <a:rPr lang="de-DE" sz="2800" dirty="0"/>
-              <a:t>Wie viele Papageien gibt es insgesamt im Datensatz?</a:t>
+              <a:t>Wie viele Papageien besitzen alle </a:t>
+            </a:r>
+            <a:r>
+              <a:rPr lang="de-DE" sz="2800" dirty="0" err="1"/>
+              <a:t>Pirat:innen</a:t>
+            </a:r>
+            <a:r>
+              <a:rPr lang="de-DE" sz="2800" dirty="0"/>
+              <a:t> insgesamt?</a:t>
             </a:r>
           </a:p>
           <a:p>
@@ -13784,7 +13869,7 @@
             </a:pPr>
             <a:r>
               <a:rPr lang="de-DE" sz="2800" dirty="0"/>
-              <a:t>Welche Lieblingspiraten gibt es? Finden Sie hierfür eine geeignete Funktion die eindeutige Werte in einem Vektor auflistet</a:t>
+              <a:t>Welche Lieblingspiraten gibt es? Finden Sie hierfür eigenständig eine geeignete Funktion, die eindeutige Werte in einem Vektor auflistet</a:t>
             </a:r>
           </a:p>
           <a:p>
@@ -13810,7 +13895,7 @@
             </a:r>
             <a:r>
               <a:rPr lang="de-DE" sz="2800" dirty="0"/>
-              <a:t> Index) und speichern Sie in diese Spalte das jeweilige Ergebnis von Gewicht geteilt durch Höhe</a:t>
+              <a:t> Index) und speichern Sie in diese Spalte das jeweilige Ergebnis von Gewicht geteilt durch Größe</a:t>
             </a:r>
           </a:p>
           <a:p>
@@ -13838,13 +13923,8 @@
             </a:pPr>
             <a:r>
               <a:rPr lang="de-DE" sz="2800" dirty="0"/>
-              <a:t>Gibt es signifikante Unterschiede der mittleren BMI zwischen weiblichen und männlichen </a:t>
-            </a:r>
-            <a:r>
-              <a:rPr lang="de-DE" sz="2800" dirty="0" err="1"/>
-              <a:t>Pirat:innen</a:t>
-            </a:r>
-            <a:endParaRPr lang="de-DE" sz="2800" dirty="0"/>
+              <a:t>Berechnen Sie den mittleren BMI einmal für Piratinnen und einmal für Piraten</a:t>
+            </a:r>
           </a:p>
         </p:txBody>
       </p:sp>
@@ -13953,12 +14033,48 @@
           <a:chExt cx="0" cy="0"/>
         </a:xfrm>
       </p:grpSpPr>
+      <p:pic>
+        <p:nvPicPr>
+          <p:cNvPr id="5" name="Grafik 4">
+            <a:extLst>
+              <a:ext uri="{FF2B5EF4-FFF2-40B4-BE49-F238E27FC236}">
+                <a16:creationId xmlns:a16="http://schemas.microsoft.com/office/drawing/2014/main" id="{0BFE138C-5CE9-4502-A16E-6DD5394862F9}"/>
+              </a:ext>
+            </a:extLst>
+          </p:cNvPr>
+          <p:cNvPicPr>
+            <a:picLocks noChangeAspect="1"/>
+          </p:cNvPicPr>
+          <p:nvPr/>
+        </p:nvPicPr>
+        <p:blipFill>
+          <a:blip r:embed="rId2">
+            <a:extLst>
+              <a:ext uri="{28A0092B-C50C-407E-A947-70E740481C1C}">
+                <a14:useLocalDpi xmlns:a14="http://schemas.microsoft.com/office/drawing/2010/main" val="0"/>
+              </a:ext>
+            </a:extLst>
+          </a:blip>
+          <a:stretch>
+            <a:fillRect/>
+          </a:stretch>
+        </p:blipFill>
+        <p:spPr>
+          <a:xfrm>
+            <a:off x="2165354" y="571252"/>
+            <a:ext cx="7620660" cy="5715495"/>
+          </a:xfrm>
+          <a:prstGeom prst="rect">
+            <a:avLst/>
+          </a:prstGeom>
+        </p:spPr>
+      </p:pic>
       <p:sp>
         <p:nvSpPr>
           <p:cNvPr id="2" name="Titel 1">
             <a:extLst>
               <a:ext uri="{FF2B5EF4-FFF2-40B4-BE49-F238E27FC236}">
-                <a16:creationId xmlns:a16="http://schemas.microsoft.com/office/drawing/2014/main" id="{08E930B5-825A-4182-B473-4F834C777D77}"/>
+                <a16:creationId xmlns:a16="http://schemas.microsoft.com/office/drawing/2014/main" id="{1649BC34-58C5-47B4-9152-7E10A4241BC6}"/>
               </a:ext>
             </a:extLst>
           </p:cNvPr>
@@ -13971,8 +14087,8 @@
         </p:nvSpPr>
         <p:spPr>
           <a:xfrm>
-            <a:off x="657606" y="564795"/>
-            <a:ext cx="10772775" cy="1030680"/>
+            <a:off x="0" y="0"/>
+            <a:ext cx="10772775" cy="1658198"/>
           </a:xfrm>
         </p:spPr>
         <p:txBody>
@@ -13980,160 +14096,21 @@
           <a:lstStyle/>
           <a:p>
             <a:r>
-              <a:rPr lang="de-DE" b="1" dirty="0"/>
-              <a:t>Übung Histogramm</a:t>
-            </a:r>
-          </a:p>
-        </p:txBody>
-      </p:sp>
-      <p:sp>
-        <p:nvSpPr>
-          <p:cNvPr id="3" name="Inhaltsplatzhalter 2">
-            <a:extLst>
-              <a:ext uri="{FF2B5EF4-FFF2-40B4-BE49-F238E27FC236}">
-                <a16:creationId xmlns:a16="http://schemas.microsoft.com/office/drawing/2014/main" id="{AEB01630-4D3C-4E88-AC29-25204C1F7989}"/>
-              </a:ext>
-            </a:extLst>
-          </p:cNvPr>
-          <p:cNvSpPr>
-            <a:spLocks noGrp="1"/>
-          </p:cNvSpPr>
-          <p:nvPr>
-            <p:ph idx="1"/>
-          </p:nvPr>
-        </p:nvSpPr>
-        <p:spPr>
-          <a:xfrm>
-            <a:off x="676656" y="1655380"/>
-            <a:ext cx="10753725" cy="4122486"/>
-          </a:xfrm>
-        </p:spPr>
-        <p:txBody>
-          <a:bodyPr/>
-          <a:lstStyle/>
-          <a:p>
-            <a:pPr marL="457200" indent="-457200">
-              <a:lnSpc>
-                <a:spcPct val="100000"/>
-              </a:lnSpc>
-              <a:buFont typeface="+mj-lt"/>
-              <a:buAutoNum type="arabicPeriod"/>
-            </a:pPr>
-            <a:r>
-              <a:rPr lang="de-DE" sz="2800" dirty="0"/>
-              <a:t>Erstellen Sie ein Histogramm, das die Verteilung von BMI darstellt</a:t>
-            </a:r>
-          </a:p>
-          <a:p>
-            <a:pPr marL="457200" indent="-457200">
-              <a:lnSpc>
-                <a:spcPct val="100000"/>
-              </a:lnSpc>
-              <a:buFont typeface="+mj-lt"/>
-              <a:buAutoNum type="arabicPeriod"/>
-            </a:pPr>
-            <a:r>
-              <a:rPr lang="de-DE" sz="2800" dirty="0"/>
-              <a:t>Fügen Sie einen Titel und Achsenbeschriftungen hinzu</a:t>
-            </a:r>
-          </a:p>
-          <a:p>
-            <a:pPr marL="457200" indent="-457200">
-              <a:lnSpc>
-                <a:spcPct val="100000"/>
-              </a:lnSpc>
-              <a:buFont typeface="+mj-lt"/>
-              <a:buAutoNum type="arabicPeriod"/>
-            </a:pPr>
-            <a:r>
-              <a:rPr lang="de-DE" sz="2800" dirty="0"/>
-              <a:t>Zeichnen Sie den Mittelwert von BMI mittels </a:t>
-            </a:r>
-            <a:r>
-              <a:rPr lang="de-DE" sz="2800" dirty="0" err="1"/>
-              <a:t>abline</a:t>
-            </a:r>
-            <a:r>
-              <a:rPr lang="de-DE" sz="2800" dirty="0"/>
-              <a:t>() ins Histogramm</a:t>
-            </a:r>
-          </a:p>
-          <a:p>
-            <a:pPr marL="457200" indent="-457200">
-              <a:lnSpc>
-                <a:spcPct val="100000"/>
-              </a:lnSpc>
-              <a:buFont typeface="+mj-lt"/>
-              <a:buAutoNum type="arabicPeriod"/>
-            </a:pPr>
-            <a:r>
-              <a:rPr lang="de-DE" sz="2800" dirty="0"/>
-              <a:t>Toben Sie sich aus mit den Farben! (</a:t>
-            </a:r>
-            <a:r>
-              <a:rPr lang="de-DE" sz="2800" dirty="0" err="1"/>
-              <a:t>colors</a:t>
-            </a:r>
-            <a:r>
-              <a:rPr lang="de-DE" sz="2800" dirty="0"/>
-              <a:t>() für einen Überblick)</a:t>
-            </a:r>
-          </a:p>
-          <a:p>
-            <a:pPr marL="457200" indent="-457200">
-              <a:lnSpc>
-                <a:spcPct val="100000"/>
-              </a:lnSpc>
-              <a:buFont typeface="+mj-lt"/>
-              <a:buAutoNum type="arabicPeriod"/>
-            </a:pPr>
-            <a:r>
-              <a:rPr lang="de-DE" sz="2800" dirty="0"/>
-              <a:t>Fügen Sie ebenfalls mit </a:t>
-            </a:r>
-            <a:r>
-              <a:rPr lang="de-DE" sz="2800" dirty="0" err="1"/>
-              <a:t>abline</a:t>
-            </a:r>
-            <a:r>
-              <a:rPr lang="de-DE" sz="2800" dirty="0"/>
-              <a:t>() horizontale Linien im Abstand von 50 dem Diagramm in der Farbe „grey90“ hinzu</a:t>
-            </a:r>
-          </a:p>
-          <a:p>
-            <a:pPr marL="457200" indent="-457200">
-              <a:lnSpc>
-                <a:spcPct val="100000"/>
-              </a:lnSpc>
-              <a:buFont typeface="+mj-lt"/>
-              <a:buAutoNum type="arabicPeriod"/>
-            </a:pPr>
-            <a:r>
-              <a:rPr lang="de-DE" sz="2800" dirty="0"/>
-              <a:t>Exportieren Sie das Histogramm als </a:t>
-            </a:r>
-            <a:r>
-              <a:rPr lang="de-DE" sz="2800" dirty="0" err="1"/>
-              <a:t>png</a:t>
-            </a:r>
-            <a:r>
-              <a:rPr lang="de-DE" sz="2800" dirty="0"/>
-              <a:t> Datei</a:t>
-            </a:r>
-          </a:p>
-          <a:p>
-            <a:pPr marL="457200" indent="-457200">
-              <a:buFont typeface="+mj-lt"/>
-              <a:buAutoNum type="arabicPeriod"/>
-            </a:pPr>
-            <a:endParaRPr lang="de-DE" dirty="0"/>
+              <a:rPr lang="de-DE" dirty="0"/>
+              <a:t>	</a:t>
+            </a:r>
+            <a:r>
+              <a:rPr lang="de-DE" sz="4800" b="1" dirty="0"/>
+              <a:t>Histogramm</a:t>
+            </a:r>
+            <a:endParaRPr lang="de-DE" b="1" dirty="0"/>
           </a:p>
         </p:txBody>
       </p:sp>
     </p:spTree>
     <p:extLst>
       <p:ext uri="{BB962C8B-B14F-4D97-AF65-F5344CB8AC3E}">
-        <p14:creationId xmlns:p14="http://schemas.microsoft.com/office/powerpoint/2010/main" val="437693465"/>
+        <p14:creationId xmlns:p14="http://schemas.microsoft.com/office/powerpoint/2010/main" val="1461480684"/>
       </p:ext>
     </p:extLst>
   </p:cSld>
@@ -14165,7 +14142,7 @@
           <p:cNvPr id="2" name="Titel 1">
             <a:extLst>
               <a:ext uri="{FF2B5EF4-FFF2-40B4-BE49-F238E27FC236}">
-                <a16:creationId xmlns:a16="http://schemas.microsoft.com/office/drawing/2014/main" id="{8BDD5EAD-7FF6-4D46-A636-A2300BFF8604}"/>
+                <a16:creationId xmlns:a16="http://schemas.microsoft.com/office/drawing/2014/main" id="{08E930B5-825A-4182-B473-4F834C777D77}"/>
               </a:ext>
             </a:extLst>
           </p:cNvPr>
@@ -14178,8 +14155,8 @@
         </p:nvSpPr>
         <p:spPr>
           <a:xfrm>
-            <a:off x="657224" y="499533"/>
-            <a:ext cx="10772775" cy="962444"/>
+            <a:off x="657606" y="564795"/>
+            <a:ext cx="10772775" cy="1030680"/>
           </a:xfrm>
         </p:spPr>
         <p:txBody>
@@ -14188,7 +14165,7 @@
           <a:p>
             <a:r>
               <a:rPr lang="de-DE" b="1" dirty="0"/>
-              <a:t>Übung Dichtediagramm</a:t>
+              <a:t>Übung Histogramm</a:t>
             </a:r>
           </a:p>
         </p:txBody>
@@ -14198,7 +14175,7 @@
           <p:cNvPr id="3" name="Inhaltsplatzhalter 2">
             <a:extLst>
               <a:ext uri="{FF2B5EF4-FFF2-40B4-BE49-F238E27FC236}">
-                <a16:creationId xmlns:a16="http://schemas.microsoft.com/office/drawing/2014/main" id="{EB53CCCD-2653-4D70-84E4-4FF62208D816}"/>
+                <a16:creationId xmlns:a16="http://schemas.microsoft.com/office/drawing/2014/main" id="{AEB01630-4D3C-4E88-AC29-25204C1F7989}"/>
               </a:ext>
             </a:extLst>
           </p:cNvPr>
@@ -14211,28 +14188,13 @@
         </p:nvSpPr>
         <p:spPr>
           <a:xfrm>
-            <a:off x="658553" y="1371600"/>
-            <a:ext cx="10753725" cy="4779335"/>
+            <a:off x="676656" y="1655380"/>
+            <a:ext cx="10753725" cy="4122486"/>
           </a:xfrm>
         </p:spPr>
         <p:txBody>
-          <a:bodyPr>
-            <a:normAutofit fontScale="92500"/>
-          </a:bodyPr>
+          <a:bodyPr/>
           <a:lstStyle/>
-          <a:p>
-            <a:pPr marL="457200" indent="-457200">
-              <a:lnSpc>
-                <a:spcPct val="150000"/>
-              </a:lnSpc>
-              <a:buFont typeface="+mj-lt"/>
-              <a:buAutoNum type="arabicPeriod"/>
-            </a:pPr>
-            <a:r>
-              <a:rPr lang="de-DE" sz="2800" dirty="0"/>
-              <a:t>Erstellen Sie ein Dichtediagramm mit dem BMI der männlichen Piraten</a:t>
-            </a:r>
-          </a:p>
           <a:p>
             <a:pPr marL="457200" indent="-457200">
               <a:lnSpc>
@@ -14243,15 +14205,7 @@
             </a:pPr>
             <a:r>
               <a:rPr lang="de-DE" sz="2800" dirty="0"/>
-              <a:t>Fügen Sie mit </a:t>
-            </a:r>
-            <a:r>
-              <a:rPr lang="de-DE" sz="2800" dirty="0" err="1"/>
-              <a:t>lines</a:t>
-            </a:r>
-            <a:r>
-              <a:rPr lang="de-DE" sz="2800" dirty="0"/>
-              <a:t>() eine Dichtekurve des BMI der weiblichen Piratinnen hinzu</a:t>
+              <a:t>Erstellen Sie ein Histogramm, das die Verteilung von BMI darstellt</a:t>
             </a:r>
           </a:p>
           <a:p>
@@ -14264,7 +14218,7 @@
             </a:pPr>
             <a:r>
               <a:rPr lang="de-DE" sz="2800" dirty="0"/>
-              <a:t>Passen Sie Farbe, Titel, Achsenbeschriftung und ggf. die Achsenlimitierung an</a:t>
+              <a:t>Fügen Sie einen Titel und Achsenbeschriftungen hinzu</a:t>
             </a:r>
           </a:p>
           <a:p>
@@ -14277,33 +14231,70 @@
             </a:pPr>
             <a:r>
               <a:rPr lang="de-DE" sz="2800" dirty="0"/>
-              <a:t>Zeichnen Sie die jeweiligen BMI Mittelwerte der Piratinnen und Piraten ein</a:t>
+              <a:t>Zeichnen Sie den Mittelwert von BMI mittels </a:t>
+            </a:r>
+            <a:r>
+              <a:rPr lang="de-DE" sz="2800" dirty="0" err="1"/>
+              <a:t>abline</a:t>
+            </a:r>
+            <a:r>
+              <a:rPr lang="de-DE" sz="2800" dirty="0"/>
+              <a:t>() ins Histogramm</a:t>
             </a:r>
           </a:p>
           <a:p>
             <a:pPr marL="457200" indent="-457200">
               <a:lnSpc>
-                <a:spcPct val="150000"/>
+                <a:spcPct val="100000"/>
               </a:lnSpc>
               <a:buFont typeface="+mj-lt"/>
               <a:buAutoNum type="arabicPeriod"/>
             </a:pPr>
             <a:r>
               <a:rPr lang="de-DE" sz="2800" dirty="0"/>
-              <a:t>Fügen Sie eine passende Legende hinzu</a:t>
+              <a:t>Toben Sie sich aus mit den Farben! (</a:t>
+            </a:r>
+            <a:r>
+              <a:rPr lang="de-DE" sz="2800" dirty="0" err="1"/>
+              <a:t>colors</a:t>
+            </a:r>
+            <a:r>
+              <a:rPr lang="de-DE" sz="2800" dirty="0"/>
+              <a:t>() für einen Überblick)</a:t>
             </a:r>
           </a:p>
           <a:p>
             <a:pPr marL="457200" indent="-457200">
               <a:lnSpc>
-                <a:spcPct val="150000"/>
+                <a:spcPct val="100000"/>
               </a:lnSpc>
               <a:buFont typeface="+mj-lt"/>
               <a:buAutoNum type="arabicPeriod"/>
             </a:pPr>
             <a:r>
               <a:rPr lang="de-DE" sz="2800" dirty="0"/>
-              <a:t>Exportieren Sie den Plot als </a:t>
+              <a:t>Fügen Sie ebenfalls mit </a:t>
+            </a:r>
+            <a:r>
+              <a:rPr lang="de-DE" sz="2800" dirty="0" err="1"/>
+              <a:t>abline</a:t>
+            </a:r>
+            <a:r>
+              <a:rPr lang="de-DE" sz="2800" dirty="0"/>
+              <a:t>() horizontale Linien im Abstand von 50 dem Diagramm in der Farbe „grey90“ hinzu</a:t>
+            </a:r>
+          </a:p>
+          <a:p>
+            <a:pPr marL="457200" indent="-457200">
+              <a:lnSpc>
+                <a:spcPct val="100000"/>
+              </a:lnSpc>
+              <a:buFont typeface="+mj-lt"/>
+              <a:buAutoNum type="arabicPeriod"/>
+            </a:pPr>
+            <a:r>
+              <a:rPr lang="de-DE" sz="2800" dirty="0"/>
+              <a:t>Exportieren Sie das Histogramm als </a:t>
             </a:r>
             <a:r>
               <a:rPr lang="de-DE" sz="2800" dirty="0" err="1"/>
@@ -14313,13 +14304,20 @@
               <a:rPr lang="de-DE" sz="2800" dirty="0"/>
               <a:t> Datei</a:t>
             </a:r>
+          </a:p>
+          <a:p>
+            <a:pPr marL="457200" indent="-457200">
+              <a:buFont typeface="+mj-lt"/>
+              <a:buAutoNum type="arabicPeriod"/>
+            </a:pPr>
+            <a:endParaRPr lang="de-DE" dirty="0"/>
           </a:p>
         </p:txBody>
       </p:sp>
     </p:spTree>
     <p:extLst>
       <p:ext uri="{BB962C8B-B14F-4D97-AF65-F5344CB8AC3E}">
-        <p14:creationId xmlns:p14="http://schemas.microsoft.com/office/powerpoint/2010/main" val="629477332"/>
+        <p14:creationId xmlns:p14="http://schemas.microsoft.com/office/powerpoint/2010/main" val="437693465"/>
       </p:ext>
     </p:extLst>
   </p:cSld>
@@ -14346,12 +14344,48 @@
           <a:chExt cx="0" cy="0"/>
         </a:xfrm>
       </p:grpSpPr>
+      <p:pic>
+        <p:nvPicPr>
+          <p:cNvPr id="5" name="Grafik 4">
+            <a:extLst>
+              <a:ext uri="{FF2B5EF4-FFF2-40B4-BE49-F238E27FC236}">
+                <a16:creationId xmlns:a16="http://schemas.microsoft.com/office/drawing/2014/main" id="{64C29E4C-DF96-45CB-AC70-3A99245DFBA7}"/>
+              </a:ext>
+            </a:extLst>
+          </p:cNvPr>
+          <p:cNvPicPr>
+            <a:picLocks noChangeAspect="1"/>
+          </p:cNvPicPr>
+          <p:nvPr/>
+        </p:nvPicPr>
+        <p:blipFill>
+          <a:blip r:embed="rId2">
+            <a:extLst>
+              <a:ext uri="{28A0092B-C50C-407E-A947-70E740481C1C}">
+                <a14:useLocalDpi xmlns:a14="http://schemas.microsoft.com/office/drawing/2010/main" val="0"/>
+              </a:ext>
+            </a:extLst>
+          </a:blip>
+          <a:stretch>
+            <a:fillRect/>
+          </a:stretch>
+        </p:blipFill>
+        <p:spPr>
+          <a:xfrm>
+            <a:off x="2574428" y="1028452"/>
+            <a:ext cx="7620660" cy="5715495"/>
+          </a:xfrm>
+          <a:prstGeom prst="rect">
+            <a:avLst/>
+          </a:prstGeom>
+        </p:spPr>
+      </p:pic>
       <p:sp>
         <p:nvSpPr>
           <p:cNvPr id="2" name="Titel 1">
             <a:extLst>
               <a:ext uri="{FF2B5EF4-FFF2-40B4-BE49-F238E27FC236}">
-                <a16:creationId xmlns:a16="http://schemas.microsoft.com/office/drawing/2014/main" id="{496F125F-4F09-4130-9999-82212092E56A}"/>
+                <a16:creationId xmlns:a16="http://schemas.microsoft.com/office/drawing/2014/main" id="{892C11D6-9B8E-4848-8D84-ACD9F14EC6D1}"/>
               </a:ext>
             </a:extLst>
           </p:cNvPr>
@@ -14364,41 +14398,8 @@
         </p:nvSpPr>
         <p:spPr>
           <a:xfrm>
-            <a:off x="657224" y="499533"/>
-            <a:ext cx="10772775" cy="978393"/>
-          </a:xfrm>
-        </p:spPr>
-        <p:txBody>
-          <a:bodyPr/>
-          <a:lstStyle/>
-          <a:p>
-            <a:r>
-              <a:rPr lang="de-DE" b="1" dirty="0"/>
-              <a:t>Übung Boxplot</a:t>
-            </a:r>
-          </a:p>
-        </p:txBody>
-      </p:sp>
-      <p:sp>
-        <p:nvSpPr>
-          <p:cNvPr id="3" name="Inhaltsplatzhalter 2">
-            <a:extLst>
-              <a:ext uri="{FF2B5EF4-FFF2-40B4-BE49-F238E27FC236}">
-                <a16:creationId xmlns:a16="http://schemas.microsoft.com/office/drawing/2014/main" id="{6E9C5726-98EE-4E55-ACF4-D2405C5D031F}"/>
-              </a:ext>
-            </a:extLst>
-          </p:cNvPr>
-          <p:cNvSpPr>
-            <a:spLocks noGrp="1"/>
-          </p:cNvSpPr>
-          <p:nvPr>
-            <p:ph idx="1"/>
-          </p:nvPr>
-        </p:nvSpPr>
-        <p:spPr>
-          <a:xfrm>
-            <a:off x="676656" y="1584252"/>
-            <a:ext cx="10753725" cy="4193614"/>
+            <a:off x="585035" y="274944"/>
+            <a:ext cx="10772775" cy="944256"/>
           </a:xfrm>
         </p:spPr>
         <p:txBody>
@@ -14407,63 +14408,9 @@
           </a:bodyPr>
           <a:lstStyle/>
           <a:p>
-            <a:pPr marL="457200" indent="-457200">
-              <a:lnSpc>
-                <a:spcPct val="150000"/>
-              </a:lnSpc>
-              <a:buFont typeface="+mj-lt"/>
-              <a:buAutoNum type="arabicPeriod"/>
-            </a:pPr>
-            <a:r>
-              <a:rPr lang="de-DE" sz="2800" dirty="0"/>
-              <a:t>Lesen Sie den MM.txt Datensatz ein</a:t>
-            </a:r>
-          </a:p>
-          <a:p>
-            <a:pPr marL="457200" indent="-457200">
-              <a:lnSpc>
-                <a:spcPct val="150000"/>
-              </a:lnSpc>
-              <a:buFont typeface="+mj-lt"/>
-              <a:buAutoNum type="arabicPeriod"/>
-            </a:pPr>
-            <a:r>
-              <a:rPr lang="de-DE" sz="2800" dirty="0"/>
-              <a:t>Erstellen Sie einen Boxplot der ausschließlich die Verteilung der M&amp;Ms nach Farbe darstellt. Passen Sie eventuell das </a:t>
-            </a:r>
-            <a:r>
-              <a:rPr lang="de-DE" sz="2800" i="1" dirty="0" err="1"/>
-              <a:t>outline</a:t>
-            </a:r>
-            <a:r>
-              <a:rPr lang="de-DE" sz="2800" dirty="0"/>
-              <a:t> Argument an</a:t>
-            </a:r>
-          </a:p>
-          <a:p>
-            <a:pPr marL="457200" indent="-457200">
-              <a:lnSpc>
-                <a:spcPct val="150000"/>
-              </a:lnSpc>
-              <a:buFont typeface="+mj-lt"/>
-              <a:buAutoNum type="arabicPeriod"/>
-            </a:pPr>
-            <a:r>
-              <a:rPr lang="de-DE" sz="2800" dirty="0"/>
-              <a:t>Färben Sie die Boxen entsprechend der M&amp;M Farben an</a:t>
-            </a:r>
-          </a:p>
-          <a:p>
-            <a:pPr marL="457200" indent="-457200">
-              <a:lnSpc>
-                <a:spcPct val="150000"/>
-              </a:lnSpc>
-              <a:buFont typeface="+mj-lt"/>
-              <a:buAutoNum type="arabicPeriod"/>
-            </a:pPr>
-            <a:r>
-              <a:rPr lang="de-DE" sz="2800" dirty="0"/>
-              <a:t>Exportieren Sie die Grafik</a:t>
+            <a:r>
+              <a:rPr lang="de-DE" sz="4800" b="1" dirty="0"/>
+              <a:t>Dichtediagramm</a:t>
             </a:r>
           </a:p>
         </p:txBody>
@@ -14471,7 +14418,7 @@
     </p:spTree>
     <p:extLst>
       <p:ext uri="{BB962C8B-B14F-4D97-AF65-F5344CB8AC3E}">
-        <p14:creationId xmlns:p14="http://schemas.microsoft.com/office/powerpoint/2010/main" val="4016134650"/>
+        <p14:creationId xmlns:p14="http://schemas.microsoft.com/office/powerpoint/2010/main" val="995368222"/>
       </p:ext>
     </p:extLst>
   </p:cSld>
@@ -14503,7 +14450,7 @@
           <p:cNvPr id="2" name="Titel 1">
             <a:extLst>
               <a:ext uri="{FF2B5EF4-FFF2-40B4-BE49-F238E27FC236}">
-                <a16:creationId xmlns:a16="http://schemas.microsoft.com/office/drawing/2014/main" id="{BAB2BF70-F744-49F7-ABC6-4C7ADFFDAE05}"/>
+                <a16:creationId xmlns:a16="http://schemas.microsoft.com/office/drawing/2014/main" id="{8BDD5EAD-7FF6-4D46-A636-A2300BFF8604}"/>
               </a:ext>
             </a:extLst>
           </p:cNvPr>
@@ -14517,7 +14464,7 @@
         <p:spPr>
           <a:xfrm>
             <a:off x="657224" y="499533"/>
-            <a:ext cx="10772775" cy="994341"/>
+            <a:ext cx="10772775" cy="962444"/>
           </a:xfrm>
         </p:spPr>
         <p:txBody>
@@ -14526,13 +14473,8 @@
           <a:p>
             <a:r>
               <a:rPr lang="de-DE" b="1" dirty="0"/>
-              <a:t>Übung </a:t>
-            </a:r>
-            <a:r>
-              <a:rPr lang="de-DE" b="1" dirty="0" err="1"/>
-              <a:t>Barplot</a:t>
-            </a:r>
-            <a:endParaRPr lang="de-DE" b="1" dirty="0"/>
+              <a:t>Übung Dichtediagramm</a:t>
+            </a:r>
           </a:p>
         </p:txBody>
       </p:sp>
@@ -14541,7 +14483,7 @@
           <p:cNvPr id="3" name="Inhaltsplatzhalter 2">
             <a:extLst>
               <a:ext uri="{FF2B5EF4-FFF2-40B4-BE49-F238E27FC236}">
-                <a16:creationId xmlns:a16="http://schemas.microsoft.com/office/drawing/2014/main" id="{A75420BA-BAEC-4AB1-87D8-BF813BC3BFA7}"/>
+                <a16:creationId xmlns:a16="http://schemas.microsoft.com/office/drawing/2014/main" id="{EB53CCCD-2653-4D70-84E4-4FF62208D816}"/>
               </a:ext>
             </a:extLst>
           </p:cNvPr>
@@ -14554,13 +14496,13 @@
         </p:nvSpPr>
         <p:spPr>
           <a:xfrm>
-            <a:off x="676656" y="1642730"/>
-            <a:ext cx="10753725" cy="4864396"/>
+            <a:off x="658553" y="1371600"/>
+            <a:ext cx="10753725" cy="4779335"/>
           </a:xfrm>
         </p:spPr>
         <p:txBody>
           <a:bodyPr>
-            <a:normAutofit/>
+            <a:normAutofit fontScale="92500"/>
           </a:bodyPr>
           <a:lstStyle/>
           <a:p>
@@ -14572,8 +14514,8 @@
               <a:buAutoNum type="arabicPeriod"/>
             </a:pPr>
             <a:r>
-              <a:rPr lang="de-DE" dirty="0"/>
-              <a:t>Lesen Sie den MM.txt Datensatz ein</a:t>
+              <a:rPr lang="de-DE" sz="2800" dirty="0"/>
+              <a:t>Erstellen Sie ein Dichtediagramm mit dem BMI der männlichen Piraten</a:t>
             </a:r>
           </a:p>
           <a:p>
@@ -14585,29 +14527,16 @@
               <a:buAutoNum type="arabicPeriod"/>
             </a:pPr>
             <a:r>
-              <a:rPr lang="de-DE" dirty="0"/>
-              <a:t>Erstellen Sie einen </a:t>
-            </a:r>
-            <a:r>
-              <a:rPr lang="de-DE" dirty="0" err="1"/>
-              <a:t>Barplot</a:t>
-            </a:r>
-            <a:r>
-              <a:rPr lang="de-DE" dirty="0"/>
-              <a:t> der die Gesamtzahl M&amp;Ms pro Farbe zeigt. (Tipp: Finden Sie im Vorfeld eine geeignete Funktion, die die Summe pro Spalte berechnet)</a:t>
-            </a:r>
-          </a:p>
-          <a:p>
-            <a:pPr marL="457200" indent="-457200">
-              <a:lnSpc>
-                <a:spcPct val="110000"/>
-              </a:lnSpc>
-              <a:buFont typeface="+mj-lt"/>
-              <a:buAutoNum type="arabicPeriod"/>
-            </a:pPr>
-            <a:r>
-              <a:rPr lang="de-DE" dirty="0"/>
-              <a:t>Passen Sie gegebenenfalls die Ränder des Plot-Fensters und drehen Sie ggf. die Achsenbeschriftung um 90°</a:t>
+              <a:rPr lang="de-DE" sz="2800" dirty="0"/>
+              <a:t>Fügen Sie mit </a:t>
+            </a:r>
+            <a:r>
+              <a:rPr lang="de-DE" sz="2800" dirty="0" err="1"/>
+              <a:t>lines</a:t>
+            </a:r>
+            <a:r>
+              <a:rPr lang="de-DE" sz="2800" dirty="0"/>
+              <a:t>() eine Dichtekurve des BMI der weiblichen Piratinnen hinzu</a:t>
             </a:r>
           </a:p>
           <a:p>
@@ -14619,8 +14548,21 @@
               <a:buAutoNum type="arabicPeriod"/>
             </a:pPr>
             <a:r>
-              <a:rPr lang="de-DE" dirty="0"/>
-              <a:t>Färben Sie die Balken entsprechend der M&amp;M Farbe ein und fügen Sie einen Titel hinzu</a:t>
+              <a:rPr lang="de-DE" sz="2800" dirty="0"/>
+              <a:t>Passen Sie Farbe, Titel, Achsenbeschriftung und ggf. die Achsenlimitierung an</a:t>
+            </a:r>
+          </a:p>
+          <a:p>
+            <a:pPr marL="457200" indent="-457200">
+              <a:lnSpc>
+                <a:spcPct val="100000"/>
+              </a:lnSpc>
+              <a:buFont typeface="+mj-lt"/>
+              <a:buAutoNum type="arabicPeriod"/>
+            </a:pPr>
+            <a:r>
+              <a:rPr lang="de-DE" sz="2800" dirty="0"/>
+              <a:t>Zeichnen Sie die jeweiligen BMI Mittelwerte der Piratinnen und Piraten ein</a:t>
             </a:r>
           </a:p>
           <a:p>
@@ -14632,31 +14574,37 @@
               <a:buAutoNum type="arabicPeriod"/>
             </a:pPr>
             <a:r>
-              <a:rPr lang="de-DE" dirty="0"/>
-              <a:t>Exportieren Sie die Grafik als </a:t>
-            </a:r>
-            <a:r>
-              <a:rPr lang="de-DE" dirty="0" err="1"/>
-              <a:t>png</a:t>
-            </a:r>
-            <a:r>
-              <a:rPr lang="de-DE" dirty="0"/>
-              <a:t> Datei</a:t>
+              <a:rPr lang="de-DE" sz="2800" dirty="0"/>
+              <a:t>Fügen Sie eine passende Legende hinzu</a:t>
             </a:r>
           </a:p>
           <a:p>
             <a:pPr marL="457200" indent="-457200">
+              <a:lnSpc>
+                <a:spcPct val="150000"/>
+              </a:lnSpc>
               <a:buFont typeface="+mj-lt"/>
               <a:buAutoNum type="arabicPeriod"/>
             </a:pPr>
-            <a:endParaRPr lang="de-DE" dirty="0"/>
+            <a:r>
+              <a:rPr lang="de-DE" sz="2800" dirty="0"/>
+              <a:t>Exportieren Sie den Plot als </a:t>
+            </a:r>
+            <a:r>
+              <a:rPr lang="de-DE" sz="2800" dirty="0" err="1"/>
+              <a:t>png</a:t>
+            </a:r>
+            <a:r>
+              <a:rPr lang="de-DE" sz="2800" dirty="0"/>
+              <a:t> Datei</a:t>
+            </a:r>
           </a:p>
         </p:txBody>
       </p:sp>
     </p:spTree>
     <p:extLst>
       <p:ext uri="{BB962C8B-B14F-4D97-AF65-F5344CB8AC3E}">
-        <p14:creationId xmlns:p14="http://schemas.microsoft.com/office/powerpoint/2010/main" val="2249418622"/>
+        <p14:creationId xmlns:p14="http://schemas.microsoft.com/office/powerpoint/2010/main" val="629477332"/>
       </p:ext>
     </p:extLst>
   </p:cSld>
@@ -14683,12 +14631,48 @@
           <a:chExt cx="0" cy="0"/>
         </a:xfrm>
       </p:grpSpPr>
+      <p:pic>
+        <p:nvPicPr>
+          <p:cNvPr id="5" name="Grafik 4">
+            <a:extLst>
+              <a:ext uri="{FF2B5EF4-FFF2-40B4-BE49-F238E27FC236}">
+                <a16:creationId xmlns:a16="http://schemas.microsoft.com/office/drawing/2014/main" id="{0AD64A4A-5C90-4930-8255-E53117240286}"/>
+              </a:ext>
+            </a:extLst>
+          </p:cNvPr>
+          <p:cNvPicPr>
+            <a:picLocks noChangeAspect="1"/>
+          </p:cNvPicPr>
+          <p:nvPr/>
+        </p:nvPicPr>
+        <p:blipFill>
+          <a:blip r:embed="rId2">
+            <a:extLst>
+              <a:ext uri="{28A0092B-C50C-407E-A947-70E740481C1C}">
+                <a14:useLocalDpi xmlns:a14="http://schemas.microsoft.com/office/drawing/2010/main" val="0"/>
+              </a:ext>
+            </a:extLst>
+          </a:blip>
+          <a:stretch>
+            <a:fillRect/>
+          </a:stretch>
+        </p:blipFill>
+        <p:spPr>
+          <a:xfrm>
+            <a:off x="2285670" y="571252"/>
+            <a:ext cx="7620660" cy="5715495"/>
+          </a:xfrm>
+          <a:prstGeom prst="rect">
+            <a:avLst/>
+          </a:prstGeom>
+        </p:spPr>
+      </p:pic>
       <p:sp>
         <p:nvSpPr>
           <p:cNvPr id="2" name="Titel 1">
             <a:extLst>
               <a:ext uri="{FF2B5EF4-FFF2-40B4-BE49-F238E27FC236}">
-                <a16:creationId xmlns:a16="http://schemas.microsoft.com/office/drawing/2014/main" id="{EBA5FD4C-F113-468D-929C-88B36AADE3F9}"/>
+                <a16:creationId xmlns:a16="http://schemas.microsoft.com/office/drawing/2014/main" id="{D70E82E2-0BEF-4CAB-823E-FB1BBD77F4D9}"/>
               </a:ext>
             </a:extLst>
           </p:cNvPr>
@@ -14701,148 +14685,19 @@
         </p:nvSpPr>
         <p:spPr>
           <a:xfrm>
-            <a:off x="676656" y="122078"/>
-            <a:ext cx="10772775" cy="1105983"/>
+            <a:off x="657224" y="499533"/>
+            <a:ext cx="10772775" cy="982426"/>
           </a:xfrm>
         </p:spPr>
         <p:txBody>
-          <a:bodyPr/>
-          <a:lstStyle/>
-          <a:p>
-            <a:r>
-              <a:rPr lang="de-DE" b="1" dirty="0"/>
-              <a:t>Übung Scatterplot</a:t>
-            </a:r>
-          </a:p>
-        </p:txBody>
-      </p:sp>
-      <p:sp>
-        <p:nvSpPr>
-          <p:cNvPr id="3" name="Inhaltsplatzhalter 2">
-            <a:extLst>
-              <a:ext uri="{FF2B5EF4-FFF2-40B4-BE49-F238E27FC236}">
-                <a16:creationId xmlns:a16="http://schemas.microsoft.com/office/drawing/2014/main" id="{BB1AE5D9-AA34-4D6A-B607-A97AF39B932D}"/>
-              </a:ext>
-            </a:extLst>
-          </p:cNvPr>
-          <p:cNvSpPr>
-            <a:spLocks noGrp="1"/>
-          </p:cNvSpPr>
-          <p:nvPr>
-            <p:ph idx="1"/>
-          </p:nvPr>
-        </p:nvSpPr>
-        <p:spPr>
-          <a:xfrm>
-            <a:off x="676656" y="1164266"/>
-            <a:ext cx="10981944" cy="5427920"/>
-          </a:xfrm>
-        </p:spPr>
-        <p:txBody>
           <a:bodyPr>
-            <a:normAutofit fontScale="85000" lnSpcReduction="20000"/>
+            <a:normAutofit/>
           </a:bodyPr>
           <a:lstStyle/>
           <a:p>
-            <a:pPr marL="457200" indent="-457200">
-              <a:lnSpc>
-                <a:spcPct val="120000"/>
-              </a:lnSpc>
-              <a:buFont typeface="+mj-lt"/>
-              <a:buAutoNum type="arabicPeriod"/>
-            </a:pPr>
-            <a:r>
-              <a:rPr lang="de-DE" sz="2800" dirty="0"/>
-              <a:t>Fügen Sie dem M&amp;M Datensatz eine Spalte hinzu in der die Gesamtanzahl M&amp;Ms pro Tüte gespeichert ist (Tipp: Es gibt eine Funktion die Summen pro Zeilen berechnet)</a:t>
-            </a:r>
-          </a:p>
-          <a:p>
-            <a:pPr marL="457200" indent="-457200">
-              <a:lnSpc>
-                <a:spcPct val="120000"/>
-              </a:lnSpc>
-              <a:buFont typeface="+mj-lt"/>
-              <a:buAutoNum type="arabicPeriod"/>
-            </a:pPr>
-            <a:r>
-              <a:rPr lang="de-DE" sz="2800" dirty="0"/>
-              <a:t>Erstellen Sie einen Scatterplot bei dem das Gewicht der Tüte im Verhältnis zu der Gesamtanzahl M&amp;Ms dargestellt ist</a:t>
-            </a:r>
-          </a:p>
-          <a:p>
-            <a:pPr marL="457200" indent="-457200">
-              <a:lnSpc>
-                <a:spcPct val="150000"/>
-              </a:lnSpc>
-              <a:buFont typeface="+mj-lt"/>
-              <a:buAutoNum type="arabicPeriod"/>
-            </a:pPr>
-            <a:r>
-              <a:rPr lang="de-DE" sz="2800" dirty="0"/>
-              <a:t>Passen Sie Titel, Achsenbeschriftung und ggf. das Punkt-Symbol an</a:t>
-            </a:r>
-          </a:p>
-          <a:p>
-            <a:pPr marL="457200" indent="-457200">
-              <a:lnSpc>
-                <a:spcPct val="150000"/>
-              </a:lnSpc>
-              <a:buFont typeface="+mj-lt"/>
-              <a:buAutoNum type="arabicPeriod"/>
-            </a:pPr>
-            <a:r>
-              <a:rPr lang="de-DE" sz="2800" dirty="0"/>
-              <a:t>Fügen Sie eine Trendlinie mittels </a:t>
-            </a:r>
-            <a:r>
-              <a:rPr lang="de-DE" sz="2800" dirty="0" err="1"/>
-              <a:t>line</a:t>
-            </a:r>
-            <a:r>
-              <a:rPr lang="de-DE" sz="2800" dirty="0"/>
-              <a:t>() und </a:t>
-            </a:r>
-            <a:r>
-              <a:rPr lang="de-DE" sz="2800" dirty="0" err="1"/>
-              <a:t>smooth.spline</a:t>
-            </a:r>
-            <a:r>
-              <a:rPr lang="de-DE" sz="2800" dirty="0"/>
-              <a:t>() hinzu</a:t>
-            </a:r>
-          </a:p>
-          <a:p>
-            <a:pPr marL="457200" indent="-457200">
-              <a:lnSpc>
-                <a:spcPct val="150000"/>
-              </a:lnSpc>
-              <a:buFont typeface="+mj-lt"/>
-              <a:buAutoNum type="arabicPeriod"/>
-            </a:pPr>
-            <a:r>
-              <a:rPr lang="de-DE" sz="2800" dirty="0"/>
-              <a:t>Berechnen Sie den Korrelationskoeffizienten nach Spearman und fügen Sie das Ergebnis dem Plot mittels </a:t>
-            </a:r>
-            <a:r>
-              <a:rPr lang="de-DE" sz="2800" dirty="0" err="1"/>
-              <a:t>text</a:t>
-            </a:r>
-            <a:r>
-              <a:rPr lang="de-DE" sz="2800" dirty="0"/>
-              <a:t>() hinzu</a:t>
-            </a:r>
-          </a:p>
-          <a:p>
-            <a:pPr marL="457200" indent="-457200">
-              <a:lnSpc>
-                <a:spcPct val="150000"/>
-              </a:lnSpc>
-              <a:buFont typeface="+mj-lt"/>
-              <a:buAutoNum type="arabicPeriod"/>
-            </a:pPr>
-            <a:r>
-              <a:rPr lang="de-DE" sz="2800" dirty="0"/>
-              <a:t>Exportieren Sie die Grafik</a:t>
+            <a:r>
+              <a:rPr lang="de-DE" sz="4800" b="1" dirty="0"/>
+              <a:t>Boxplot</a:t>
             </a:r>
           </a:p>
         </p:txBody>
@@ -14850,7 +14705,7 @@
     </p:spTree>
     <p:extLst>
       <p:ext uri="{BB962C8B-B14F-4D97-AF65-F5344CB8AC3E}">
-        <p14:creationId xmlns:p14="http://schemas.microsoft.com/office/powerpoint/2010/main" val="4079362406"/>
+        <p14:creationId xmlns:p14="http://schemas.microsoft.com/office/powerpoint/2010/main" val="3456039895"/>
       </p:ext>
     </p:extLst>
   </p:cSld>
@@ -14862,81 +14717,6 @@
 
 <file path=ppt/slides/slide37.xml><?xml version="1.0" encoding="utf-8"?>
 <p:sld xmlns:a="http://schemas.openxmlformats.org/drawingml/2006/main" xmlns:r="http://schemas.openxmlformats.org/officeDocument/2006/relationships" xmlns:p="http://schemas.openxmlformats.org/presentationml/2006/main">
-  <p:cSld>
-    <p:bg>
-      <p:bgPr>
-        <a:solidFill>
-          <a:srgbClr val="4F81BD"/>
-        </a:solidFill>
-        <a:effectLst/>
-      </p:bgPr>
-    </p:bg>
-    <p:spTree>
-      <p:nvGrpSpPr>
-        <p:cNvPr id="1" name=""/>
-        <p:cNvGrpSpPr/>
-        <p:nvPr/>
-      </p:nvGrpSpPr>
-      <p:grpSpPr>
-        <a:xfrm>
-          <a:off x="0" y="0"/>
-          <a:ext cx="0" cy="0"/>
-          <a:chOff x="0" y="0"/>
-          <a:chExt cx="0" cy="0"/>
-        </a:xfrm>
-      </p:grpSpPr>
-      <p:sp>
-        <p:nvSpPr>
-          <p:cNvPr id="2" name="Titel 1">
-            <a:extLst>
-              <a:ext uri="{FF2B5EF4-FFF2-40B4-BE49-F238E27FC236}">
-                <a16:creationId xmlns:a16="http://schemas.microsoft.com/office/drawing/2014/main" id="{CEB57258-F287-4CBC-8412-C532B261731D}"/>
-              </a:ext>
-            </a:extLst>
-          </p:cNvPr>
-          <p:cNvSpPr>
-            <a:spLocks noGrp="1"/>
-          </p:cNvSpPr>
-          <p:nvPr>
-            <p:ph type="title"/>
-          </p:nvPr>
-        </p:nvSpPr>
-        <p:spPr>
-          <a:xfrm>
-            <a:off x="853167" y="2021356"/>
-            <a:ext cx="10772775" cy="1658198"/>
-          </a:xfrm>
-        </p:spPr>
-        <p:txBody>
-          <a:bodyPr/>
-          <a:lstStyle/>
-          <a:p>
-            <a:r>
-              <a:rPr lang="de-DE" b="1" dirty="0">
-                <a:solidFill>
-                  <a:schemeClr val="bg1"/>
-                </a:solidFill>
-              </a:rPr>
-              <a:t>Automatisierungen</a:t>
-            </a:r>
-          </a:p>
-        </p:txBody>
-      </p:sp>
-    </p:spTree>
-    <p:extLst>
-      <p:ext uri="{BB962C8B-B14F-4D97-AF65-F5344CB8AC3E}">
-        <p14:creationId xmlns:p14="http://schemas.microsoft.com/office/powerpoint/2010/main" val="1072907355"/>
-      </p:ext>
-    </p:extLst>
-  </p:cSld>
-  <p:clrMapOvr>
-    <a:masterClrMapping/>
-  </p:clrMapOvr>
-</p:sld>
-</file>
-
-<file path=ppt/slides/slide38.xml><?xml version="1.0" encoding="utf-8"?>
-<p:sld xmlns:a="http://schemas.openxmlformats.org/drawingml/2006/main" xmlns:r="http://schemas.openxmlformats.org/officeDocument/2006/relationships" xmlns:p="http://schemas.openxmlformats.org/presentationml/2006/main" show="0">
   <p:cSld>
     <p:spTree>
       <p:nvGrpSpPr>
@@ -14957,7 +14737,7 @@
           <p:cNvPr id="2" name="Titel 1">
             <a:extLst>
               <a:ext uri="{FF2B5EF4-FFF2-40B4-BE49-F238E27FC236}">
-                <a16:creationId xmlns:a16="http://schemas.microsoft.com/office/drawing/2014/main" id="{450BB82A-4A36-4F92-B3E6-CAC5D2A9A249}"/>
+                <a16:creationId xmlns:a16="http://schemas.microsoft.com/office/drawing/2014/main" id="{496F125F-4F09-4130-9999-82212092E56A}"/>
               </a:ext>
             </a:extLst>
           </p:cNvPr>
@@ -14970,8 +14750,8 @@
         </p:nvSpPr>
         <p:spPr>
           <a:xfrm>
-            <a:off x="540266" y="297514"/>
-            <a:ext cx="10772775" cy="840169"/>
+            <a:off x="657224" y="499533"/>
+            <a:ext cx="10772775" cy="978393"/>
           </a:xfrm>
         </p:spPr>
         <p:txBody>
@@ -14979,8 +14759,8 @@
           <a:lstStyle/>
           <a:p>
             <a:r>
-              <a:rPr lang="de-DE" dirty="0"/>
-              <a:t>Übung Fibonacci Folge</a:t>
+              <a:rPr lang="de-DE" b="1" dirty="0"/>
+              <a:t>Übung Boxplot</a:t>
             </a:r>
           </a:p>
         </p:txBody>
@@ -14990,7 +14770,7 @@
           <p:cNvPr id="3" name="Inhaltsplatzhalter 2">
             <a:extLst>
               <a:ext uri="{FF2B5EF4-FFF2-40B4-BE49-F238E27FC236}">
-                <a16:creationId xmlns:a16="http://schemas.microsoft.com/office/drawing/2014/main" id="{3FB7BE5A-ECE7-4725-87E2-9FA5BBB1BC69}"/>
+                <a16:creationId xmlns:a16="http://schemas.microsoft.com/office/drawing/2014/main" id="{6E9C5726-98EE-4E55-ACF4-D2405C5D031F}"/>
               </a:ext>
             </a:extLst>
           </p:cNvPr>
@@ -15003,8 +14783,8 @@
         </p:nvSpPr>
         <p:spPr>
           <a:xfrm>
-            <a:off x="676656" y="1190848"/>
-            <a:ext cx="10753725" cy="5241850"/>
+            <a:off x="676656" y="1584252"/>
+            <a:ext cx="10753725" cy="4193614"/>
           </a:xfrm>
         </p:spPr>
         <p:txBody>
@@ -15012,27 +14792,6 @@
             <a:normAutofit/>
           </a:bodyPr>
           <a:lstStyle/>
-          <a:p>
-            <a:pPr marL="457200" indent="-457200">
-              <a:lnSpc>
-                <a:spcPct val="100000"/>
-              </a:lnSpc>
-              <a:buFont typeface="+mj-lt"/>
-              <a:buAutoNum type="arabicPeriod"/>
-            </a:pPr>
-            <a:r>
-              <a:rPr lang="de-DE" sz="2800" dirty="0"/>
-              <a:t>Schreiben Sie eine </a:t>
-            </a:r>
-            <a:r>
-              <a:rPr lang="de-DE" sz="2800" dirty="0" err="1"/>
-              <a:t>while</a:t>
-            </a:r>
-            <a:r>
-              <a:rPr lang="de-DE" sz="2800" dirty="0"/>
-              <a:t>-Schleife die die Fibonacci Folge berechnet bis die neue Zahl größer ist als 100</a:t>
-            </a:r>
-          </a:p>
           <a:p>
             <a:pPr marL="457200" indent="-457200">
               <a:lnSpc>
@@ -15043,41 +14802,7 @@
             </a:pPr>
             <a:r>
               <a:rPr lang="de-DE" sz="2800" dirty="0"/>
-              <a:t>Wie groß ist die neue Zahl?</a:t>
-            </a:r>
-          </a:p>
-          <a:p>
-            <a:pPr marL="457200" indent="-457200">
-              <a:lnSpc>
-                <a:spcPct val="110000"/>
-              </a:lnSpc>
-              <a:buFont typeface="+mj-lt"/>
-              <a:buAutoNum type="arabicPeriod"/>
-            </a:pPr>
-            <a:r>
-              <a:rPr lang="de-DE" sz="2800" dirty="0"/>
-              <a:t>Wie viele Iterationen braucht die Folge bis die neue Zahl größer ist als 100?</a:t>
-            </a:r>
-          </a:p>
-          <a:p>
-            <a:pPr marL="457200" indent="-457200">
-              <a:lnSpc>
-                <a:spcPct val="110000"/>
-              </a:lnSpc>
-              <a:buFont typeface="+mj-lt"/>
-              <a:buAutoNum type="arabicPeriod"/>
-            </a:pPr>
-            <a:r>
-              <a:rPr lang="de-DE" sz="2800" dirty="0"/>
-              <a:t>Schreiben Sie die Fibonacci Folge nun als </a:t>
-            </a:r>
-            <a:r>
-              <a:rPr lang="de-DE" sz="2800" dirty="0" err="1"/>
-              <a:t>for</a:t>
-            </a:r>
-            <a:r>
-              <a:rPr lang="de-DE" sz="2800" dirty="0"/>
-              <a:t>-Schleife die 100 mal über die Folge iteriert</a:t>
+              <a:t>Lesen Sie den MM.txt Datensatz ein</a:t>
             </a:r>
           </a:p>
           <a:p>
@@ -15090,7 +14815,41 @@
             </a:pPr>
             <a:r>
               <a:rPr lang="de-DE" sz="2800" dirty="0"/>
-              <a:t>Wie groß ist die neue Zahl nach 100 Iterationen</a:t>
+              <a:t>Erstellen Sie einen Boxplot der ausschließlich die Verteilung der M&amp;Ms nach Farbe darstellt. Passen Sie eventuell das </a:t>
+            </a:r>
+            <a:r>
+              <a:rPr lang="de-DE" sz="2800" i="1" dirty="0" err="1"/>
+              <a:t>outline</a:t>
+            </a:r>
+            <a:r>
+              <a:rPr lang="de-DE" sz="2800" dirty="0"/>
+              <a:t> Argument an</a:t>
+            </a:r>
+          </a:p>
+          <a:p>
+            <a:pPr marL="457200" indent="-457200">
+              <a:lnSpc>
+                <a:spcPct val="150000"/>
+              </a:lnSpc>
+              <a:buFont typeface="+mj-lt"/>
+              <a:buAutoNum type="arabicPeriod"/>
+            </a:pPr>
+            <a:r>
+              <a:rPr lang="de-DE" sz="2800" dirty="0"/>
+              <a:t>Färben Sie die Boxen entsprechend der M&amp;M Farben an</a:t>
+            </a:r>
+          </a:p>
+          <a:p>
+            <a:pPr marL="457200" indent="-457200">
+              <a:lnSpc>
+                <a:spcPct val="150000"/>
+              </a:lnSpc>
+              <a:buFont typeface="+mj-lt"/>
+              <a:buAutoNum type="arabicPeriod"/>
+            </a:pPr>
+            <a:r>
+              <a:rPr lang="de-DE" sz="2800" dirty="0"/>
+              <a:t>Exportieren Sie die Grafik</a:t>
             </a:r>
           </a:p>
         </p:txBody>
@@ -15098,7 +14857,107 @@
     </p:spTree>
     <p:extLst>
       <p:ext uri="{BB962C8B-B14F-4D97-AF65-F5344CB8AC3E}">
-        <p14:creationId xmlns:p14="http://schemas.microsoft.com/office/powerpoint/2010/main" val="3530125378"/>
+        <p14:creationId xmlns:p14="http://schemas.microsoft.com/office/powerpoint/2010/main" val="4016134650"/>
+      </p:ext>
+    </p:extLst>
+  </p:cSld>
+  <p:clrMapOvr>
+    <a:masterClrMapping/>
+  </p:clrMapOvr>
+</p:sld>
+</file>
+
+<file path=ppt/slides/slide38.xml><?xml version="1.0" encoding="utf-8"?>
+<p:sld xmlns:a="http://schemas.openxmlformats.org/drawingml/2006/main" xmlns:r="http://schemas.openxmlformats.org/officeDocument/2006/relationships" xmlns:p="http://schemas.openxmlformats.org/presentationml/2006/main">
+  <p:cSld>
+    <p:spTree>
+      <p:nvGrpSpPr>
+        <p:cNvPr id="1" name=""/>
+        <p:cNvGrpSpPr/>
+        <p:nvPr/>
+      </p:nvGrpSpPr>
+      <p:grpSpPr>
+        <a:xfrm>
+          <a:off x="0" y="0"/>
+          <a:ext cx="0" cy="0"/>
+          <a:chOff x="0" y="0"/>
+          <a:chExt cx="0" cy="0"/>
+        </a:xfrm>
+      </p:grpSpPr>
+      <p:pic>
+        <p:nvPicPr>
+          <p:cNvPr id="5" name="Grafik 4">
+            <a:extLst>
+              <a:ext uri="{FF2B5EF4-FFF2-40B4-BE49-F238E27FC236}">
+                <a16:creationId xmlns:a16="http://schemas.microsoft.com/office/drawing/2014/main" id="{DAE17A41-8A66-4EB1-8EAC-C8426703FDE4}"/>
+              </a:ext>
+            </a:extLst>
+          </p:cNvPr>
+          <p:cNvPicPr>
+            <a:picLocks noChangeAspect="1"/>
+          </p:cNvPicPr>
+          <p:nvPr/>
+        </p:nvPicPr>
+        <p:blipFill>
+          <a:blip r:embed="rId2">
+            <a:extLst>
+              <a:ext uri="{28A0092B-C50C-407E-A947-70E740481C1C}">
+                <a14:useLocalDpi xmlns:a14="http://schemas.microsoft.com/office/drawing/2010/main" val="0"/>
+              </a:ext>
+            </a:extLst>
+          </a:blip>
+          <a:stretch>
+            <a:fillRect/>
+          </a:stretch>
+        </p:blipFill>
+        <p:spPr>
+          <a:xfrm>
+            <a:off x="2608863" y="571252"/>
+            <a:ext cx="7620660" cy="5715495"/>
+          </a:xfrm>
+          <a:prstGeom prst="rect">
+            <a:avLst/>
+          </a:prstGeom>
+        </p:spPr>
+      </p:pic>
+      <p:sp>
+        <p:nvSpPr>
+          <p:cNvPr id="2" name="Titel 1">
+            <a:extLst>
+              <a:ext uri="{FF2B5EF4-FFF2-40B4-BE49-F238E27FC236}">
+                <a16:creationId xmlns:a16="http://schemas.microsoft.com/office/drawing/2014/main" id="{649618F6-334B-4AE1-8F5F-D25BF90BBD6E}"/>
+              </a:ext>
+            </a:extLst>
+          </p:cNvPr>
+          <p:cNvSpPr>
+            <a:spLocks noGrp="1"/>
+          </p:cNvSpPr>
+          <p:nvPr>
+            <p:ph type="title"/>
+          </p:nvPr>
+        </p:nvSpPr>
+        <p:spPr>
+          <a:xfrm>
+            <a:off x="389210" y="316522"/>
+            <a:ext cx="10772775" cy="887833"/>
+          </a:xfrm>
+        </p:spPr>
+        <p:txBody>
+          <a:bodyPr/>
+          <a:lstStyle/>
+          <a:p>
+            <a:r>
+              <a:rPr lang="de-DE" sz="4800" b="1" dirty="0"/>
+              <a:t>Balkendiagramm</a:t>
+            </a:r>
+            <a:endParaRPr lang="de-DE" b="1" dirty="0"/>
+          </a:p>
+        </p:txBody>
+      </p:sp>
+    </p:spTree>
+    <p:extLst>
+      <p:ext uri="{BB962C8B-B14F-4D97-AF65-F5344CB8AC3E}">
+        <p14:creationId xmlns:p14="http://schemas.microsoft.com/office/powerpoint/2010/main" val="1159621067"/>
       </p:ext>
     </p:extLst>
   </p:cSld>
@@ -15130,7 +14989,7 @@
           <p:cNvPr id="2" name="Titel 1">
             <a:extLst>
               <a:ext uri="{FF2B5EF4-FFF2-40B4-BE49-F238E27FC236}">
-                <a16:creationId xmlns:a16="http://schemas.microsoft.com/office/drawing/2014/main" id="{C4237B4F-0744-4883-AAB0-293CC3A7ED88}"/>
+                <a16:creationId xmlns:a16="http://schemas.microsoft.com/office/drawing/2014/main" id="{BAB2BF70-F744-49F7-ABC6-4C7ADFFDAE05}"/>
               </a:ext>
             </a:extLst>
           </p:cNvPr>
@@ -15144,7 +15003,7 @@
         <p:spPr>
           <a:xfrm>
             <a:off x="657224" y="499533"/>
-            <a:ext cx="10772775" cy="861434"/>
+            <a:ext cx="10772775" cy="994341"/>
           </a:xfrm>
         </p:spPr>
         <p:txBody>
@@ -15152,14 +15011,9 @@
           <a:lstStyle/>
           <a:p>
             <a:r>
-              <a:rPr lang="de-DE" dirty="0"/>
-              <a:t>Übung Schleife mit </a:t>
-            </a:r>
-            <a:r>
-              <a:rPr lang="de-DE" dirty="0" err="1"/>
-              <a:t>if-else</a:t>
-            </a:r>
-            <a:endParaRPr lang="de-DE" dirty="0"/>
+              <a:rPr lang="de-DE" b="1" dirty="0"/>
+              <a:t>Übung Balkendiagramm</a:t>
+            </a:r>
           </a:p>
         </p:txBody>
       </p:sp>
@@ -15168,7 +15022,7 @@
           <p:cNvPr id="3" name="Inhaltsplatzhalter 2">
             <a:extLst>
               <a:ext uri="{FF2B5EF4-FFF2-40B4-BE49-F238E27FC236}">
-                <a16:creationId xmlns:a16="http://schemas.microsoft.com/office/drawing/2014/main" id="{EBC88ED8-5F13-4AFE-AD62-F1AE70FA6DE0}"/>
+                <a16:creationId xmlns:a16="http://schemas.microsoft.com/office/drawing/2014/main" id="{A75420BA-BAEC-4AB1-87D8-BF813BC3BFA7}"/>
               </a:ext>
             </a:extLst>
           </p:cNvPr>
@@ -15181,13 +15035,13 @@
         </p:nvSpPr>
         <p:spPr>
           <a:xfrm>
-            <a:off x="676656" y="1440712"/>
-            <a:ext cx="10997893" cy="5002618"/>
+            <a:off x="676656" y="1642730"/>
+            <a:ext cx="10753725" cy="4864396"/>
           </a:xfrm>
         </p:spPr>
         <p:txBody>
           <a:bodyPr>
-            <a:normAutofit fontScale="92500" lnSpcReduction="20000"/>
+            <a:normAutofit/>
           </a:bodyPr>
           <a:lstStyle/>
           <a:p>
@@ -15199,78 +15053,91 @@
               <a:buAutoNum type="arabicPeriod"/>
             </a:pPr>
             <a:r>
-              <a:rPr lang="de-DE" sz="2800" dirty="0"/>
-              <a:t>Berechnen Sie die ersten 100 Stellen einer Folge mit den folgenden Eigenschaften:</a:t>
-            </a:r>
-          </a:p>
-          <a:p>
-            <a:pPr marL="713232" lvl="1" indent="-457200">
+              <a:rPr lang="de-DE" dirty="0"/>
+              <a:t>Lesen Sie den MM.txt Datensatz ein</a:t>
+            </a:r>
+          </a:p>
+          <a:p>
+            <a:pPr marL="457200" indent="-457200">
+              <a:lnSpc>
+                <a:spcPct val="100000"/>
+              </a:lnSpc>
+              <a:buFont typeface="+mj-lt"/>
+              <a:buAutoNum type="arabicPeriod"/>
+            </a:pPr>
+            <a:r>
+              <a:rPr lang="de-DE" dirty="0"/>
+              <a:t>Erstellen Sie einen </a:t>
+            </a:r>
+            <a:r>
+              <a:rPr lang="de-DE" dirty="0" err="1"/>
+              <a:t>Barplot</a:t>
+            </a:r>
+            <a:r>
+              <a:rPr lang="de-DE" dirty="0"/>
+              <a:t> der die Gesamtzahl M&amp;Ms pro Farbe zeigt. (Tipp: Finden Sie im Vorfeld eine geeignete Funktion, die die Summe pro Spalte berechnet)</a:t>
+            </a:r>
+          </a:p>
+          <a:p>
+            <a:pPr marL="457200" indent="-457200">
+              <a:lnSpc>
+                <a:spcPct val="110000"/>
+              </a:lnSpc>
+              <a:buFont typeface="+mj-lt"/>
+              <a:buAutoNum type="arabicPeriod"/>
+            </a:pPr>
+            <a:r>
+              <a:rPr lang="de-DE" dirty="0"/>
+              <a:t>Passen Sie gegebenenfalls die Ränder des Plot-Fensters und drehen Sie ggf. die Achsenbeschriftung um 90°</a:t>
+            </a:r>
+          </a:p>
+          <a:p>
+            <a:pPr marL="457200" indent="-457200">
+              <a:lnSpc>
+                <a:spcPct val="100000"/>
+              </a:lnSpc>
+              <a:buFont typeface="+mj-lt"/>
+              <a:buAutoNum type="arabicPeriod"/>
+            </a:pPr>
+            <a:r>
+              <a:rPr lang="de-DE" dirty="0"/>
+              <a:t>Färben Sie die Balken entsprechend der M&amp;M Farbe ein und fügen Sie einen Titel hinzu</a:t>
+            </a:r>
+          </a:p>
+          <a:p>
+            <a:pPr marL="457200" indent="-457200">
               <a:lnSpc>
                 <a:spcPct val="150000"/>
               </a:lnSpc>
-              <a:buFont typeface="Arial" panose="020B0604020202020204" pitchFamily="34" charset="0"/>
-              <a:buChar char="•"/>
+              <a:buFont typeface="+mj-lt"/>
+              <a:buAutoNum type="arabicPeriod"/>
             </a:pPr>
             <a:r>
-              <a:rPr lang="de-DE" sz="2800" dirty="0"/>
-              <a:t>Sie startet mit dem Wert 3</a:t>
-            </a:r>
-          </a:p>
-          <a:p>
-            <a:pPr marL="713232" lvl="1" indent="-457200">
-              <a:lnSpc>
-                <a:spcPct val="120000"/>
-              </a:lnSpc>
-              <a:buFont typeface="Arial" panose="020B0604020202020204" pitchFamily="34" charset="0"/>
-              <a:buChar char="•"/>
+              <a:rPr lang="de-DE" dirty="0"/>
+              <a:t>Exportieren Sie die Grafik als </a:t>
+            </a:r>
+            <a:r>
+              <a:rPr lang="de-DE" dirty="0" err="1"/>
+              <a:t>png</a:t>
+            </a:r>
+            <a:r>
+              <a:rPr lang="de-DE" dirty="0"/>
+              <a:t> Datei</a:t>
+            </a:r>
+          </a:p>
+          <a:p>
+            <a:pPr marL="457200" indent="-457200">
+              <a:buFont typeface="+mj-lt"/>
+              <a:buAutoNum type="arabicPeriod"/>
             </a:pPr>
-            <a:r>
-              <a:rPr lang="de-DE" sz="2800" dirty="0"/>
-              <a:t>Bei der Berechnung der nächsten Zahl soll geprüft werden ob die vorherige Zahl teilbar durch 3 ist. </a:t>
-            </a:r>
-          </a:p>
-          <a:p>
-            <a:pPr marL="256032" lvl="1" indent="0">
-              <a:lnSpc>
-                <a:spcPct val="120000"/>
-              </a:lnSpc>
-              <a:buNone/>
-            </a:pPr>
-            <a:r>
-              <a:rPr lang="de-DE" sz="2800" dirty="0"/>
-              <a:t>	-&gt; Wenn ja, dann soll der nächste Wert berechnet werden aus dem 			vorherigen Wert + 7</a:t>
-            </a:r>
-          </a:p>
-          <a:p>
-            <a:pPr marL="256032" lvl="1" indent="0">
-              <a:lnSpc>
-                <a:spcPct val="120000"/>
-              </a:lnSpc>
-              <a:buNone/>
-            </a:pPr>
-            <a:r>
-              <a:rPr lang="de-DE" sz="2800" dirty="0"/>
-              <a:t>	-&gt; ansonsten soll der nächste Wert berechnet werden aus dem vorherigen 		Wert – 2</a:t>
-            </a:r>
-          </a:p>
-          <a:p>
-            <a:pPr marL="256032" lvl="1" indent="0">
-              <a:lnSpc>
-                <a:spcPct val="150000"/>
-              </a:lnSpc>
-              <a:buNone/>
-            </a:pPr>
-            <a:r>
-              <a:rPr lang="de-DE" sz="2800" dirty="0"/>
-              <a:t>2. Stellen Sie die Folge grafisch dar </a:t>
-            </a:r>
+            <a:endParaRPr lang="de-DE" dirty="0"/>
           </a:p>
         </p:txBody>
       </p:sp>
     </p:spTree>
     <p:extLst>
       <p:ext uri="{BB962C8B-B14F-4D97-AF65-F5344CB8AC3E}">
-        <p14:creationId xmlns:p14="http://schemas.microsoft.com/office/powerpoint/2010/main" val="3529331888"/>
+        <p14:creationId xmlns:p14="http://schemas.microsoft.com/office/powerpoint/2010/main" val="2249418622"/>
       </p:ext>
     </p:extLst>
   </p:cSld>
@@ -15417,6 +15284,720 @@
           <a:chExt cx="0" cy="0"/>
         </a:xfrm>
       </p:grpSpPr>
+      <p:pic>
+        <p:nvPicPr>
+          <p:cNvPr id="5" name="Grafik 4">
+            <a:extLst>
+              <a:ext uri="{FF2B5EF4-FFF2-40B4-BE49-F238E27FC236}">
+                <a16:creationId xmlns:a16="http://schemas.microsoft.com/office/drawing/2014/main" id="{1174C6F6-39D5-4AA2-9E2E-FDC207031AFF}"/>
+              </a:ext>
+            </a:extLst>
+          </p:cNvPr>
+          <p:cNvPicPr>
+            <a:picLocks noChangeAspect="1"/>
+          </p:cNvPicPr>
+          <p:nvPr/>
+        </p:nvPicPr>
+        <p:blipFill>
+          <a:blip r:embed="rId2">
+            <a:extLst>
+              <a:ext uri="{28A0092B-C50C-407E-A947-70E740481C1C}">
+                <a14:useLocalDpi xmlns:a14="http://schemas.microsoft.com/office/drawing/2010/main" val="0"/>
+              </a:ext>
+            </a:extLst>
+          </a:blip>
+          <a:stretch>
+            <a:fillRect/>
+          </a:stretch>
+        </p:blipFill>
+        <p:spPr>
+          <a:xfrm>
+            <a:off x="2285670" y="1014394"/>
+            <a:ext cx="7620660" cy="5715495"/>
+          </a:xfrm>
+          <a:prstGeom prst="rect">
+            <a:avLst/>
+          </a:prstGeom>
+        </p:spPr>
+      </p:pic>
+      <p:sp>
+        <p:nvSpPr>
+          <p:cNvPr id="2" name="Titel 1">
+            <a:extLst>
+              <a:ext uri="{FF2B5EF4-FFF2-40B4-BE49-F238E27FC236}">
+                <a16:creationId xmlns:a16="http://schemas.microsoft.com/office/drawing/2014/main" id="{875FB25E-E7A2-47B4-B54E-C22BBAC52828}"/>
+              </a:ext>
+            </a:extLst>
+          </p:cNvPr>
+          <p:cNvSpPr>
+            <a:spLocks noGrp="1"/>
+          </p:cNvSpPr>
+          <p:nvPr>
+            <p:ph type="title"/>
+          </p:nvPr>
+        </p:nvSpPr>
+        <p:spPr>
+          <a:xfrm>
+            <a:off x="657224" y="499533"/>
+            <a:ext cx="10772775" cy="1029722"/>
+          </a:xfrm>
+        </p:spPr>
+        <p:txBody>
+          <a:bodyPr/>
+          <a:lstStyle/>
+          <a:p>
+            <a:r>
+              <a:rPr lang="de-DE" sz="4800" b="1" dirty="0"/>
+              <a:t>Scatterplot</a:t>
+            </a:r>
+            <a:endParaRPr lang="de-DE" b="1" dirty="0"/>
+          </a:p>
+        </p:txBody>
+      </p:sp>
+    </p:spTree>
+    <p:extLst>
+      <p:ext uri="{BB962C8B-B14F-4D97-AF65-F5344CB8AC3E}">
+        <p14:creationId xmlns:p14="http://schemas.microsoft.com/office/powerpoint/2010/main" val="2538640724"/>
+      </p:ext>
+    </p:extLst>
+  </p:cSld>
+  <p:clrMapOvr>
+    <a:masterClrMapping/>
+  </p:clrMapOvr>
+</p:sld>
+</file>
+
+<file path=ppt/slides/slide41.xml><?xml version="1.0" encoding="utf-8"?>
+<p:sld xmlns:a="http://schemas.openxmlformats.org/drawingml/2006/main" xmlns:r="http://schemas.openxmlformats.org/officeDocument/2006/relationships" xmlns:p="http://schemas.openxmlformats.org/presentationml/2006/main">
+  <p:cSld>
+    <p:spTree>
+      <p:nvGrpSpPr>
+        <p:cNvPr id="1" name=""/>
+        <p:cNvGrpSpPr/>
+        <p:nvPr/>
+      </p:nvGrpSpPr>
+      <p:grpSpPr>
+        <a:xfrm>
+          <a:off x="0" y="0"/>
+          <a:ext cx="0" cy="0"/>
+          <a:chOff x="0" y="0"/>
+          <a:chExt cx="0" cy="0"/>
+        </a:xfrm>
+      </p:grpSpPr>
+      <p:sp>
+        <p:nvSpPr>
+          <p:cNvPr id="2" name="Titel 1">
+            <a:extLst>
+              <a:ext uri="{FF2B5EF4-FFF2-40B4-BE49-F238E27FC236}">
+                <a16:creationId xmlns:a16="http://schemas.microsoft.com/office/drawing/2014/main" id="{EBA5FD4C-F113-468D-929C-88B36AADE3F9}"/>
+              </a:ext>
+            </a:extLst>
+          </p:cNvPr>
+          <p:cNvSpPr>
+            <a:spLocks noGrp="1"/>
+          </p:cNvSpPr>
+          <p:nvPr>
+            <p:ph type="title"/>
+          </p:nvPr>
+        </p:nvSpPr>
+        <p:spPr>
+          <a:xfrm>
+            <a:off x="676656" y="122078"/>
+            <a:ext cx="10772775" cy="1105983"/>
+          </a:xfrm>
+        </p:spPr>
+        <p:txBody>
+          <a:bodyPr/>
+          <a:lstStyle/>
+          <a:p>
+            <a:r>
+              <a:rPr lang="de-DE" b="1" dirty="0"/>
+              <a:t>Übung Scatterplot</a:t>
+            </a:r>
+          </a:p>
+        </p:txBody>
+      </p:sp>
+      <p:sp>
+        <p:nvSpPr>
+          <p:cNvPr id="3" name="Inhaltsplatzhalter 2">
+            <a:extLst>
+              <a:ext uri="{FF2B5EF4-FFF2-40B4-BE49-F238E27FC236}">
+                <a16:creationId xmlns:a16="http://schemas.microsoft.com/office/drawing/2014/main" id="{BB1AE5D9-AA34-4D6A-B607-A97AF39B932D}"/>
+              </a:ext>
+            </a:extLst>
+          </p:cNvPr>
+          <p:cNvSpPr>
+            <a:spLocks noGrp="1"/>
+          </p:cNvSpPr>
+          <p:nvPr>
+            <p:ph idx="1"/>
+          </p:nvPr>
+        </p:nvSpPr>
+        <p:spPr>
+          <a:xfrm>
+            <a:off x="676656" y="1164266"/>
+            <a:ext cx="10981944" cy="5427920"/>
+          </a:xfrm>
+        </p:spPr>
+        <p:txBody>
+          <a:bodyPr>
+            <a:normAutofit fontScale="85000" lnSpcReduction="20000"/>
+          </a:bodyPr>
+          <a:lstStyle/>
+          <a:p>
+            <a:pPr marL="457200" indent="-457200">
+              <a:lnSpc>
+                <a:spcPct val="120000"/>
+              </a:lnSpc>
+              <a:buFont typeface="+mj-lt"/>
+              <a:buAutoNum type="arabicPeriod"/>
+            </a:pPr>
+            <a:r>
+              <a:rPr lang="de-DE" sz="2800" dirty="0"/>
+              <a:t>Fügen Sie dem M&amp;M Datensatz eine Spalte hinzu in der die Gesamtanzahl M&amp;Ms pro Tüte gespeichert ist (Tipp: Es gibt eine Funktion die Summen pro Zeilen berechnet)</a:t>
+            </a:r>
+          </a:p>
+          <a:p>
+            <a:pPr marL="457200" indent="-457200">
+              <a:lnSpc>
+                <a:spcPct val="120000"/>
+              </a:lnSpc>
+              <a:buFont typeface="+mj-lt"/>
+              <a:buAutoNum type="arabicPeriod"/>
+            </a:pPr>
+            <a:r>
+              <a:rPr lang="de-DE" sz="2800" dirty="0"/>
+              <a:t>Erstellen Sie einen Scatterplot bei dem das Gewicht der Tüte im Verhältnis zu der Gesamtanzahl M&amp;Ms dargestellt ist</a:t>
+            </a:r>
+          </a:p>
+          <a:p>
+            <a:pPr marL="457200" indent="-457200">
+              <a:lnSpc>
+                <a:spcPct val="150000"/>
+              </a:lnSpc>
+              <a:buFont typeface="+mj-lt"/>
+              <a:buAutoNum type="arabicPeriod"/>
+            </a:pPr>
+            <a:r>
+              <a:rPr lang="de-DE" sz="2800" dirty="0"/>
+              <a:t>Passen Sie Titel, Achsenbeschriftung und ggf. das Punkt-Symbol an</a:t>
+            </a:r>
+          </a:p>
+          <a:p>
+            <a:pPr marL="457200" indent="-457200">
+              <a:lnSpc>
+                <a:spcPct val="150000"/>
+              </a:lnSpc>
+              <a:buFont typeface="+mj-lt"/>
+              <a:buAutoNum type="arabicPeriod"/>
+            </a:pPr>
+            <a:r>
+              <a:rPr lang="de-DE" sz="2800" dirty="0"/>
+              <a:t>Fügen Sie eine Trendlinie mittels </a:t>
+            </a:r>
+            <a:r>
+              <a:rPr lang="de-DE" sz="2800" dirty="0" err="1"/>
+              <a:t>line</a:t>
+            </a:r>
+            <a:r>
+              <a:rPr lang="de-DE" sz="2800" dirty="0"/>
+              <a:t>() und </a:t>
+            </a:r>
+            <a:r>
+              <a:rPr lang="de-DE" sz="2800" dirty="0" err="1"/>
+              <a:t>smooth.spline</a:t>
+            </a:r>
+            <a:r>
+              <a:rPr lang="de-DE" sz="2800" dirty="0"/>
+              <a:t>() hinzu</a:t>
+            </a:r>
+          </a:p>
+          <a:p>
+            <a:pPr marL="457200" indent="-457200">
+              <a:lnSpc>
+                <a:spcPct val="150000"/>
+              </a:lnSpc>
+              <a:buFont typeface="+mj-lt"/>
+              <a:buAutoNum type="arabicPeriod"/>
+            </a:pPr>
+            <a:r>
+              <a:rPr lang="de-DE" sz="2800" dirty="0"/>
+              <a:t>Berechnen Sie den Korrelationskoeffizienten nach Spearman und fügen Sie das Ergebnis dem Plot mittels </a:t>
+            </a:r>
+            <a:r>
+              <a:rPr lang="de-DE" sz="2800" dirty="0" err="1"/>
+              <a:t>text</a:t>
+            </a:r>
+            <a:r>
+              <a:rPr lang="de-DE" sz="2800" dirty="0"/>
+              <a:t>() hinzu</a:t>
+            </a:r>
+          </a:p>
+          <a:p>
+            <a:pPr marL="457200" indent="-457200">
+              <a:lnSpc>
+                <a:spcPct val="150000"/>
+              </a:lnSpc>
+              <a:buFont typeface="+mj-lt"/>
+              <a:buAutoNum type="arabicPeriod"/>
+            </a:pPr>
+            <a:r>
+              <a:rPr lang="de-DE" sz="2800" dirty="0"/>
+              <a:t>Exportieren Sie die Grafik</a:t>
+            </a:r>
+          </a:p>
+        </p:txBody>
+      </p:sp>
+    </p:spTree>
+    <p:extLst>
+      <p:ext uri="{BB962C8B-B14F-4D97-AF65-F5344CB8AC3E}">
+        <p14:creationId xmlns:p14="http://schemas.microsoft.com/office/powerpoint/2010/main" val="4079362406"/>
+      </p:ext>
+    </p:extLst>
+  </p:cSld>
+  <p:clrMapOvr>
+    <a:masterClrMapping/>
+  </p:clrMapOvr>
+</p:sld>
+</file>
+
+<file path=ppt/slides/slide42.xml><?xml version="1.0" encoding="utf-8"?>
+<p:sld xmlns:a="http://schemas.openxmlformats.org/drawingml/2006/main" xmlns:r="http://schemas.openxmlformats.org/officeDocument/2006/relationships" xmlns:p="http://schemas.openxmlformats.org/presentationml/2006/main">
+  <p:cSld>
+    <p:bg>
+      <p:bgPr>
+        <a:solidFill>
+          <a:srgbClr val="4F81BD"/>
+        </a:solidFill>
+        <a:effectLst/>
+      </p:bgPr>
+    </p:bg>
+    <p:spTree>
+      <p:nvGrpSpPr>
+        <p:cNvPr id="1" name=""/>
+        <p:cNvGrpSpPr/>
+        <p:nvPr/>
+      </p:nvGrpSpPr>
+      <p:grpSpPr>
+        <a:xfrm>
+          <a:off x="0" y="0"/>
+          <a:ext cx="0" cy="0"/>
+          <a:chOff x="0" y="0"/>
+          <a:chExt cx="0" cy="0"/>
+        </a:xfrm>
+      </p:grpSpPr>
+      <p:sp>
+        <p:nvSpPr>
+          <p:cNvPr id="2" name="Titel 1">
+            <a:extLst>
+              <a:ext uri="{FF2B5EF4-FFF2-40B4-BE49-F238E27FC236}">
+                <a16:creationId xmlns:a16="http://schemas.microsoft.com/office/drawing/2014/main" id="{CEB57258-F287-4CBC-8412-C532B261731D}"/>
+              </a:ext>
+            </a:extLst>
+          </p:cNvPr>
+          <p:cNvSpPr>
+            <a:spLocks noGrp="1"/>
+          </p:cNvSpPr>
+          <p:nvPr>
+            <p:ph type="title"/>
+          </p:nvPr>
+        </p:nvSpPr>
+        <p:spPr>
+          <a:xfrm>
+            <a:off x="853167" y="2021356"/>
+            <a:ext cx="10772775" cy="1658198"/>
+          </a:xfrm>
+        </p:spPr>
+        <p:txBody>
+          <a:bodyPr/>
+          <a:lstStyle/>
+          <a:p>
+            <a:r>
+              <a:rPr lang="de-DE" b="1" dirty="0">
+                <a:solidFill>
+                  <a:schemeClr val="bg1"/>
+                </a:solidFill>
+              </a:rPr>
+              <a:t>Automatisierungen</a:t>
+            </a:r>
+          </a:p>
+        </p:txBody>
+      </p:sp>
+    </p:spTree>
+    <p:extLst>
+      <p:ext uri="{BB962C8B-B14F-4D97-AF65-F5344CB8AC3E}">
+        <p14:creationId xmlns:p14="http://schemas.microsoft.com/office/powerpoint/2010/main" val="1072907355"/>
+      </p:ext>
+    </p:extLst>
+  </p:cSld>
+  <p:clrMapOvr>
+    <a:masterClrMapping/>
+  </p:clrMapOvr>
+</p:sld>
+</file>
+
+<file path=ppt/slides/slide43.xml><?xml version="1.0" encoding="utf-8"?>
+<p:sld xmlns:a="http://schemas.openxmlformats.org/drawingml/2006/main" xmlns:r="http://schemas.openxmlformats.org/officeDocument/2006/relationships" xmlns:p="http://schemas.openxmlformats.org/presentationml/2006/main" show="0">
+  <p:cSld>
+    <p:spTree>
+      <p:nvGrpSpPr>
+        <p:cNvPr id="1" name=""/>
+        <p:cNvGrpSpPr/>
+        <p:nvPr/>
+      </p:nvGrpSpPr>
+      <p:grpSpPr>
+        <a:xfrm>
+          <a:off x="0" y="0"/>
+          <a:ext cx="0" cy="0"/>
+          <a:chOff x="0" y="0"/>
+          <a:chExt cx="0" cy="0"/>
+        </a:xfrm>
+      </p:grpSpPr>
+      <p:sp>
+        <p:nvSpPr>
+          <p:cNvPr id="2" name="Titel 1">
+            <a:extLst>
+              <a:ext uri="{FF2B5EF4-FFF2-40B4-BE49-F238E27FC236}">
+                <a16:creationId xmlns:a16="http://schemas.microsoft.com/office/drawing/2014/main" id="{450BB82A-4A36-4F92-B3E6-CAC5D2A9A249}"/>
+              </a:ext>
+            </a:extLst>
+          </p:cNvPr>
+          <p:cNvSpPr>
+            <a:spLocks noGrp="1"/>
+          </p:cNvSpPr>
+          <p:nvPr>
+            <p:ph type="title"/>
+          </p:nvPr>
+        </p:nvSpPr>
+        <p:spPr>
+          <a:xfrm>
+            <a:off x="540266" y="297514"/>
+            <a:ext cx="10772775" cy="840169"/>
+          </a:xfrm>
+        </p:spPr>
+        <p:txBody>
+          <a:bodyPr/>
+          <a:lstStyle/>
+          <a:p>
+            <a:r>
+              <a:rPr lang="de-DE" dirty="0"/>
+              <a:t>Übung Fibonacci Folge</a:t>
+            </a:r>
+          </a:p>
+        </p:txBody>
+      </p:sp>
+      <p:sp>
+        <p:nvSpPr>
+          <p:cNvPr id="3" name="Inhaltsplatzhalter 2">
+            <a:extLst>
+              <a:ext uri="{FF2B5EF4-FFF2-40B4-BE49-F238E27FC236}">
+                <a16:creationId xmlns:a16="http://schemas.microsoft.com/office/drawing/2014/main" id="{3FB7BE5A-ECE7-4725-87E2-9FA5BBB1BC69}"/>
+              </a:ext>
+            </a:extLst>
+          </p:cNvPr>
+          <p:cNvSpPr>
+            <a:spLocks noGrp="1"/>
+          </p:cNvSpPr>
+          <p:nvPr>
+            <p:ph idx="1"/>
+          </p:nvPr>
+        </p:nvSpPr>
+        <p:spPr>
+          <a:xfrm>
+            <a:off x="676656" y="1190848"/>
+            <a:ext cx="10753725" cy="5241850"/>
+          </a:xfrm>
+        </p:spPr>
+        <p:txBody>
+          <a:bodyPr>
+            <a:normAutofit/>
+          </a:bodyPr>
+          <a:lstStyle/>
+          <a:p>
+            <a:pPr marL="457200" indent="-457200">
+              <a:lnSpc>
+                <a:spcPct val="100000"/>
+              </a:lnSpc>
+              <a:buFont typeface="+mj-lt"/>
+              <a:buAutoNum type="arabicPeriod"/>
+            </a:pPr>
+            <a:r>
+              <a:rPr lang="de-DE" sz="2800" dirty="0"/>
+              <a:t>Schreiben Sie eine </a:t>
+            </a:r>
+            <a:r>
+              <a:rPr lang="de-DE" sz="2800" dirty="0" err="1"/>
+              <a:t>while</a:t>
+            </a:r>
+            <a:r>
+              <a:rPr lang="de-DE" sz="2800" dirty="0"/>
+              <a:t>-Schleife die die Fibonacci Folge berechnet bis die neue Zahl größer ist als 100</a:t>
+            </a:r>
+          </a:p>
+          <a:p>
+            <a:pPr marL="457200" indent="-457200">
+              <a:lnSpc>
+                <a:spcPct val="150000"/>
+              </a:lnSpc>
+              <a:buFont typeface="+mj-lt"/>
+              <a:buAutoNum type="arabicPeriod"/>
+            </a:pPr>
+            <a:r>
+              <a:rPr lang="de-DE" sz="2800" dirty="0"/>
+              <a:t>Wie groß ist die neue Zahl?</a:t>
+            </a:r>
+          </a:p>
+          <a:p>
+            <a:pPr marL="457200" indent="-457200">
+              <a:lnSpc>
+                <a:spcPct val="110000"/>
+              </a:lnSpc>
+              <a:buFont typeface="+mj-lt"/>
+              <a:buAutoNum type="arabicPeriod"/>
+            </a:pPr>
+            <a:r>
+              <a:rPr lang="de-DE" sz="2800" dirty="0"/>
+              <a:t>Wie viele Iterationen braucht die Folge bis die neue Zahl größer ist als 100?</a:t>
+            </a:r>
+          </a:p>
+          <a:p>
+            <a:pPr marL="457200" indent="-457200">
+              <a:lnSpc>
+                <a:spcPct val="110000"/>
+              </a:lnSpc>
+              <a:buFont typeface="+mj-lt"/>
+              <a:buAutoNum type="arabicPeriod"/>
+            </a:pPr>
+            <a:r>
+              <a:rPr lang="de-DE" sz="2800" dirty="0"/>
+              <a:t>Schreiben Sie die Fibonacci Folge nun als </a:t>
+            </a:r>
+            <a:r>
+              <a:rPr lang="de-DE" sz="2800" dirty="0" err="1"/>
+              <a:t>for</a:t>
+            </a:r>
+            <a:r>
+              <a:rPr lang="de-DE" sz="2800" dirty="0"/>
+              <a:t>-Schleife die 100 mal über die Folge iteriert</a:t>
+            </a:r>
+          </a:p>
+          <a:p>
+            <a:pPr marL="457200" indent="-457200">
+              <a:lnSpc>
+                <a:spcPct val="150000"/>
+              </a:lnSpc>
+              <a:buFont typeface="+mj-lt"/>
+              <a:buAutoNum type="arabicPeriod"/>
+            </a:pPr>
+            <a:r>
+              <a:rPr lang="de-DE" sz="2800" dirty="0"/>
+              <a:t>Wie groß ist die neue Zahl nach 100 Iterationen</a:t>
+            </a:r>
+          </a:p>
+        </p:txBody>
+      </p:sp>
+    </p:spTree>
+    <p:extLst>
+      <p:ext uri="{BB962C8B-B14F-4D97-AF65-F5344CB8AC3E}">
+        <p14:creationId xmlns:p14="http://schemas.microsoft.com/office/powerpoint/2010/main" val="3530125378"/>
+      </p:ext>
+    </p:extLst>
+  </p:cSld>
+  <p:clrMapOvr>
+    <a:masterClrMapping/>
+  </p:clrMapOvr>
+</p:sld>
+</file>
+
+<file path=ppt/slides/slide44.xml><?xml version="1.0" encoding="utf-8"?>
+<p:sld xmlns:a="http://schemas.openxmlformats.org/drawingml/2006/main" xmlns:r="http://schemas.openxmlformats.org/officeDocument/2006/relationships" xmlns:p="http://schemas.openxmlformats.org/presentationml/2006/main">
+  <p:cSld>
+    <p:spTree>
+      <p:nvGrpSpPr>
+        <p:cNvPr id="1" name=""/>
+        <p:cNvGrpSpPr/>
+        <p:nvPr/>
+      </p:nvGrpSpPr>
+      <p:grpSpPr>
+        <a:xfrm>
+          <a:off x="0" y="0"/>
+          <a:ext cx="0" cy="0"/>
+          <a:chOff x="0" y="0"/>
+          <a:chExt cx="0" cy="0"/>
+        </a:xfrm>
+      </p:grpSpPr>
+      <p:sp>
+        <p:nvSpPr>
+          <p:cNvPr id="2" name="Titel 1">
+            <a:extLst>
+              <a:ext uri="{FF2B5EF4-FFF2-40B4-BE49-F238E27FC236}">
+                <a16:creationId xmlns:a16="http://schemas.microsoft.com/office/drawing/2014/main" id="{C4237B4F-0744-4883-AAB0-293CC3A7ED88}"/>
+              </a:ext>
+            </a:extLst>
+          </p:cNvPr>
+          <p:cNvSpPr>
+            <a:spLocks noGrp="1"/>
+          </p:cNvSpPr>
+          <p:nvPr>
+            <p:ph type="title"/>
+          </p:nvPr>
+        </p:nvSpPr>
+        <p:spPr>
+          <a:xfrm>
+            <a:off x="657224" y="499533"/>
+            <a:ext cx="10772775" cy="861434"/>
+          </a:xfrm>
+        </p:spPr>
+        <p:txBody>
+          <a:bodyPr/>
+          <a:lstStyle/>
+          <a:p>
+            <a:r>
+              <a:rPr lang="de-DE" dirty="0"/>
+              <a:t>Übung Schleife mit </a:t>
+            </a:r>
+            <a:r>
+              <a:rPr lang="de-DE" dirty="0" err="1"/>
+              <a:t>if-else</a:t>
+            </a:r>
+            <a:endParaRPr lang="de-DE" dirty="0"/>
+          </a:p>
+        </p:txBody>
+      </p:sp>
+      <p:sp>
+        <p:nvSpPr>
+          <p:cNvPr id="3" name="Inhaltsplatzhalter 2">
+            <a:extLst>
+              <a:ext uri="{FF2B5EF4-FFF2-40B4-BE49-F238E27FC236}">
+                <a16:creationId xmlns:a16="http://schemas.microsoft.com/office/drawing/2014/main" id="{EBC88ED8-5F13-4AFE-AD62-F1AE70FA6DE0}"/>
+              </a:ext>
+            </a:extLst>
+          </p:cNvPr>
+          <p:cNvSpPr>
+            <a:spLocks noGrp="1"/>
+          </p:cNvSpPr>
+          <p:nvPr>
+            <p:ph idx="1"/>
+          </p:nvPr>
+        </p:nvSpPr>
+        <p:spPr>
+          <a:xfrm>
+            <a:off x="676656" y="1440712"/>
+            <a:ext cx="10997893" cy="5002618"/>
+          </a:xfrm>
+        </p:spPr>
+        <p:txBody>
+          <a:bodyPr>
+            <a:normAutofit fontScale="92500" lnSpcReduction="20000"/>
+          </a:bodyPr>
+          <a:lstStyle/>
+          <a:p>
+            <a:pPr marL="457200" indent="-457200">
+              <a:lnSpc>
+                <a:spcPct val="150000"/>
+              </a:lnSpc>
+              <a:buFont typeface="+mj-lt"/>
+              <a:buAutoNum type="arabicPeriod"/>
+            </a:pPr>
+            <a:r>
+              <a:rPr lang="de-DE" sz="2800" dirty="0"/>
+              <a:t>Berechnen Sie die ersten 100 Stellen einer Folge mit den folgenden Eigenschaften:</a:t>
+            </a:r>
+          </a:p>
+          <a:p>
+            <a:pPr marL="713232" lvl="1" indent="-457200">
+              <a:lnSpc>
+                <a:spcPct val="150000"/>
+              </a:lnSpc>
+              <a:buFont typeface="Arial" panose="020B0604020202020204" pitchFamily="34" charset="0"/>
+              <a:buChar char="•"/>
+            </a:pPr>
+            <a:r>
+              <a:rPr lang="de-DE" sz="2800" dirty="0"/>
+              <a:t>Sie startet mit dem Wert 3</a:t>
+            </a:r>
+          </a:p>
+          <a:p>
+            <a:pPr marL="713232" lvl="1" indent="-457200">
+              <a:lnSpc>
+                <a:spcPct val="120000"/>
+              </a:lnSpc>
+              <a:buFont typeface="Arial" panose="020B0604020202020204" pitchFamily="34" charset="0"/>
+              <a:buChar char="•"/>
+            </a:pPr>
+            <a:r>
+              <a:rPr lang="de-DE" sz="2800" dirty="0"/>
+              <a:t>Bei der Berechnung der nächsten Zahl soll geprüft werden ob die vorherige Zahl teilbar durch 3 ist. </a:t>
+            </a:r>
+          </a:p>
+          <a:p>
+            <a:pPr marL="256032" lvl="1" indent="0">
+              <a:lnSpc>
+                <a:spcPct val="120000"/>
+              </a:lnSpc>
+              <a:buNone/>
+            </a:pPr>
+            <a:r>
+              <a:rPr lang="de-DE" sz="2800" dirty="0"/>
+              <a:t>	-&gt; Wenn ja, dann soll der nächste Wert berechnet werden aus dem 			vorherigen Wert + 7</a:t>
+            </a:r>
+          </a:p>
+          <a:p>
+            <a:pPr marL="256032" lvl="1" indent="0">
+              <a:lnSpc>
+                <a:spcPct val="120000"/>
+              </a:lnSpc>
+              <a:buNone/>
+            </a:pPr>
+            <a:r>
+              <a:rPr lang="de-DE" sz="2800" dirty="0"/>
+              <a:t>	-&gt; ansonsten soll der nächste Wert berechnet werden aus dem vorherigen 		Wert – 2</a:t>
+            </a:r>
+          </a:p>
+          <a:p>
+            <a:pPr marL="256032" lvl="1" indent="0">
+              <a:lnSpc>
+                <a:spcPct val="150000"/>
+              </a:lnSpc>
+              <a:buNone/>
+            </a:pPr>
+            <a:r>
+              <a:rPr lang="de-DE" sz="2800" dirty="0"/>
+              <a:t>2. Stellen Sie die Folge grafisch dar </a:t>
+            </a:r>
+          </a:p>
+        </p:txBody>
+      </p:sp>
+    </p:spTree>
+    <p:extLst>
+      <p:ext uri="{BB962C8B-B14F-4D97-AF65-F5344CB8AC3E}">
+        <p14:creationId xmlns:p14="http://schemas.microsoft.com/office/powerpoint/2010/main" val="3529331888"/>
+      </p:ext>
+    </p:extLst>
+  </p:cSld>
+  <p:clrMapOvr>
+    <a:masterClrMapping/>
+  </p:clrMapOvr>
+</p:sld>
+</file>
+
+<file path=ppt/slides/slide45.xml><?xml version="1.0" encoding="utf-8"?>
+<p:sld xmlns:a="http://schemas.openxmlformats.org/drawingml/2006/main" xmlns:r="http://schemas.openxmlformats.org/officeDocument/2006/relationships" xmlns:p="http://schemas.openxmlformats.org/presentationml/2006/main">
+  <p:cSld>
+    <p:spTree>
+      <p:nvGrpSpPr>
+        <p:cNvPr id="1" name=""/>
+        <p:cNvGrpSpPr/>
+        <p:nvPr/>
+      </p:nvGrpSpPr>
+      <p:grpSpPr>
+        <a:xfrm>
+          <a:off x="0" y="0"/>
+          <a:ext cx="0" cy="0"/>
+          <a:chOff x="0" y="0"/>
+          <a:chExt cx="0" cy="0"/>
+        </a:xfrm>
+      </p:grpSpPr>
       <p:sp>
         <p:nvSpPr>
           <p:cNvPr id="2" name="Titel 1">
@@ -15572,7 +16153,7 @@
 </p:sld>
 </file>
 
-<file path=ppt/slides/slide41.xml><?xml version="1.0" encoding="utf-8"?>
+<file path=ppt/slides/slide46.xml><?xml version="1.0" encoding="utf-8"?>
 <p:sld xmlns:a="http://schemas.openxmlformats.org/drawingml/2006/main" xmlns:r="http://schemas.openxmlformats.org/officeDocument/2006/relationships" xmlns:p="http://schemas.openxmlformats.org/presentationml/2006/main">
   <p:cSld>
     <p:spTree>

</xml_diff>

<commit_message>
Konzept für Automatisierungen erstellt
</commit_message>
<xml_diff>
--- a/Präsentationen/Einführung in R.pptx
+++ b/Präsentationen/Einführung in R.pptx
@@ -47,10 +47,13 @@
     <p:sldId id="304" r:id="rId41"/>
     <p:sldId id="292" r:id="rId42"/>
     <p:sldId id="293" r:id="rId43"/>
-    <p:sldId id="294" r:id="rId44"/>
-    <p:sldId id="295" r:id="rId45"/>
-    <p:sldId id="296" r:id="rId46"/>
-    <p:sldId id="297" r:id="rId47"/>
+    <p:sldId id="305" r:id="rId44"/>
+    <p:sldId id="306" r:id="rId45"/>
+    <p:sldId id="307" r:id="rId46"/>
+    <p:sldId id="294" r:id="rId47"/>
+    <p:sldId id="295" r:id="rId48"/>
+    <p:sldId id="296" r:id="rId49"/>
+    <p:sldId id="297" r:id="rId50"/>
   </p:sldIdLst>
   <p:sldSz cx="12192000" cy="6858000"/>
   <p:notesSz cx="6858000" cy="9144000"/>
@@ -13984,12 +13987,14 @@
         </p:nvSpPr>
         <p:spPr>
           <a:xfrm>
-            <a:off x="853167" y="2021356"/>
+            <a:off x="882104" y="2414895"/>
             <a:ext cx="10772775" cy="1658198"/>
           </a:xfrm>
         </p:spPr>
         <p:txBody>
-          <a:bodyPr/>
+          <a:bodyPr>
+            <a:normAutofit fontScale="90000"/>
+          </a:bodyPr>
           <a:lstStyle/>
           <a:p>
             <a:r>
@@ -14000,6 +14005,33 @@
               </a:rPr>
               <a:t>Visualisierungen</a:t>
             </a:r>
+            <a:br>
+              <a:rPr lang="de-DE" b="1" dirty="0">
+                <a:solidFill>
+                  <a:schemeClr val="bg1"/>
+                </a:solidFill>
+              </a:rPr>
+            </a:br>
+            <a:br>
+              <a:rPr lang="de-DE" b="1" dirty="0">
+                <a:solidFill>
+                  <a:schemeClr val="bg1"/>
+                </a:solidFill>
+              </a:rPr>
+            </a:br>
+            <a:r>
+              <a:rPr lang="de-DE" sz="4000" b="1" dirty="0">
+                <a:solidFill>
+                  <a:schemeClr val="bg1"/>
+                </a:solidFill>
+              </a:rPr>
+              <a:t>Histogramm, Dichtediagramm, Boxplot, Balkendiagramm und Scatterplot</a:t>
+            </a:r>
+            <a:endParaRPr lang="de-DE" b="1" dirty="0">
+              <a:solidFill>
+                <a:schemeClr val="bg1"/>
+              </a:solidFill>
+            </a:endParaRPr>
           </a:p>
         </p:txBody>
       </p:sp>
@@ -14100,10 +14132,18 @@
               <a:t>	</a:t>
             </a:r>
             <a:r>
-              <a:rPr lang="de-DE" sz="4800" b="1" dirty="0"/>
+              <a:rPr lang="de-DE" sz="4800" b="1" dirty="0">
+                <a:solidFill>
+                  <a:srgbClr val="4F81BD"/>
+                </a:solidFill>
+              </a:rPr>
               <a:t>Histogramm</a:t>
             </a:r>
-            <a:endParaRPr lang="de-DE" b="1" dirty="0"/>
+            <a:endParaRPr lang="de-DE" b="1" dirty="0">
+              <a:solidFill>
+                <a:srgbClr val="4F81BD"/>
+              </a:solidFill>
+            </a:endParaRPr>
           </a:p>
         </p:txBody>
       </p:sp>
@@ -15604,12 +15644,14 @@
         </p:nvSpPr>
         <p:spPr>
           <a:xfrm>
-            <a:off x="853167" y="2021356"/>
+            <a:off x="876316" y="2443832"/>
             <a:ext cx="10772775" cy="1658198"/>
           </a:xfrm>
         </p:spPr>
         <p:txBody>
-          <a:bodyPr/>
+          <a:bodyPr>
+            <a:normAutofit fontScale="90000"/>
+          </a:bodyPr>
           <a:lstStyle/>
           <a:p>
             <a:r>
@@ -15620,6 +15662,49 @@
               </a:rPr>
               <a:t>Automatisierungen</a:t>
             </a:r>
+            <a:br>
+              <a:rPr lang="de-DE" b="1" dirty="0">
+                <a:solidFill>
+                  <a:schemeClr val="bg1"/>
+                </a:solidFill>
+              </a:rPr>
+            </a:br>
+            <a:br>
+              <a:rPr lang="de-DE" b="1" dirty="0">
+                <a:solidFill>
+                  <a:schemeClr val="bg1"/>
+                </a:solidFill>
+              </a:rPr>
+            </a:br>
+            <a:r>
+              <a:rPr lang="de-DE" sz="4000" b="1" dirty="0">
+                <a:solidFill>
+                  <a:schemeClr val="bg1"/>
+                </a:solidFill>
+              </a:rPr>
+              <a:t>Eigene Funktionen, </a:t>
+            </a:r>
+            <a:r>
+              <a:rPr lang="de-DE" sz="4000" b="1" dirty="0" err="1">
+                <a:solidFill>
+                  <a:schemeClr val="bg1"/>
+                </a:solidFill>
+              </a:rPr>
+              <a:t>If</a:t>
+            </a:r>
+            <a:r>
+              <a:rPr lang="de-DE" sz="4000" b="1" dirty="0">
+                <a:solidFill>
+                  <a:schemeClr val="bg1"/>
+                </a:solidFill>
+              </a:rPr>
+              <a:t>-Else Bedingungen und Schleifen</a:t>
+            </a:r>
+            <a:endParaRPr lang="de-DE" b="1" dirty="0">
+              <a:solidFill>
+                <a:schemeClr val="bg1"/>
+              </a:solidFill>
+            </a:endParaRPr>
           </a:p>
         </p:txBody>
       </p:sp>
@@ -15637,7 +15722,7 @@
 </file>
 
 <file path=ppt/slides/slide43.xml><?xml version="1.0" encoding="utf-8"?>
-<p:sld xmlns:a="http://schemas.openxmlformats.org/drawingml/2006/main" xmlns:r="http://schemas.openxmlformats.org/officeDocument/2006/relationships" xmlns:p="http://schemas.openxmlformats.org/presentationml/2006/main" show="0">
+<p:sld xmlns:a="http://schemas.openxmlformats.org/drawingml/2006/main" xmlns:r="http://schemas.openxmlformats.org/officeDocument/2006/relationships" xmlns:p="http://schemas.openxmlformats.org/presentationml/2006/main">
   <p:cSld>
     <p:spTree>
       <p:nvGrpSpPr>
@@ -15658,7 +15743,7 @@
           <p:cNvPr id="2" name="Titel 1">
             <a:extLst>
               <a:ext uri="{FF2B5EF4-FFF2-40B4-BE49-F238E27FC236}">
-                <a16:creationId xmlns:a16="http://schemas.microsoft.com/office/drawing/2014/main" id="{450BB82A-4A36-4F92-B3E6-CAC5D2A9A249}"/>
+                <a16:creationId xmlns:a16="http://schemas.microsoft.com/office/drawing/2014/main" id="{CA61D52C-4090-4D68-B29B-9900C5867AB4}"/>
               </a:ext>
             </a:extLst>
           </p:cNvPr>
@@ -15671,8 +15756,8 @@
         </p:nvSpPr>
         <p:spPr>
           <a:xfrm>
-            <a:off x="540266" y="297514"/>
-            <a:ext cx="10772775" cy="840169"/>
+            <a:off x="657224" y="453234"/>
+            <a:ext cx="10772775" cy="1658198"/>
           </a:xfrm>
         </p:spPr>
         <p:txBody>
@@ -15680,8 +15765,8 @@
           <a:lstStyle/>
           <a:p>
             <a:r>
-              <a:rPr lang="de-DE" dirty="0"/>
-              <a:t>Übung Fibonacci Folge</a:t>
+              <a:rPr lang="de-DE" b="1" dirty="0"/>
+              <a:t>Eigene Funktionen</a:t>
             </a:r>
           </a:p>
         </p:txBody>
@@ -15691,7 +15776,7 @@
           <p:cNvPr id="3" name="Inhaltsplatzhalter 2">
             <a:extLst>
               <a:ext uri="{FF2B5EF4-FFF2-40B4-BE49-F238E27FC236}">
-                <a16:creationId xmlns:a16="http://schemas.microsoft.com/office/drawing/2014/main" id="{3FB7BE5A-ECE7-4725-87E2-9FA5BBB1BC69}"/>
+                <a16:creationId xmlns:a16="http://schemas.microsoft.com/office/drawing/2014/main" id="{F8D794F0-51CA-4F66-A67D-E4353E79C2A7}"/>
               </a:ext>
             </a:extLst>
           </p:cNvPr>
@@ -15704,102 +15789,22 @@
         </p:nvSpPr>
         <p:spPr>
           <a:xfrm>
-            <a:off x="676656" y="1190848"/>
-            <a:ext cx="10753725" cy="5241850"/>
+            <a:off x="676656" y="2057979"/>
+            <a:ext cx="10753725" cy="3766185"/>
           </a:xfrm>
         </p:spPr>
         <p:txBody>
-          <a:bodyPr>
-            <a:normAutofit/>
-          </a:bodyPr>
+          <a:bodyPr/>
           <a:lstStyle/>
           <a:p>
-            <a:pPr marL="457200" indent="-457200">
-              <a:lnSpc>
-                <a:spcPct val="100000"/>
-              </a:lnSpc>
-              <a:buFont typeface="+mj-lt"/>
-              <a:buAutoNum type="arabicPeriod"/>
-            </a:pPr>
-            <a:r>
-              <a:rPr lang="de-DE" sz="2800" dirty="0"/>
-              <a:t>Schreiben Sie eine </a:t>
-            </a:r>
-            <a:r>
-              <a:rPr lang="de-DE" sz="2800" dirty="0" err="1"/>
-              <a:t>while</a:t>
-            </a:r>
-            <a:r>
-              <a:rPr lang="de-DE" sz="2800" dirty="0"/>
-              <a:t>-Schleife die die Fibonacci Folge berechnet bis die neue Zahl größer ist als 100</a:t>
-            </a:r>
-          </a:p>
-          <a:p>
-            <a:pPr marL="457200" indent="-457200">
-              <a:lnSpc>
-                <a:spcPct val="150000"/>
-              </a:lnSpc>
-              <a:buFont typeface="+mj-lt"/>
-              <a:buAutoNum type="arabicPeriod"/>
-            </a:pPr>
-            <a:r>
-              <a:rPr lang="de-DE" sz="2800" dirty="0"/>
-              <a:t>Wie groß ist die neue Zahl?</a:t>
-            </a:r>
-          </a:p>
-          <a:p>
-            <a:pPr marL="457200" indent="-457200">
-              <a:lnSpc>
-                <a:spcPct val="110000"/>
-              </a:lnSpc>
-              <a:buFont typeface="+mj-lt"/>
-              <a:buAutoNum type="arabicPeriod"/>
-            </a:pPr>
-            <a:r>
-              <a:rPr lang="de-DE" sz="2800" dirty="0"/>
-              <a:t>Wie viele Iterationen braucht die Folge bis die neue Zahl größer ist als 100?</a:t>
-            </a:r>
-          </a:p>
-          <a:p>
-            <a:pPr marL="457200" indent="-457200">
-              <a:lnSpc>
-                <a:spcPct val="110000"/>
-              </a:lnSpc>
-              <a:buFont typeface="+mj-lt"/>
-              <a:buAutoNum type="arabicPeriod"/>
-            </a:pPr>
-            <a:r>
-              <a:rPr lang="de-DE" sz="2800" dirty="0"/>
-              <a:t>Schreiben Sie die Fibonacci Folge nun als </a:t>
-            </a:r>
-            <a:r>
-              <a:rPr lang="de-DE" sz="2800" dirty="0" err="1"/>
-              <a:t>for</a:t>
-            </a:r>
-            <a:r>
-              <a:rPr lang="de-DE" sz="2800" dirty="0"/>
-              <a:t>-Schleife die 100 mal über die Folge iteriert</a:t>
-            </a:r>
-          </a:p>
-          <a:p>
-            <a:pPr marL="457200" indent="-457200">
-              <a:lnSpc>
-                <a:spcPct val="150000"/>
-              </a:lnSpc>
-              <a:buFont typeface="+mj-lt"/>
-              <a:buAutoNum type="arabicPeriod"/>
-            </a:pPr>
-            <a:r>
-              <a:rPr lang="de-DE" sz="2800" dirty="0"/>
-              <a:t>Wie groß ist die neue Zahl nach 100 Iterationen</a:t>
-            </a:r>
+            <a:endParaRPr lang="de-DE"/>
           </a:p>
         </p:txBody>
       </p:sp>
     </p:spTree>
     <p:extLst>
       <p:ext uri="{BB962C8B-B14F-4D97-AF65-F5344CB8AC3E}">
-        <p14:creationId xmlns:p14="http://schemas.microsoft.com/office/powerpoint/2010/main" val="3530125378"/>
+        <p14:creationId xmlns:p14="http://schemas.microsoft.com/office/powerpoint/2010/main" val="885307314"/>
       </p:ext>
     </p:extLst>
   </p:cSld>
@@ -15831,7 +15836,7 @@
           <p:cNvPr id="2" name="Titel 1">
             <a:extLst>
               <a:ext uri="{FF2B5EF4-FFF2-40B4-BE49-F238E27FC236}">
-                <a16:creationId xmlns:a16="http://schemas.microsoft.com/office/drawing/2014/main" id="{C4237B4F-0744-4883-AAB0-293CC3A7ED88}"/>
+                <a16:creationId xmlns:a16="http://schemas.microsoft.com/office/drawing/2014/main" id="{D1527AE5-27A9-445B-BD64-38DE7F107B85}"/>
               </a:ext>
             </a:extLst>
           </p:cNvPr>
@@ -15842,25 +15847,19 @@
             <p:ph type="title"/>
           </p:nvPr>
         </p:nvSpPr>
-        <p:spPr>
-          <a:xfrm>
-            <a:off x="657224" y="499533"/>
-            <a:ext cx="10772775" cy="861434"/>
-          </a:xfrm>
-        </p:spPr>
+        <p:spPr/>
         <p:txBody>
           <a:bodyPr/>
           <a:lstStyle/>
           <a:p>
             <a:r>
-              <a:rPr lang="de-DE" dirty="0"/>
-              <a:t>Übung Schleife mit </a:t>
-            </a:r>
-            <a:r>
-              <a:rPr lang="de-DE" dirty="0" err="1"/>
-              <a:t>if-else</a:t>
-            </a:r>
-            <a:endParaRPr lang="de-DE" dirty="0"/>
+              <a:rPr lang="de-DE" b="1" dirty="0" err="1"/>
+              <a:t>If</a:t>
+            </a:r>
+            <a:r>
+              <a:rPr lang="de-DE" b="1" dirty="0"/>
+              <a:t>-Else Bedingungen</a:t>
+            </a:r>
           </a:p>
         </p:txBody>
       </p:sp>
@@ -15869,7 +15868,7 @@
           <p:cNvPr id="3" name="Inhaltsplatzhalter 2">
             <a:extLst>
               <a:ext uri="{FF2B5EF4-FFF2-40B4-BE49-F238E27FC236}">
-                <a16:creationId xmlns:a16="http://schemas.microsoft.com/office/drawing/2014/main" id="{EBC88ED8-5F13-4AFE-AD62-F1AE70FA6DE0}"/>
+                <a16:creationId xmlns:a16="http://schemas.microsoft.com/office/drawing/2014/main" id="{1A221475-45E4-4BA8-8463-28D33DCFA6A3}"/>
               </a:ext>
             </a:extLst>
           </p:cNvPr>
@@ -15880,98 +15879,19 @@
             <p:ph idx="1"/>
           </p:nvPr>
         </p:nvSpPr>
-        <p:spPr>
-          <a:xfrm>
-            <a:off x="676656" y="1440712"/>
-            <a:ext cx="10997893" cy="5002618"/>
-          </a:xfrm>
-        </p:spPr>
-        <p:txBody>
-          <a:bodyPr>
-            <a:normAutofit fontScale="92500" lnSpcReduction="20000"/>
-          </a:bodyPr>
+        <p:spPr/>
+        <p:txBody>
+          <a:bodyPr/>
           <a:lstStyle/>
           <a:p>
-            <a:pPr marL="457200" indent="-457200">
-              <a:lnSpc>
-                <a:spcPct val="150000"/>
-              </a:lnSpc>
-              <a:buFont typeface="+mj-lt"/>
-              <a:buAutoNum type="arabicPeriod"/>
-            </a:pPr>
-            <a:r>
-              <a:rPr lang="de-DE" sz="2800" dirty="0"/>
-              <a:t>Berechnen Sie die ersten 100 Stellen einer Folge mit den folgenden Eigenschaften:</a:t>
-            </a:r>
-          </a:p>
-          <a:p>
-            <a:pPr marL="713232" lvl="1" indent="-457200">
-              <a:lnSpc>
-                <a:spcPct val="150000"/>
-              </a:lnSpc>
-              <a:buFont typeface="Arial" panose="020B0604020202020204" pitchFamily="34" charset="0"/>
-              <a:buChar char="•"/>
-            </a:pPr>
-            <a:r>
-              <a:rPr lang="de-DE" sz="2800" dirty="0"/>
-              <a:t>Sie startet mit dem Wert 3</a:t>
-            </a:r>
-          </a:p>
-          <a:p>
-            <a:pPr marL="713232" lvl="1" indent="-457200">
-              <a:lnSpc>
-                <a:spcPct val="120000"/>
-              </a:lnSpc>
-              <a:buFont typeface="Arial" panose="020B0604020202020204" pitchFamily="34" charset="0"/>
-              <a:buChar char="•"/>
-            </a:pPr>
-            <a:r>
-              <a:rPr lang="de-DE" sz="2800" dirty="0"/>
-              <a:t>Bei der Berechnung der nächsten Zahl soll geprüft werden ob die vorherige Zahl teilbar durch 3 ist. </a:t>
-            </a:r>
-          </a:p>
-          <a:p>
-            <a:pPr marL="256032" lvl="1" indent="0">
-              <a:lnSpc>
-                <a:spcPct val="120000"/>
-              </a:lnSpc>
-              <a:buNone/>
-            </a:pPr>
-            <a:r>
-              <a:rPr lang="de-DE" sz="2800" dirty="0"/>
-              <a:t>	-&gt; Wenn ja, dann soll der nächste Wert berechnet werden aus dem 			vorherigen Wert + 7</a:t>
-            </a:r>
-          </a:p>
-          <a:p>
-            <a:pPr marL="256032" lvl="1" indent="0">
-              <a:lnSpc>
-                <a:spcPct val="120000"/>
-              </a:lnSpc>
-              <a:buNone/>
-            </a:pPr>
-            <a:r>
-              <a:rPr lang="de-DE" sz="2800" dirty="0"/>
-              <a:t>	-&gt; ansonsten soll der nächste Wert berechnet werden aus dem vorherigen 		Wert – 2</a:t>
-            </a:r>
-          </a:p>
-          <a:p>
-            <a:pPr marL="256032" lvl="1" indent="0">
-              <a:lnSpc>
-                <a:spcPct val="150000"/>
-              </a:lnSpc>
-              <a:buNone/>
-            </a:pPr>
-            <a:r>
-              <a:rPr lang="de-DE" sz="2800" dirty="0"/>
-              <a:t>2. Stellen Sie die Folge grafisch dar </a:t>
-            </a:r>
+            <a:endParaRPr lang="de-DE"/>
           </a:p>
         </p:txBody>
       </p:sp>
     </p:spTree>
     <p:extLst>
       <p:ext uri="{BB962C8B-B14F-4D97-AF65-F5344CB8AC3E}">
-        <p14:creationId xmlns:p14="http://schemas.microsoft.com/office/powerpoint/2010/main" val="3529331888"/>
+        <p14:creationId xmlns:p14="http://schemas.microsoft.com/office/powerpoint/2010/main" val="548204528"/>
       </p:ext>
     </p:extLst>
   </p:cSld>
@@ -16003,6 +15923,434 @@
           <p:cNvPr id="2" name="Titel 1">
             <a:extLst>
               <a:ext uri="{FF2B5EF4-FFF2-40B4-BE49-F238E27FC236}">
+                <a16:creationId xmlns:a16="http://schemas.microsoft.com/office/drawing/2014/main" id="{9E78A32F-A1FB-490A-82F1-27B7B4336244}"/>
+              </a:ext>
+            </a:extLst>
+          </p:cNvPr>
+          <p:cNvSpPr>
+            <a:spLocks noGrp="1"/>
+          </p:cNvSpPr>
+          <p:nvPr>
+            <p:ph type="title"/>
+          </p:nvPr>
+        </p:nvSpPr>
+        <p:spPr/>
+        <p:txBody>
+          <a:bodyPr/>
+          <a:lstStyle/>
+          <a:p>
+            <a:r>
+              <a:rPr lang="de-DE" b="1" dirty="0"/>
+              <a:t>Schleifen</a:t>
+            </a:r>
+          </a:p>
+        </p:txBody>
+      </p:sp>
+      <p:sp>
+        <p:nvSpPr>
+          <p:cNvPr id="3" name="Inhaltsplatzhalter 2">
+            <a:extLst>
+              <a:ext uri="{FF2B5EF4-FFF2-40B4-BE49-F238E27FC236}">
+                <a16:creationId xmlns:a16="http://schemas.microsoft.com/office/drawing/2014/main" id="{31D7419C-78E8-4760-B7CA-4F89D304FC11}"/>
+              </a:ext>
+            </a:extLst>
+          </p:cNvPr>
+          <p:cNvSpPr>
+            <a:spLocks noGrp="1"/>
+          </p:cNvSpPr>
+          <p:nvPr>
+            <p:ph idx="1"/>
+          </p:nvPr>
+        </p:nvSpPr>
+        <p:spPr/>
+        <p:txBody>
+          <a:bodyPr/>
+          <a:lstStyle/>
+          <a:p>
+            <a:endParaRPr lang="de-DE"/>
+          </a:p>
+        </p:txBody>
+      </p:sp>
+    </p:spTree>
+    <p:extLst>
+      <p:ext uri="{BB962C8B-B14F-4D97-AF65-F5344CB8AC3E}">
+        <p14:creationId xmlns:p14="http://schemas.microsoft.com/office/powerpoint/2010/main" val="1353607626"/>
+      </p:ext>
+    </p:extLst>
+  </p:cSld>
+  <p:clrMapOvr>
+    <a:masterClrMapping/>
+  </p:clrMapOvr>
+</p:sld>
+</file>
+
+<file path=ppt/slides/slide46.xml><?xml version="1.0" encoding="utf-8"?>
+<p:sld xmlns:a="http://schemas.openxmlformats.org/drawingml/2006/main" xmlns:r="http://schemas.openxmlformats.org/officeDocument/2006/relationships" xmlns:p="http://schemas.openxmlformats.org/presentationml/2006/main" show="0">
+  <p:cSld>
+    <p:spTree>
+      <p:nvGrpSpPr>
+        <p:cNvPr id="1" name=""/>
+        <p:cNvGrpSpPr/>
+        <p:nvPr/>
+      </p:nvGrpSpPr>
+      <p:grpSpPr>
+        <a:xfrm>
+          <a:off x="0" y="0"/>
+          <a:ext cx="0" cy="0"/>
+          <a:chOff x="0" y="0"/>
+          <a:chExt cx="0" cy="0"/>
+        </a:xfrm>
+      </p:grpSpPr>
+      <p:sp>
+        <p:nvSpPr>
+          <p:cNvPr id="2" name="Titel 1">
+            <a:extLst>
+              <a:ext uri="{FF2B5EF4-FFF2-40B4-BE49-F238E27FC236}">
+                <a16:creationId xmlns:a16="http://schemas.microsoft.com/office/drawing/2014/main" id="{450BB82A-4A36-4F92-B3E6-CAC5D2A9A249}"/>
+              </a:ext>
+            </a:extLst>
+          </p:cNvPr>
+          <p:cNvSpPr>
+            <a:spLocks noGrp="1"/>
+          </p:cNvSpPr>
+          <p:nvPr>
+            <p:ph type="title"/>
+          </p:nvPr>
+        </p:nvSpPr>
+        <p:spPr>
+          <a:xfrm>
+            <a:off x="540266" y="297514"/>
+            <a:ext cx="10772775" cy="840169"/>
+          </a:xfrm>
+        </p:spPr>
+        <p:txBody>
+          <a:bodyPr/>
+          <a:lstStyle/>
+          <a:p>
+            <a:r>
+              <a:rPr lang="de-DE" dirty="0"/>
+              <a:t>Übung Fibonacci Folge</a:t>
+            </a:r>
+          </a:p>
+        </p:txBody>
+      </p:sp>
+      <p:sp>
+        <p:nvSpPr>
+          <p:cNvPr id="3" name="Inhaltsplatzhalter 2">
+            <a:extLst>
+              <a:ext uri="{FF2B5EF4-FFF2-40B4-BE49-F238E27FC236}">
+                <a16:creationId xmlns:a16="http://schemas.microsoft.com/office/drawing/2014/main" id="{3FB7BE5A-ECE7-4725-87E2-9FA5BBB1BC69}"/>
+              </a:ext>
+            </a:extLst>
+          </p:cNvPr>
+          <p:cNvSpPr>
+            <a:spLocks noGrp="1"/>
+          </p:cNvSpPr>
+          <p:nvPr>
+            <p:ph idx="1"/>
+          </p:nvPr>
+        </p:nvSpPr>
+        <p:spPr>
+          <a:xfrm>
+            <a:off x="676656" y="1190848"/>
+            <a:ext cx="10753725" cy="5241850"/>
+          </a:xfrm>
+        </p:spPr>
+        <p:txBody>
+          <a:bodyPr>
+            <a:normAutofit/>
+          </a:bodyPr>
+          <a:lstStyle/>
+          <a:p>
+            <a:pPr marL="457200" indent="-457200">
+              <a:lnSpc>
+                <a:spcPct val="100000"/>
+              </a:lnSpc>
+              <a:buFont typeface="+mj-lt"/>
+              <a:buAutoNum type="arabicPeriod"/>
+            </a:pPr>
+            <a:r>
+              <a:rPr lang="de-DE" sz="2800" dirty="0"/>
+              <a:t>Schreiben Sie eine </a:t>
+            </a:r>
+            <a:r>
+              <a:rPr lang="de-DE" sz="2800" dirty="0" err="1"/>
+              <a:t>while</a:t>
+            </a:r>
+            <a:r>
+              <a:rPr lang="de-DE" sz="2800" dirty="0"/>
+              <a:t>-Schleife die die Fibonacci Folge berechnet bis die neue Zahl größer ist als 100</a:t>
+            </a:r>
+          </a:p>
+          <a:p>
+            <a:pPr marL="457200" indent="-457200">
+              <a:lnSpc>
+                <a:spcPct val="150000"/>
+              </a:lnSpc>
+              <a:buFont typeface="+mj-lt"/>
+              <a:buAutoNum type="arabicPeriod"/>
+            </a:pPr>
+            <a:r>
+              <a:rPr lang="de-DE" sz="2800" dirty="0"/>
+              <a:t>Wie groß ist die neue Zahl?</a:t>
+            </a:r>
+          </a:p>
+          <a:p>
+            <a:pPr marL="457200" indent="-457200">
+              <a:lnSpc>
+                <a:spcPct val="110000"/>
+              </a:lnSpc>
+              <a:buFont typeface="+mj-lt"/>
+              <a:buAutoNum type="arabicPeriod"/>
+            </a:pPr>
+            <a:r>
+              <a:rPr lang="de-DE" sz="2800" dirty="0"/>
+              <a:t>Wie viele Iterationen braucht die Folge bis die neue Zahl größer ist als 100?</a:t>
+            </a:r>
+          </a:p>
+          <a:p>
+            <a:pPr marL="457200" indent="-457200">
+              <a:lnSpc>
+                <a:spcPct val="110000"/>
+              </a:lnSpc>
+              <a:buFont typeface="+mj-lt"/>
+              <a:buAutoNum type="arabicPeriod"/>
+            </a:pPr>
+            <a:r>
+              <a:rPr lang="de-DE" sz="2800" dirty="0"/>
+              <a:t>Schreiben Sie die Fibonacci Folge nun als </a:t>
+            </a:r>
+            <a:r>
+              <a:rPr lang="de-DE" sz="2800" dirty="0" err="1"/>
+              <a:t>for</a:t>
+            </a:r>
+            <a:r>
+              <a:rPr lang="de-DE" sz="2800" dirty="0"/>
+              <a:t>-Schleife die 100 mal über die Folge iteriert</a:t>
+            </a:r>
+          </a:p>
+          <a:p>
+            <a:pPr marL="457200" indent="-457200">
+              <a:lnSpc>
+                <a:spcPct val="150000"/>
+              </a:lnSpc>
+              <a:buFont typeface="+mj-lt"/>
+              <a:buAutoNum type="arabicPeriod"/>
+            </a:pPr>
+            <a:r>
+              <a:rPr lang="de-DE" sz="2800" dirty="0"/>
+              <a:t>Wie groß ist die neue Zahl nach 100 Iterationen</a:t>
+            </a:r>
+          </a:p>
+        </p:txBody>
+      </p:sp>
+    </p:spTree>
+    <p:extLst>
+      <p:ext uri="{BB962C8B-B14F-4D97-AF65-F5344CB8AC3E}">
+        <p14:creationId xmlns:p14="http://schemas.microsoft.com/office/powerpoint/2010/main" val="3530125378"/>
+      </p:ext>
+    </p:extLst>
+  </p:cSld>
+  <p:clrMapOvr>
+    <a:masterClrMapping/>
+  </p:clrMapOvr>
+</p:sld>
+</file>
+
+<file path=ppt/slides/slide47.xml><?xml version="1.0" encoding="utf-8"?>
+<p:sld xmlns:a="http://schemas.openxmlformats.org/drawingml/2006/main" xmlns:r="http://schemas.openxmlformats.org/officeDocument/2006/relationships" xmlns:p="http://schemas.openxmlformats.org/presentationml/2006/main" show="0">
+  <p:cSld>
+    <p:spTree>
+      <p:nvGrpSpPr>
+        <p:cNvPr id="1" name=""/>
+        <p:cNvGrpSpPr/>
+        <p:nvPr/>
+      </p:nvGrpSpPr>
+      <p:grpSpPr>
+        <a:xfrm>
+          <a:off x="0" y="0"/>
+          <a:ext cx="0" cy="0"/>
+          <a:chOff x="0" y="0"/>
+          <a:chExt cx="0" cy="0"/>
+        </a:xfrm>
+      </p:grpSpPr>
+      <p:sp>
+        <p:nvSpPr>
+          <p:cNvPr id="2" name="Titel 1">
+            <a:extLst>
+              <a:ext uri="{FF2B5EF4-FFF2-40B4-BE49-F238E27FC236}">
+                <a16:creationId xmlns:a16="http://schemas.microsoft.com/office/drawing/2014/main" id="{C4237B4F-0744-4883-AAB0-293CC3A7ED88}"/>
+              </a:ext>
+            </a:extLst>
+          </p:cNvPr>
+          <p:cNvSpPr>
+            <a:spLocks noGrp="1"/>
+          </p:cNvSpPr>
+          <p:nvPr>
+            <p:ph type="title"/>
+          </p:nvPr>
+        </p:nvSpPr>
+        <p:spPr>
+          <a:xfrm>
+            <a:off x="657224" y="499533"/>
+            <a:ext cx="10772775" cy="861434"/>
+          </a:xfrm>
+        </p:spPr>
+        <p:txBody>
+          <a:bodyPr/>
+          <a:lstStyle/>
+          <a:p>
+            <a:r>
+              <a:rPr lang="de-DE" dirty="0"/>
+              <a:t>Übung Schleife mit </a:t>
+            </a:r>
+            <a:r>
+              <a:rPr lang="de-DE" dirty="0" err="1"/>
+              <a:t>if-else</a:t>
+            </a:r>
+            <a:endParaRPr lang="de-DE" dirty="0"/>
+          </a:p>
+        </p:txBody>
+      </p:sp>
+      <p:sp>
+        <p:nvSpPr>
+          <p:cNvPr id="3" name="Inhaltsplatzhalter 2">
+            <a:extLst>
+              <a:ext uri="{FF2B5EF4-FFF2-40B4-BE49-F238E27FC236}">
+                <a16:creationId xmlns:a16="http://schemas.microsoft.com/office/drawing/2014/main" id="{EBC88ED8-5F13-4AFE-AD62-F1AE70FA6DE0}"/>
+              </a:ext>
+            </a:extLst>
+          </p:cNvPr>
+          <p:cNvSpPr>
+            <a:spLocks noGrp="1"/>
+          </p:cNvSpPr>
+          <p:nvPr>
+            <p:ph idx="1"/>
+          </p:nvPr>
+        </p:nvSpPr>
+        <p:spPr>
+          <a:xfrm>
+            <a:off x="676656" y="1440712"/>
+            <a:ext cx="10997893" cy="5002618"/>
+          </a:xfrm>
+        </p:spPr>
+        <p:txBody>
+          <a:bodyPr>
+            <a:normAutofit fontScale="92500" lnSpcReduction="20000"/>
+          </a:bodyPr>
+          <a:lstStyle/>
+          <a:p>
+            <a:pPr marL="457200" indent="-457200">
+              <a:lnSpc>
+                <a:spcPct val="150000"/>
+              </a:lnSpc>
+              <a:buFont typeface="+mj-lt"/>
+              <a:buAutoNum type="arabicPeriod"/>
+            </a:pPr>
+            <a:r>
+              <a:rPr lang="de-DE" sz="2800" dirty="0"/>
+              <a:t>Berechnen Sie die ersten 100 Stellen einer Folge mit den folgenden Eigenschaften:</a:t>
+            </a:r>
+          </a:p>
+          <a:p>
+            <a:pPr marL="713232" lvl="1" indent="-457200">
+              <a:lnSpc>
+                <a:spcPct val="150000"/>
+              </a:lnSpc>
+              <a:buFont typeface="Arial" panose="020B0604020202020204" pitchFamily="34" charset="0"/>
+              <a:buChar char="•"/>
+            </a:pPr>
+            <a:r>
+              <a:rPr lang="de-DE" sz="2800" dirty="0"/>
+              <a:t>Sie startet mit dem Wert 3</a:t>
+            </a:r>
+          </a:p>
+          <a:p>
+            <a:pPr marL="713232" lvl="1" indent="-457200">
+              <a:lnSpc>
+                <a:spcPct val="120000"/>
+              </a:lnSpc>
+              <a:buFont typeface="Arial" panose="020B0604020202020204" pitchFamily="34" charset="0"/>
+              <a:buChar char="•"/>
+            </a:pPr>
+            <a:r>
+              <a:rPr lang="de-DE" sz="2800" dirty="0"/>
+              <a:t>Bei der Berechnung der nächsten Zahl soll geprüft werden ob die vorherige Zahl teilbar durch 3 ist. </a:t>
+            </a:r>
+          </a:p>
+          <a:p>
+            <a:pPr marL="256032" lvl="1" indent="0">
+              <a:lnSpc>
+                <a:spcPct val="120000"/>
+              </a:lnSpc>
+              <a:buNone/>
+            </a:pPr>
+            <a:r>
+              <a:rPr lang="de-DE" sz="2800" dirty="0"/>
+              <a:t>	-&gt; Wenn ja, dann soll der nächste Wert berechnet werden aus dem 			vorherigen Wert + 7</a:t>
+            </a:r>
+          </a:p>
+          <a:p>
+            <a:pPr marL="256032" lvl="1" indent="0">
+              <a:lnSpc>
+                <a:spcPct val="120000"/>
+              </a:lnSpc>
+              <a:buNone/>
+            </a:pPr>
+            <a:r>
+              <a:rPr lang="de-DE" sz="2800" dirty="0"/>
+              <a:t>	-&gt; ansonsten soll der nächste Wert berechnet werden aus dem vorherigen 		Wert – 2</a:t>
+            </a:r>
+          </a:p>
+          <a:p>
+            <a:pPr marL="256032" lvl="1" indent="0">
+              <a:lnSpc>
+                <a:spcPct val="150000"/>
+              </a:lnSpc>
+              <a:buNone/>
+            </a:pPr>
+            <a:r>
+              <a:rPr lang="de-DE" sz="2800" dirty="0"/>
+              <a:t>2. Stellen Sie die Folge grafisch dar </a:t>
+            </a:r>
+          </a:p>
+        </p:txBody>
+      </p:sp>
+    </p:spTree>
+    <p:extLst>
+      <p:ext uri="{BB962C8B-B14F-4D97-AF65-F5344CB8AC3E}">
+        <p14:creationId xmlns:p14="http://schemas.microsoft.com/office/powerpoint/2010/main" val="3529331888"/>
+      </p:ext>
+    </p:extLst>
+  </p:cSld>
+  <p:clrMapOvr>
+    <a:masterClrMapping/>
+  </p:clrMapOvr>
+</p:sld>
+</file>
+
+<file path=ppt/slides/slide48.xml><?xml version="1.0" encoding="utf-8"?>
+<p:sld xmlns:a="http://schemas.openxmlformats.org/drawingml/2006/main" xmlns:r="http://schemas.openxmlformats.org/officeDocument/2006/relationships" xmlns:p="http://schemas.openxmlformats.org/presentationml/2006/main" show="0">
+  <p:cSld>
+    <p:spTree>
+      <p:nvGrpSpPr>
+        <p:cNvPr id="1" name=""/>
+        <p:cNvGrpSpPr/>
+        <p:nvPr/>
+      </p:nvGrpSpPr>
+      <p:grpSpPr>
+        <a:xfrm>
+          <a:off x="0" y="0"/>
+          <a:ext cx="0" cy="0"/>
+          <a:chOff x="0" y="0"/>
+          <a:chExt cx="0" cy="0"/>
+        </a:xfrm>
+      </p:grpSpPr>
+      <p:sp>
+        <p:nvSpPr>
+          <p:cNvPr id="2" name="Titel 1">
+            <a:extLst>
+              <a:ext uri="{FF2B5EF4-FFF2-40B4-BE49-F238E27FC236}">
                 <a16:creationId xmlns:a16="http://schemas.microsoft.com/office/drawing/2014/main" id="{2F8442BA-4AF9-4F3C-A1DE-0472859C5193}"/>
               </a:ext>
             </a:extLst>
@@ -16153,8 +16501,8 @@
 </p:sld>
 </file>
 
-<file path=ppt/slides/slide46.xml><?xml version="1.0" encoding="utf-8"?>
-<p:sld xmlns:a="http://schemas.openxmlformats.org/drawingml/2006/main" xmlns:r="http://schemas.openxmlformats.org/officeDocument/2006/relationships" xmlns:p="http://schemas.openxmlformats.org/presentationml/2006/main">
+<file path=ppt/slides/slide49.xml><?xml version="1.0" encoding="utf-8"?>
+<p:sld xmlns:a="http://schemas.openxmlformats.org/drawingml/2006/main" xmlns:r="http://schemas.openxmlformats.org/officeDocument/2006/relationships" xmlns:p="http://schemas.openxmlformats.org/presentationml/2006/main" show="0">
   <p:cSld>
     <p:spTree>
       <p:nvGrpSpPr>

</xml_diff>

<commit_message>
Alle Übungen als eigene Dokumente aus der Powerpoint exportiert
</commit_message>
<xml_diff>
--- a/Präsentationen/Einführung in R.pptx
+++ b/Präsentationen/Einführung in R.pptx
@@ -360,7 +360,7 @@
           <a:p>
             <a:fld id="{3F46AE61-50B3-4440-BB01-1FF85E3E82A7}" type="datetimeFigureOut">
               <a:rPr lang="de-DE" smtClean="0"/>
-              <a:t>30.06.2025</a:t>
+              <a:t>01.07.2025</a:t>
             </a:fld>
             <a:endParaRPr lang="de-DE"/>
           </a:p>
@@ -550,7 +550,7 @@
           <a:p>
             <a:fld id="{3F46AE61-50B3-4440-BB01-1FF85E3E82A7}" type="datetimeFigureOut">
               <a:rPr lang="de-DE" smtClean="0"/>
-              <a:t>30.06.2025</a:t>
+              <a:t>01.07.2025</a:t>
             </a:fld>
             <a:endParaRPr lang="de-DE"/>
           </a:p>
@@ -730,7 +730,7 @@
           <a:p>
             <a:fld id="{3F46AE61-50B3-4440-BB01-1FF85E3E82A7}" type="datetimeFigureOut">
               <a:rPr lang="de-DE" smtClean="0"/>
-              <a:t>30.06.2025</a:t>
+              <a:t>01.07.2025</a:t>
             </a:fld>
             <a:endParaRPr lang="de-DE"/>
           </a:p>
@@ -900,7 +900,7 @@
           <a:p>
             <a:fld id="{3F46AE61-50B3-4440-BB01-1FF85E3E82A7}" type="datetimeFigureOut">
               <a:rPr lang="de-DE" smtClean="0"/>
-              <a:t>30.06.2025</a:t>
+              <a:t>01.07.2025</a:t>
             </a:fld>
             <a:endParaRPr lang="de-DE"/>
           </a:p>
@@ -1156,7 +1156,7 @@
           <a:p>
             <a:fld id="{3F46AE61-50B3-4440-BB01-1FF85E3E82A7}" type="datetimeFigureOut">
               <a:rPr lang="de-DE" smtClean="0"/>
-              <a:t>30.06.2025</a:t>
+              <a:t>01.07.2025</a:t>
             </a:fld>
             <a:endParaRPr lang="de-DE"/>
           </a:p>
@@ -1444,7 +1444,7 @@
           <a:p>
             <a:fld id="{3F46AE61-50B3-4440-BB01-1FF85E3E82A7}" type="datetimeFigureOut">
               <a:rPr lang="de-DE" smtClean="0"/>
-              <a:t>30.06.2025</a:t>
+              <a:t>01.07.2025</a:t>
             </a:fld>
             <a:endParaRPr lang="de-DE"/>
           </a:p>
@@ -1882,7 +1882,7 @@
           <a:p>
             <a:fld id="{3F46AE61-50B3-4440-BB01-1FF85E3E82A7}" type="datetimeFigureOut">
               <a:rPr lang="de-DE" smtClean="0"/>
-              <a:t>30.06.2025</a:t>
+              <a:t>01.07.2025</a:t>
             </a:fld>
             <a:endParaRPr lang="de-DE"/>
           </a:p>
@@ -2000,7 +2000,7 @@
           <a:p>
             <a:fld id="{3F46AE61-50B3-4440-BB01-1FF85E3E82A7}" type="datetimeFigureOut">
               <a:rPr lang="de-DE" smtClean="0"/>
-              <a:t>30.06.2025</a:t>
+              <a:t>01.07.2025</a:t>
             </a:fld>
             <a:endParaRPr lang="de-DE"/>
           </a:p>
@@ -2095,7 +2095,7 @@
           <a:p>
             <a:fld id="{3F46AE61-50B3-4440-BB01-1FF85E3E82A7}" type="datetimeFigureOut">
               <a:rPr lang="de-DE" smtClean="0"/>
-              <a:t>30.06.2025</a:t>
+              <a:t>01.07.2025</a:t>
             </a:fld>
             <a:endParaRPr lang="de-DE"/>
           </a:p>
@@ -2451,7 +2451,7 @@
           <a:p>
             <a:fld id="{3F46AE61-50B3-4440-BB01-1FF85E3E82A7}" type="datetimeFigureOut">
               <a:rPr lang="de-DE" smtClean="0"/>
-              <a:t>30.06.2025</a:t>
+              <a:t>01.07.2025</a:t>
             </a:fld>
             <a:endParaRPr lang="de-DE"/>
           </a:p>
@@ -2767,7 +2767,7 @@
           <a:p>
             <a:fld id="{3F46AE61-50B3-4440-BB01-1FF85E3E82A7}" type="datetimeFigureOut">
               <a:rPr lang="de-DE" smtClean="0"/>
-              <a:t>30.06.2025</a:t>
+              <a:t>01.07.2025</a:t>
             </a:fld>
             <a:endParaRPr lang="de-DE"/>
           </a:p>
@@ -3000,7 +3000,7 @@
           <a:p>
             <a:fld id="{3F46AE61-50B3-4440-BB01-1FF85E3E82A7}" type="datetimeFigureOut">
               <a:rPr lang="de-DE" smtClean="0"/>
-              <a:t>30.06.2025</a:t>
+              <a:t>01.07.2025</a:t>
             </a:fld>
             <a:endParaRPr lang="de-DE"/>
           </a:p>
@@ -6628,244 +6628,19 @@
         </p:nvSpPr>
         <p:spPr>
           <a:xfrm>
-            <a:off x="619902" y="223934"/>
-            <a:ext cx="10636677" cy="564342"/>
+            <a:off x="604137" y="1201397"/>
+            <a:ext cx="10636677" cy="1013658"/>
           </a:xfrm>
         </p:spPr>
         <p:txBody>
           <a:bodyPr>
-            <a:normAutofit fontScale="90000"/>
+            <a:normAutofit/>
           </a:bodyPr>
           <a:lstStyle/>
           <a:p>
             <a:r>
-              <a:rPr lang="de-DE" sz="4000" b="1" dirty="0"/>
+              <a:rPr lang="de-DE" b="1" dirty="0"/>
               <a:t>Übung: Operatoren und Variablen</a:t>
-            </a:r>
-          </a:p>
-        </p:txBody>
-      </p:sp>
-      <p:sp>
-        <p:nvSpPr>
-          <p:cNvPr id="3" name="Inhaltsplatzhalter 2">
-            <a:extLst>
-              <a:ext uri="{FF2B5EF4-FFF2-40B4-BE49-F238E27FC236}">
-                <a16:creationId xmlns:a16="http://schemas.microsoft.com/office/drawing/2014/main" id="{D0888A6A-7541-431D-8589-09F48760BEEA}"/>
-              </a:ext>
-            </a:extLst>
-          </p:cNvPr>
-          <p:cNvSpPr>
-            <a:spLocks noGrp="1"/>
-          </p:cNvSpPr>
-          <p:nvPr>
-            <p:ph idx="1"/>
-          </p:nvPr>
-        </p:nvSpPr>
-        <p:spPr>
-          <a:xfrm>
-            <a:off x="676656" y="1213945"/>
-            <a:ext cx="11142120" cy="4969142"/>
-          </a:xfrm>
-        </p:spPr>
-        <p:txBody>
-          <a:bodyPr>
-            <a:normAutofit fontScale="77500" lnSpcReduction="20000"/>
-          </a:bodyPr>
-          <a:lstStyle/>
-          <a:p>
-            <a:pPr marL="0" indent="0">
-              <a:lnSpc>
-                <a:spcPct val="100000"/>
-              </a:lnSpc>
-              <a:buNone/>
-            </a:pPr>
-            <a:r>
-              <a:rPr lang="de-DE" sz="2800" dirty="0"/>
-              <a:t>Öffnen Sie </a:t>
-            </a:r>
-            <a:r>
-              <a:rPr lang="de-DE" sz="2800" dirty="0" err="1"/>
-              <a:t>RStudio</a:t>
-            </a:r>
-            <a:r>
-              <a:rPr lang="de-DE" sz="2800" dirty="0"/>
-              <a:t> und erstellen Sie ein neues R Skript</a:t>
-            </a:r>
-          </a:p>
-          <a:p>
-            <a:pPr marL="0" indent="0">
-              <a:lnSpc>
-                <a:spcPct val="100000"/>
-              </a:lnSpc>
-              <a:buNone/>
-            </a:pPr>
-            <a:endParaRPr lang="de-DE" sz="2800" dirty="0"/>
-          </a:p>
-          <a:p>
-            <a:pPr marL="0" indent="0">
-              <a:lnSpc>
-                <a:spcPct val="120000"/>
-              </a:lnSpc>
-              <a:buNone/>
-            </a:pPr>
-            <a:r>
-              <a:rPr lang="de-DE" sz="2800" dirty="0"/>
-              <a:t>Erzeugen Sie die Variablen </a:t>
-            </a:r>
-            <a:r>
-              <a:rPr lang="de-DE" sz="2800" b="1" dirty="0"/>
-              <a:t>X</a:t>
-            </a:r>
-            <a:r>
-              <a:rPr lang="de-DE" sz="2800" dirty="0"/>
-              <a:t> = 3 und </a:t>
-            </a:r>
-            <a:r>
-              <a:rPr lang="de-DE" sz="2800" b="1" dirty="0"/>
-              <a:t>Y</a:t>
-            </a:r>
-            <a:r>
-              <a:rPr lang="de-DE" sz="2800" dirty="0"/>
-              <a:t> = 19 und speichern sie die Potenz von </a:t>
-            </a:r>
-            <a:r>
-              <a:rPr lang="de-DE" sz="2800" b="1" dirty="0"/>
-              <a:t>X</a:t>
-            </a:r>
-            <a:r>
-              <a:rPr lang="de-DE" sz="2800" dirty="0"/>
-              <a:t> hoch </a:t>
-            </a:r>
-            <a:r>
-              <a:rPr lang="de-DE" sz="2800" b="1" dirty="0"/>
-              <a:t>Y</a:t>
-            </a:r>
-            <a:r>
-              <a:rPr lang="de-DE" sz="2800" dirty="0"/>
-              <a:t> in einer dritten Variablen </a:t>
-            </a:r>
-            <a:r>
-              <a:rPr lang="de-DE" sz="2800" b="1" dirty="0"/>
-              <a:t>Z</a:t>
-            </a:r>
-            <a:r>
-              <a:rPr lang="de-DE" sz="2800" dirty="0"/>
-              <a:t>. Denken Sie daran, die Zeilen mit STRG+ENTER auszuführen. </a:t>
-            </a:r>
-          </a:p>
-          <a:p>
-            <a:pPr marL="0" indent="0">
-              <a:lnSpc>
-                <a:spcPct val="100000"/>
-              </a:lnSpc>
-              <a:buNone/>
-            </a:pPr>
-            <a:endParaRPr lang="de-DE" sz="2800" dirty="0"/>
-          </a:p>
-          <a:p>
-            <a:pPr marL="0" indent="0">
-              <a:lnSpc>
-                <a:spcPct val="100000"/>
-              </a:lnSpc>
-              <a:buNone/>
-            </a:pPr>
-            <a:r>
-              <a:rPr lang="de-DE" sz="2800" dirty="0"/>
-              <a:t>Ziehen Sie jetzt von </a:t>
-            </a:r>
-            <a:r>
-              <a:rPr lang="de-DE" sz="2800" b="1" dirty="0"/>
-              <a:t>Z</a:t>
-            </a:r>
-            <a:r>
-              <a:rPr lang="de-DE" sz="2800" dirty="0"/>
-              <a:t> die Variable </a:t>
-            </a:r>
-            <a:r>
-              <a:rPr lang="de-DE" sz="2800" b="1" dirty="0"/>
-              <a:t>X</a:t>
-            </a:r>
-            <a:r>
-              <a:rPr lang="de-DE" sz="2800" dirty="0"/>
-              <a:t> ab und schreiben Sie das Ergebnis in Variable </a:t>
-            </a:r>
-            <a:r>
-              <a:rPr lang="de-DE" sz="2800" b="1" dirty="0"/>
-              <a:t>Z</a:t>
-            </a:r>
-            <a:r>
-              <a:rPr lang="de-DE" sz="2800" dirty="0"/>
-              <a:t>.</a:t>
-            </a:r>
-          </a:p>
-          <a:p>
-            <a:pPr marL="0" indent="0">
-              <a:lnSpc>
-                <a:spcPct val="100000"/>
-              </a:lnSpc>
-              <a:buNone/>
-            </a:pPr>
-            <a:endParaRPr lang="de-DE" sz="2800" dirty="0"/>
-          </a:p>
-          <a:p>
-            <a:pPr marL="0" indent="0">
-              <a:lnSpc>
-                <a:spcPct val="100000"/>
-              </a:lnSpc>
-              <a:buNone/>
-            </a:pPr>
-            <a:r>
-              <a:rPr lang="de-DE" sz="2800" dirty="0"/>
-              <a:t>Nutzen Sie einen logischen Operator um herauszufinden ob Variable </a:t>
-            </a:r>
-            <a:r>
-              <a:rPr lang="de-DE" sz="2800" b="1" dirty="0"/>
-              <a:t>Z</a:t>
-            </a:r>
-            <a:r>
-              <a:rPr lang="de-DE" sz="2800" dirty="0"/>
-              <a:t> größer ist als 1000 </a:t>
-            </a:r>
-          </a:p>
-          <a:p>
-            <a:pPr marL="0" indent="0">
-              <a:lnSpc>
-                <a:spcPct val="100000"/>
-              </a:lnSpc>
-              <a:buNone/>
-            </a:pPr>
-            <a:endParaRPr lang="de-DE" sz="2800" dirty="0"/>
-          </a:p>
-          <a:p>
-            <a:pPr marL="0" indent="0">
-              <a:lnSpc>
-                <a:spcPct val="120000"/>
-              </a:lnSpc>
-              <a:buNone/>
-            </a:pPr>
-            <a:r>
-              <a:rPr lang="de-DE" sz="2800" dirty="0"/>
-              <a:t>Nutzen Sie den Modulo Operator und den Gleichheitsoperator um eine logische Abfrage zu erstellen die TRUE ausgibt wenn </a:t>
-            </a:r>
-            <a:r>
-              <a:rPr lang="de-DE" sz="2800" b="1" dirty="0"/>
-              <a:t>Z</a:t>
-            </a:r>
-            <a:r>
-              <a:rPr lang="de-DE" sz="2800" dirty="0"/>
-              <a:t> eine gerade Zahl ist, und FALSE wenn </a:t>
-            </a:r>
-            <a:r>
-              <a:rPr lang="de-DE" sz="2800" b="1" dirty="0"/>
-              <a:t>Z</a:t>
-            </a:r>
-            <a:r>
-              <a:rPr lang="de-DE" sz="2800" dirty="0"/>
-              <a:t> eine ungerade Zahl ist </a:t>
-            </a:r>
-            <a:r>
-              <a:rPr lang="de-DE" sz="2800" i="1" dirty="0"/>
-              <a:t>(Tipp: eine gerade Zahl hat keinen Rest wenn sie durch 2 geteilt wird)</a:t>
             </a:r>
           </a:p>
         </p:txBody>
@@ -8371,178 +8146,19 @@
         </p:nvSpPr>
         <p:spPr>
           <a:xfrm>
-            <a:off x="638174" y="259041"/>
+            <a:off x="638174" y="1204972"/>
             <a:ext cx="10772775" cy="529235"/>
           </a:xfrm>
         </p:spPr>
         <p:txBody>
           <a:bodyPr>
-            <a:normAutofit fontScale="90000"/>
+            <a:noAutofit/>
           </a:bodyPr>
           <a:lstStyle/>
           <a:p>
             <a:r>
-              <a:rPr lang="de-DE" sz="4000" b="1" dirty="0"/>
+              <a:rPr lang="de-DE" b="1" dirty="0"/>
               <a:t>Übung: Vektoren</a:t>
-            </a:r>
-          </a:p>
-        </p:txBody>
-      </p:sp>
-      <p:sp>
-        <p:nvSpPr>
-          <p:cNvPr id="3" name="Inhaltsplatzhalter 2">
-            <a:extLst>
-              <a:ext uri="{FF2B5EF4-FFF2-40B4-BE49-F238E27FC236}">
-                <a16:creationId xmlns:a16="http://schemas.microsoft.com/office/drawing/2014/main" id="{4CF981BD-E5E2-4F40-B1EA-B35213368847}"/>
-              </a:ext>
-            </a:extLst>
-          </p:cNvPr>
-          <p:cNvSpPr>
-            <a:spLocks noGrp="1"/>
-          </p:cNvSpPr>
-          <p:nvPr>
-            <p:ph idx="1"/>
-          </p:nvPr>
-        </p:nvSpPr>
-        <p:spPr>
-          <a:xfrm>
-            <a:off x="657224" y="1212980"/>
-            <a:ext cx="10753725" cy="5262465"/>
-          </a:xfrm>
-        </p:spPr>
-        <p:txBody>
-          <a:bodyPr>
-            <a:normAutofit fontScale="55000" lnSpcReduction="20000"/>
-          </a:bodyPr>
-          <a:lstStyle/>
-          <a:p>
-            <a:pPr marL="457200" indent="-457200">
-              <a:buFont typeface="+mj-lt"/>
-              <a:buAutoNum type="arabicPeriod"/>
-            </a:pPr>
-            <a:r>
-              <a:rPr lang="de-DE" sz="2800" dirty="0"/>
-              <a:t>Erzeugen Sie einen Vektor </a:t>
-            </a:r>
-            <a:r>
-              <a:rPr lang="de-DE" sz="2800" b="1" dirty="0" err="1"/>
-              <a:t>vec</a:t>
-            </a:r>
-            <a:r>
-              <a:rPr lang="de-DE" sz="2800" dirty="0"/>
-              <a:t> mit den Zahlen 2, 23, 42, 256, 13</a:t>
-            </a:r>
-          </a:p>
-          <a:p>
-            <a:pPr marL="0" indent="0">
-              <a:buNone/>
-            </a:pPr>
-            <a:endParaRPr lang="de-DE" sz="2800" dirty="0"/>
-          </a:p>
-          <a:p>
-            <a:pPr marL="457200" indent="-457200">
-              <a:buFont typeface="+mj-lt"/>
-              <a:buAutoNum type="arabicPeriod"/>
-            </a:pPr>
-            <a:r>
-              <a:rPr lang="de-DE" sz="2800" dirty="0"/>
-              <a:t>Hängen Sie an den Vektor die Zahl 800 an</a:t>
-            </a:r>
-          </a:p>
-          <a:p>
-            <a:pPr marL="0" indent="0">
-              <a:buNone/>
-            </a:pPr>
-            <a:endParaRPr lang="de-DE" sz="2800" dirty="0"/>
-          </a:p>
-          <a:p>
-            <a:pPr marL="457200" indent="-457200">
-              <a:buFont typeface="+mj-lt"/>
-              <a:buAutoNum type="arabicPeriod"/>
-            </a:pPr>
-            <a:r>
-              <a:rPr lang="de-DE" sz="2800" dirty="0"/>
-              <a:t>Fügen Sie vor der ersten Zahl eine 0 dem Vektor hinzu</a:t>
-            </a:r>
-          </a:p>
-          <a:p>
-            <a:pPr marL="0" indent="0">
-              <a:buNone/>
-            </a:pPr>
-            <a:endParaRPr lang="de-DE" sz="2800" dirty="0"/>
-          </a:p>
-          <a:p>
-            <a:pPr marL="457200" indent="-457200">
-              <a:buFont typeface="+mj-lt"/>
-              <a:buAutoNum type="arabicPeriod"/>
-            </a:pPr>
-            <a:r>
-              <a:rPr lang="de-DE" sz="2800" dirty="0"/>
-              <a:t>Löschen Sie die Stelle mit Zahl 256 aus dem Vektor </a:t>
-            </a:r>
-          </a:p>
-          <a:p>
-            <a:pPr marL="0" indent="0">
-              <a:buNone/>
-            </a:pPr>
-            <a:endParaRPr lang="de-DE" sz="2800" dirty="0"/>
-          </a:p>
-          <a:p>
-            <a:pPr marL="457200" indent="-457200">
-              <a:buFont typeface="+mj-lt"/>
-              <a:buAutoNum type="arabicPeriod"/>
-            </a:pPr>
-            <a:r>
-              <a:rPr lang="de-DE" sz="2800" dirty="0"/>
-              <a:t>Überschreiben Sie die Zahl 800 mit der Zahl 799 </a:t>
-            </a:r>
-          </a:p>
-          <a:p>
-            <a:pPr marL="0" indent="0">
-              <a:buNone/>
-            </a:pPr>
-            <a:endParaRPr lang="de-DE" sz="2800" dirty="0"/>
-          </a:p>
-          <a:p>
-            <a:pPr marL="457200" indent="-457200">
-              <a:buFont typeface="+mj-lt"/>
-              <a:buAutoNum type="arabicPeriod"/>
-            </a:pPr>
-            <a:r>
-              <a:rPr lang="de-DE" sz="2800" dirty="0"/>
-              <a:t>Wählen sie die ersten 3 Stellen des Vektors aus und speichern diese in einen neuen Vektor. Den Namen für den neuen Vektor können Sie beliebig wählen.</a:t>
-            </a:r>
-          </a:p>
-          <a:p>
-            <a:pPr marL="0" indent="0">
-              <a:buNone/>
-            </a:pPr>
-            <a:endParaRPr lang="de-DE" sz="2800" dirty="0"/>
-          </a:p>
-          <a:p>
-            <a:pPr marL="457200" indent="-457200">
-              <a:buFont typeface="+mj-lt"/>
-              <a:buAutoNum type="arabicPeriod"/>
-            </a:pPr>
-            <a:r>
-              <a:rPr lang="de-DE" sz="2800" dirty="0"/>
-              <a:t>Wählen sie alle Stellen aus dem Vektor aus die größer sind als 20 und speichern Sie diese ebenfalls in einem neuen Vektor </a:t>
-            </a:r>
-          </a:p>
-          <a:p>
-            <a:pPr marL="0" indent="0">
-              <a:buNone/>
-            </a:pPr>
-            <a:endParaRPr lang="de-DE" sz="2800" dirty="0"/>
-          </a:p>
-          <a:p>
-            <a:pPr marL="457200" indent="-457200">
-              <a:buFont typeface="+mj-lt"/>
-              <a:buAutoNum type="arabicPeriod"/>
-            </a:pPr>
-            <a:r>
-              <a:rPr lang="de-DE" sz="2800" dirty="0"/>
-              <a:t>Wählen Sie die Stellen des Vektors so aus, dass die gewählten Zahlen den Vektor in sortierter Reihenfolge darstellen</a:t>
             </a:r>
           </a:p>
         </p:txBody>
@@ -9807,78 +9423,6 @@
           </a:p>
         </p:txBody>
       </p:sp>
-      <p:sp>
-        <p:nvSpPr>
-          <p:cNvPr id="3" name="Inhaltsplatzhalter 2">
-            <a:extLst>
-              <a:ext uri="{FF2B5EF4-FFF2-40B4-BE49-F238E27FC236}">
-                <a16:creationId xmlns:a16="http://schemas.microsoft.com/office/drawing/2014/main" id="{EE0BEB4D-8E11-490E-A671-CBE1AE527032}"/>
-              </a:ext>
-            </a:extLst>
-          </p:cNvPr>
-          <p:cNvSpPr>
-            <a:spLocks noGrp="1"/>
-          </p:cNvSpPr>
-          <p:nvPr>
-            <p:ph idx="1"/>
-          </p:nvPr>
-        </p:nvSpPr>
-        <p:spPr/>
-        <p:txBody>
-          <a:bodyPr>
-            <a:normAutofit/>
-          </a:bodyPr>
-          <a:lstStyle/>
-          <a:p>
-            <a:pPr marL="457200" indent="-457200">
-              <a:buFont typeface="+mj-lt"/>
-              <a:buAutoNum type="arabicPeriod"/>
-            </a:pPr>
-            <a:r>
-              <a:rPr lang="de-DE" sz="2800" dirty="0"/>
-              <a:t>Erzeugen Sie mit der Funktion sample() einen Vektor bestehend aus 100 zufälligen Zahlen zwischen 1 und 5</a:t>
-            </a:r>
-          </a:p>
-          <a:p>
-            <a:pPr marL="457200" indent="-457200">
-              <a:buFont typeface="+mj-lt"/>
-              <a:buAutoNum type="arabicPeriod"/>
-            </a:pPr>
-            <a:r>
-              <a:rPr lang="de-DE" sz="2800" dirty="0"/>
-              <a:t> Berechnen Sie die Summe, den Mittelwert und Median des Vektors</a:t>
-            </a:r>
-          </a:p>
-          <a:p>
-            <a:pPr marL="457200" indent="-457200">
-              <a:buFont typeface="+mj-lt"/>
-              <a:buAutoNum type="arabicPeriod"/>
-            </a:pPr>
-            <a:r>
-              <a:rPr lang="de-DE" sz="2800" dirty="0"/>
-              <a:t> Sortieren Sie den Vektor von großen nach kleinen Zahlen (Schauen sie sich dafür die Argumente der </a:t>
-            </a:r>
-            <a:r>
-              <a:rPr lang="de-DE" sz="2800" dirty="0" err="1"/>
-              <a:t>sort</a:t>
-            </a:r>
-            <a:r>
-              <a:rPr lang="de-DE" sz="2800" dirty="0"/>
-              <a:t>() Funktion an)</a:t>
-            </a:r>
-          </a:p>
-          <a:p>
-            <a:pPr marL="457200" indent="-457200">
-              <a:buFont typeface="+mj-lt"/>
-              <a:buAutoNum type="arabicPeriod"/>
-            </a:pPr>
-            <a:r>
-              <a:rPr lang="de-DE" sz="2800" dirty="0"/>
-              <a:t>Finden Sie mittels R-Hilfe und Google eine Funktion, die ausgibt wie oft eine Zahl im Vektor vorkommt</a:t>
-            </a:r>
-          </a:p>
-        </p:txBody>
-      </p:sp>
     </p:spTree>
     <p:extLst>
       <p:ext uri="{BB962C8B-B14F-4D97-AF65-F5344CB8AC3E}">
@@ -11325,7 +10869,12 @@
             <p:ph type="title"/>
           </p:nvPr>
         </p:nvSpPr>
-        <p:spPr/>
+        <p:spPr>
+          <a:xfrm>
+            <a:off x="641458" y="917319"/>
+            <a:ext cx="10772775" cy="1658198"/>
+          </a:xfrm>
+        </p:spPr>
         <p:txBody>
           <a:bodyPr/>
           <a:lstStyle/>
@@ -11337,135 +10886,6 @@
           </a:p>
         </p:txBody>
       </p:sp>
-      <p:sp>
-        <p:nvSpPr>
-          <p:cNvPr id="3" name="Inhaltsplatzhalter 2">
-            <a:extLst>
-              <a:ext uri="{FF2B5EF4-FFF2-40B4-BE49-F238E27FC236}">
-                <a16:creationId xmlns:a16="http://schemas.microsoft.com/office/drawing/2014/main" id="{C377893B-9CA7-49BE-AD7E-22008EBF7734}"/>
-              </a:ext>
-            </a:extLst>
-          </p:cNvPr>
-          <p:cNvSpPr>
-            <a:spLocks noGrp="1"/>
-          </p:cNvSpPr>
-          <p:nvPr>
-            <p:ph idx="1"/>
-          </p:nvPr>
-        </p:nvSpPr>
-        <p:spPr/>
-        <p:txBody>
-          <a:bodyPr/>
-          <a:lstStyle/>
-          <a:p>
-            <a:pPr marL="0" indent="0">
-              <a:buNone/>
-            </a:pPr>
-            <a:r>
-              <a:rPr lang="de-DE" dirty="0"/>
-              <a:t>Erzeugen Sie eine Matrix aus 0 mit den Dimensionen 5 Zeilen und 5 Spalten</a:t>
-            </a:r>
-          </a:p>
-          <a:p>
-            <a:pPr marL="0" indent="0">
-              <a:buNone/>
-            </a:pPr>
-            <a:endParaRPr lang="de-DE" dirty="0"/>
-          </a:p>
-          <a:p>
-            <a:pPr marL="0" indent="0">
-              <a:buNone/>
-            </a:pPr>
-            <a:r>
-              <a:rPr lang="de-DE" dirty="0"/>
-              <a:t>Füllen Sie Zellen der Matrix wie dargestellt</a:t>
-            </a:r>
-          </a:p>
-          <a:p>
-            <a:pPr marL="0" indent="0">
-              <a:buNone/>
-            </a:pPr>
-            <a:endParaRPr lang="de-DE" dirty="0"/>
-          </a:p>
-          <a:p>
-            <a:pPr marL="0" indent="0">
-              <a:buNone/>
-            </a:pPr>
-            <a:r>
-              <a:rPr lang="de-DE" dirty="0"/>
-              <a:t>Löschen Sie alle Zellen mit den Werten 5 aus der</a:t>
-            </a:r>
-          </a:p>
-          <a:p>
-            <a:pPr marL="0" indent="0">
-              <a:buNone/>
-            </a:pPr>
-            <a:r>
-              <a:rPr lang="de-DE" dirty="0"/>
-              <a:t>Matrix. Die Matrix soll danach nur noch 3 Zeilen </a:t>
-            </a:r>
-          </a:p>
-          <a:p>
-            <a:pPr marL="0" indent="0">
-              <a:buNone/>
-            </a:pPr>
-            <a:r>
-              <a:rPr lang="de-DE" dirty="0"/>
-              <a:t>und 3 Spalten besitzen</a:t>
-            </a:r>
-          </a:p>
-          <a:p>
-            <a:pPr marL="457200" indent="-457200">
-              <a:buFont typeface="+mj-lt"/>
-              <a:buAutoNum type="arabicPeriod"/>
-            </a:pPr>
-            <a:endParaRPr lang="de-DE" dirty="0"/>
-          </a:p>
-          <a:p>
-            <a:pPr marL="457200" indent="-457200">
-              <a:buFont typeface="+mj-lt"/>
-              <a:buAutoNum type="arabicPeriod"/>
-            </a:pPr>
-            <a:endParaRPr lang="de-DE" dirty="0"/>
-          </a:p>
-        </p:txBody>
-      </p:sp>
-      <p:pic>
-        <p:nvPicPr>
-          <p:cNvPr id="5" name="Grafik 4">
-            <a:extLst>
-              <a:ext uri="{FF2B5EF4-FFF2-40B4-BE49-F238E27FC236}">
-                <a16:creationId xmlns:a16="http://schemas.microsoft.com/office/drawing/2014/main" id="{CC057750-FEE5-407E-9EEA-71F34CEE4D9A}"/>
-              </a:ext>
-            </a:extLst>
-          </p:cNvPr>
-          <p:cNvPicPr>
-            <a:picLocks noChangeAspect="1"/>
-          </p:cNvPicPr>
-          <p:nvPr/>
-        </p:nvPicPr>
-        <p:blipFill>
-          <a:blip r:embed="rId2">
-            <a:extLst>
-              <a:ext uri="{28A0092B-C50C-407E-A947-70E740481C1C}">
-                <a14:useLocalDpi xmlns:a14="http://schemas.microsoft.com/office/drawing/2010/main" val="0"/>
-              </a:ext>
-            </a:extLst>
-          </a:blip>
-          <a:stretch>
-            <a:fillRect/>
-          </a:stretch>
-        </p:blipFill>
-        <p:spPr>
-          <a:xfrm>
-            <a:off x="7397842" y="3161924"/>
-            <a:ext cx="3289247" cy="2423143"/>
-          </a:xfrm>
-          <a:prstGeom prst="rect">
-            <a:avLst/>
-          </a:prstGeom>
-        </p:spPr>
-      </p:pic>
     </p:spTree>
     <p:extLst>
       <p:ext uri="{BB962C8B-B14F-4D97-AF65-F5344CB8AC3E}">
@@ -13752,181 +13172,19 @@
         </p:nvSpPr>
         <p:spPr>
           <a:xfrm>
-            <a:off x="676656" y="175339"/>
-            <a:ext cx="10772775" cy="439516"/>
+            <a:off x="709612" y="884788"/>
+            <a:ext cx="10772775" cy="1558868"/>
           </a:xfrm>
         </p:spPr>
         <p:txBody>
           <a:bodyPr>
-            <a:normAutofit fontScale="90000"/>
+            <a:normAutofit/>
           </a:bodyPr>
           <a:lstStyle/>
           <a:p>
             <a:r>
-              <a:rPr lang="de-DE" sz="4400" b="1" dirty="0"/>
+              <a:rPr lang="de-DE" b="1" dirty="0"/>
               <a:t>Übung: Dataframes</a:t>
-            </a:r>
-          </a:p>
-        </p:txBody>
-      </p:sp>
-      <p:sp>
-        <p:nvSpPr>
-          <p:cNvPr id="3" name="Inhaltsplatzhalter 2">
-            <a:extLst>
-              <a:ext uri="{FF2B5EF4-FFF2-40B4-BE49-F238E27FC236}">
-                <a16:creationId xmlns:a16="http://schemas.microsoft.com/office/drawing/2014/main" id="{9D8D5F8B-2B79-4023-9636-42E270F563E0}"/>
-              </a:ext>
-            </a:extLst>
-          </p:cNvPr>
-          <p:cNvSpPr>
-            <a:spLocks noGrp="1"/>
-          </p:cNvSpPr>
-          <p:nvPr>
-            <p:ph idx="1"/>
-          </p:nvPr>
-        </p:nvSpPr>
-        <p:spPr>
-          <a:xfrm>
-            <a:off x="676656" y="733097"/>
-            <a:ext cx="10902200" cy="5784661"/>
-          </a:xfrm>
-        </p:spPr>
-        <p:txBody>
-          <a:bodyPr>
-            <a:normAutofit lnSpcReduction="10000"/>
-          </a:bodyPr>
-          <a:lstStyle/>
-          <a:p>
-            <a:pPr marL="457200" indent="-457200">
-              <a:buFont typeface="+mj-lt"/>
-              <a:buAutoNum type="arabicPeriod"/>
-            </a:pPr>
-            <a:r>
-              <a:rPr lang="de-DE" sz="2800" dirty="0"/>
-              <a:t>Lesen sie den Datensatz pirates.csv in R mittels Funktion read.csv() ein oder über ‚</a:t>
-            </a:r>
-            <a:r>
-              <a:rPr lang="de-DE" sz="2800" dirty="0" err="1"/>
-              <a:t>import</a:t>
-            </a:r>
-            <a:r>
-              <a:rPr lang="de-DE" sz="2800" dirty="0"/>
-              <a:t> Dataset‘ in der Environment</a:t>
-            </a:r>
-          </a:p>
-          <a:p>
-            <a:pPr marL="457200" indent="-457200">
-              <a:buFont typeface="+mj-lt"/>
-              <a:buAutoNum type="arabicPeriod"/>
-            </a:pPr>
-            <a:r>
-              <a:rPr lang="de-DE" sz="2800" dirty="0"/>
-              <a:t>Berechnen Sie die mittlere Anzahl an Tattoos pro </a:t>
-            </a:r>
-            <a:r>
-              <a:rPr lang="de-DE" sz="2800" dirty="0" err="1"/>
-              <a:t>Pirat:in</a:t>
-            </a:r>
-            <a:endParaRPr lang="de-DE" sz="2800" dirty="0"/>
-          </a:p>
-          <a:p>
-            <a:pPr marL="457200" indent="-457200">
-              <a:buFont typeface="+mj-lt"/>
-              <a:buAutoNum type="arabicPeriod"/>
-            </a:pPr>
-            <a:r>
-              <a:rPr lang="de-DE" sz="2800" dirty="0"/>
-              <a:t>Wie viele Papageien besitzen alle </a:t>
-            </a:r>
-            <a:r>
-              <a:rPr lang="de-DE" sz="2800" dirty="0" err="1"/>
-              <a:t>Pirat:innen</a:t>
-            </a:r>
-            <a:r>
-              <a:rPr lang="de-DE" sz="2800" dirty="0"/>
-              <a:t> insgesamt?</a:t>
-            </a:r>
-          </a:p>
-          <a:p>
-            <a:pPr marL="457200" indent="-457200">
-              <a:buFont typeface="+mj-lt"/>
-              <a:buAutoNum type="arabicPeriod"/>
-            </a:pPr>
-            <a:r>
-              <a:rPr lang="de-DE" sz="2800" dirty="0"/>
-              <a:t>Wie viele </a:t>
-            </a:r>
-            <a:r>
-              <a:rPr lang="de-DE" sz="2800" dirty="0" err="1"/>
-              <a:t>Pirat:innen</a:t>
-            </a:r>
-            <a:r>
-              <a:rPr lang="de-DE" sz="2800" dirty="0"/>
-              <a:t> tragen eine Augenklappe?</a:t>
-            </a:r>
-          </a:p>
-          <a:p>
-            <a:pPr marL="457200" indent="-457200">
-              <a:buFont typeface="+mj-lt"/>
-              <a:buAutoNum type="arabicPeriod"/>
-            </a:pPr>
-            <a:r>
-              <a:rPr lang="de-DE" sz="2800" dirty="0"/>
-              <a:t>Welche Lieblingspiraten gibt es? Finden Sie hierfür eigenständig eine geeignete Funktion, die eindeutige Werte in einem Vektor auflistet</a:t>
-            </a:r>
-          </a:p>
-          <a:p>
-            <a:pPr marL="457200" indent="-457200">
-              <a:buFont typeface="+mj-lt"/>
-              <a:buAutoNum type="arabicPeriod"/>
-            </a:pPr>
-            <a:r>
-              <a:rPr lang="de-DE" sz="2800" dirty="0"/>
-              <a:t>Legen Sie eine neue Spalte mit Namen </a:t>
-            </a:r>
-            <a:r>
-              <a:rPr lang="de-DE" sz="2800" b="1" dirty="0"/>
-              <a:t>BMI</a:t>
-            </a:r>
-            <a:r>
-              <a:rPr lang="de-DE" sz="2800" dirty="0"/>
-              <a:t> an (Body </a:t>
-            </a:r>
-            <a:r>
-              <a:rPr lang="de-DE" sz="2800" dirty="0" err="1"/>
-              <a:t>Mass</a:t>
-            </a:r>
-            <a:r>
-              <a:rPr lang="de-DE" sz="2800" dirty="0"/>
-              <a:t> Index) und speichern Sie in diese Spalte das jeweilige Ergebnis von Gewicht geteilt durch Größe</a:t>
-            </a:r>
-          </a:p>
-          <a:p>
-            <a:pPr marL="457200" indent="-457200">
-              <a:buFont typeface="+mj-lt"/>
-              <a:buAutoNum type="arabicPeriod"/>
-            </a:pPr>
-            <a:r>
-              <a:rPr lang="de-DE" sz="2800" dirty="0"/>
-              <a:t>Welche </a:t>
-            </a:r>
-            <a:r>
-              <a:rPr lang="de-DE" sz="2800" dirty="0" err="1"/>
-              <a:t>Pirat:in</a:t>
-            </a:r>
-            <a:r>
-              <a:rPr lang="de-DE" sz="2800" dirty="0"/>
-              <a:t> hat den größten BMI? Welche den Kleinsten?</a:t>
-            </a:r>
-          </a:p>
-          <a:p>
-            <a:pPr marL="457200" indent="-457200">
-              <a:buFont typeface="+mj-lt"/>
-              <a:buAutoNum type="arabicPeriod"/>
-            </a:pPr>
-            <a:r>
-              <a:rPr lang="de-DE" sz="2800" dirty="0"/>
-              <a:t>Berechnen Sie den mittleren BMI einmal für Piratinnen und einmal für Piraten</a:t>
             </a:r>
           </a:p>
         </p:txBody>
@@ -14003,7 +13261,7 @@
                   <a:schemeClr val="bg1"/>
                 </a:solidFill>
               </a:rPr>
-              <a:t>Visualisierungen</a:t>
+              <a:t>Grafiken</a:t>
             </a:r>
             <a:br>
               <a:rPr lang="de-DE" b="1" dirty="0">
@@ -14195,7 +13453,7 @@
         </p:nvSpPr>
         <p:spPr>
           <a:xfrm>
-            <a:off x="657606" y="564795"/>
+            <a:off x="610309" y="935284"/>
             <a:ext cx="10772775" cy="1030680"/>
           </a:xfrm>
         </p:spPr>
@@ -14207,150 +13465,6 @@
               <a:rPr lang="de-DE" b="1" dirty="0"/>
               <a:t>Übung Histogramm</a:t>
             </a:r>
-          </a:p>
-        </p:txBody>
-      </p:sp>
-      <p:sp>
-        <p:nvSpPr>
-          <p:cNvPr id="3" name="Inhaltsplatzhalter 2">
-            <a:extLst>
-              <a:ext uri="{FF2B5EF4-FFF2-40B4-BE49-F238E27FC236}">
-                <a16:creationId xmlns:a16="http://schemas.microsoft.com/office/drawing/2014/main" id="{AEB01630-4D3C-4E88-AC29-25204C1F7989}"/>
-              </a:ext>
-            </a:extLst>
-          </p:cNvPr>
-          <p:cNvSpPr>
-            <a:spLocks noGrp="1"/>
-          </p:cNvSpPr>
-          <p:nvPr>
-            <p:ph idx="1"/>
-          </p:nvPr>
-        </p:nvSpPr>
-        <p:spPr>
-          <a:xfrm>
-            <a:off x="676656" y="1655380"/>
-            <a:ext cx="10753725" cy="4122486"/>
-          </a:xfrm>
-        </p:spPr>
-        <p:txBody>
-          <a:bodyPr/>
-          <a:lstStyle/>
-          <a:p>
-            <a:pPr marL="457200" indent="-457200">
-              <a:lnSpc>
-                <a:spcPct val="100000"/>
-              </a:lnSpc>
-              <a:buFont typeface="+mj-lt"/>
-              <a:buAutoNum type="arabicPeriod"/>
-            </a:pPr>
-            <a:r>
-              <a:rPr lang="de-DE" sz="2800" dirty="0"/>
-              <a:t>Erstellen Sie ein Histogramm, das die Verteilung von BMI darstellt</a:t>
-            </a:r>
-          </a:p>
-          <a:p>
-            <a:pPr marL="457200" indent="-457200">
-              <a:lnSpc>
-                <a:spcPct val="100000"/>
-              </a:lnSpc>
-              <a:buFont typeface="+mj-lt"/>
-              <a:buAutoNum type="arabicPeriod"/>
-            </a:pPr>
-            <a:r>
-              <a:rPr lang="de-DE" sz="2800" dirty="0"/>
-              <a:t>Fügen Sie einen Titel und Achsenbeschriftungen hinzu</a:t>
-            </a:r>
-          </a:p>
-          <a:p>
-            <a:pPr marL="457200" indent="-457200">
-              <a:lnSpc>
-                <a:spcPct val="100000"/>
-              </a:lnSpc>
-              <a:buFont typeface="+mj-lt"/>
-              <a:buAutoNum type="arabicPeriod"/>
-            </a:pPr>
-            <a:r>
-              <a:rPr lang="de-DE" sz="2800" dirty="0"/>
-              <a:t>Zeichnen Sie den Mittelwert von BMI mittels </a:t>
-            </a:r>
-            <a:r>
-              <a:rPr lang="de-DE" sz="2800" dirty="0" err="1"/>
-              <a:t>abline</a:t>
-            </a:r>
-            <a:r>
-              <a:rPr lang="de-DE" sz="2800" dirty="0"/>
-              <a:t>() ins Histogramm</a:t>
-            </a:r>
-          </a:p>
-          <a:p>
-            <a:pPr marL="457200" indent="-457200">
-              <a:lnSpc>
-                <a:spcPct val="100000"/>
-              </a:lnSpc>
-              <a:buFont typeface="+mj-lt"/>
-              <a:buAutoNum type="arabicPeriod"/>
-            </a:pPr>
-            <a:r>
-              <a:rPr lang="de-DE" sz="2800" dirty="0"/>
-              <a:t>Toben Sie sich aus mit den Farben! (</a:t>
-            </a:r>
-            <a:r>
-              <a:rPr lang="de-DE" sz="2800" dirty="0" err="1"/>
-              <a:t>colors</a:t>
-            </a:r>
-            <a:r>
-              <a:rPr lang="de-DE" sz="2800" dirty="0"/>
-              <a:t>() für einen Überblick)</a:t>
-            </a:r>
-          </a:p>
-          <a:p>
-            <a:pPr marL="457200" indent="-457200">
-              <a:lnSpc>
-                <a:spcPct val="100000"/>
-              </a:lnSpc>
-              <a:buFont typeface="+mj-lt"/>
-              <a:buAutoNum type="arabicPeriod"/>
-            </a:pPr>
-            <a:r>
-              <a:rPr lang="de-DE" sz="2800" dirty="0"/>
-              <a:t>Fügen Sie ebenfalls mit </a:t>
-            </a:r>
-            <a:r>
-              <a:rPr lang="de-DE" sz="2800" dirty="0" err="1"/>
-              <a:t>abline</a:t>
-            </a:r>
-            <a:r>
-              <a:rPr lang="de-DE" sz="2800" dirty="0"/>
-              <a:t>() horizontale Linien im Abstand von 50 dem Diagramm in der Farbe „grey90“ hinzu</a:t>
-            </a:r>
-          </a:p>
-          <a:p>
-            <a:pPr marL="457200" indent="-457200">
-              <a:lnSpc>
-                <a:spcPct val="100000"/>
-              </a:lnSpc>
-              <a:buFont typeface="+mj-lt"/>
-              <a:buAutoNum type="arabicPeriod"/>
-            </a:pPr>
-            <a:r>
-              <a:rPr lang="de-DE" sz="2800" dirty="0"/>
-              <a:t>Exportieren Sie das Histogramm als </a:t>
-            </a:r>
-            <a:r>
-              <a:rPr lang="de-DE" sz="2800" dirty="0" err="1"/>
-              <a:t>png</a:t>
-            </a:r>
-            <a:r>
-              <a:rPr lang="de-DE" sz="2800" dirty="0"/>
-              <a:t> Datei</a:t>
-            </a:r>
-          </a:p>
-          <a:p>
-            <a:pPr marL="457200" indent="-457200">
-              <a:buFont typeface="+mj-lt"/>
-              <a:buAutoNum type="arabicPeriod"/>
-            </a:pPr>
-            <a:endParaRPr lang="de-DE" dirty="0"/>
           </a:p>
         </p:txBody>
       </p:sp>
@@ -14503,7 +13617,7 @@
         </p:nvSpPr>
         <p:spPr>
           <a:xfrm>
-            <a:off x="657224" y="499533"/>
+            <a:off x="633576" y="1390284"/>
             <a:ext cx="10772775" cy="962444"/>
           </a:xfrm>
         </p:spPr>
@@ -14514,129 +13628,6 @@
             <a:r>
               <a:rPr lang="de-DE" b="1" dirty="0"/>
               <a:t>Übung Dichtediagramm</a:t>
-            </a:r>
-          </a:p>
-        </p:txBody>
-      </p:sp>
-      <p:sp>
-        <p:nvSpPr>
-          <p:cNvPr id="3" name="Inhaltsplatzhalter 2">
-            <a:extLst>
-              <a:ext uri="{FF2B5EF4-FFF2-40B4-BE49-F238E27FC236}">
-                <a16:creationId xmlns:a16="http://schemas.microsoft.com/office/drawing/2014/main" id="{EB53CCCD-2653-4D70-84E4-4FF62208D816}"/>
-              </a:ext>
-            </a:extLst>
-          </p:cNvPr>
-          <p:cNvSpPr>
-            <a:spLocks noGrp="1"/>
-          </p:cNvSpPr>
-          <p:nvPr>
-            <p:ph idx="1"/>
-          </p:nvPr>
-        </p:nvSpPr>
-        <p:spPr>
-          <a:xfrm>
-            <a:off x="658553" y="1371600"/>
-            <a:ext cx="10753725" cy="4779335"/>
-          </a:xfrm>
-        </p:spPr>
-        <p:txBody>
-          <a:bodyPr>
-            <a:normAutofit fontScale="92500"/>
-          </a:bodyPr>
-          <a:lstStyle/>
-          <a:p>
-            <a:pPr marL="457200" indent="-457200">
-              <a:lnSpc>
-                <a:spcPct val="150000"/>
-              </a:lnSpc>
-              <a:buFont typeface="+mj-lt"/>
-              <a:buAutoNum type="arabicPeriod"/>
-            </a:pPr>
-            <a:r>
-              <a:rPr lang="de-DE" sz="2800" dirty="0"/>
-              <a:t>Erstellen Sie ein Dichtediagramm mit dem BMI der männlichen Piraten</a:t>
-            </a:r>
-          </a:p>
-          <a:p>
-            <a:pPr marL="457200" indent="-457200">
-              <a:lnSpc>
-                <a:spcPct val="100000"/>
-              </a:lnSpc>
-              <a:buFont typeface="+mj-lt"/>
-              <a:buAutoNum type="arabicPeriod"/>
-            </a:pPr>
-            <a:r>
-              <a:rPr lang="de-DE" sz="2800" dirty="0"/>
-              <a:t>Fügen Sie mit </a:t>
-            </a:r>
-            <a:r>
-              <a:rPr lang="de-DE" sz="2800" dirty="0" err="1"/>
-              <a:t>lines</a:t>
-            </a:r>
-            <a:r>
-              <a:rPr lang="de-DE" sz="2800" dirty="0"/>
-              <a:t>() eine Dichtekurve des BMI der weiblichen Piratinnen hinzu</a:t>
-            </a:r>
-          </a:p>
-          <a:p>
-            <a:pPr marL="457200" indent="-457200">
-              <a:lnSpc>
-                <a:spcPct val="100000"/>
-              </a:lnSpc>
-              <a:buFont typeface="+mj-lt"/>
-              <a:buAutoNum type="arabicPeriod"/>
-            </a:pPr>
-            <a:r>
-              <a:rPr lang="de-DE" sz="2800" dirty="0"/>
-              <a:t>Passen Sie Farbe, Titel, Achsenbeschriftung und ggf. die Achsenlimitierung an</a:t>
-            </a:r>
-          </a:p>
-          <a:p>
-            <a:pPr marL="457200" indent="-457200">
-              <a:lnSpc>
-                <a:spcPct val="100000"/>
-              </a:lnSpc>
-              <a:buFont typeface="+mj-lt"/>
-              <a:buAutoNum type="arabicPeriod"/>
-            </a:pPr>
-            <a:r>
-              <a:rPr lang="de-DE" sz="2800" dirty="0"/>
-              <a:t>Zeichnen Sie die jeweiligen BMI Mittelwerte der Piratinnen und Piraten ein</a:t>
-            </a:r>
-          </a:p>
-          <a:p>
-            <a:pPr marL="457200" indent="-457200">
-              <a:lnSpc>
-                <a:spcPct val="150000"/>
-              </a:lnSpc>
-              <a:buFont typeface="+mj-lt"/>
-              <a:buAutoNum type="arabicPeriod"/>
-            </a:pPr>
-            <a:r>
-              <a:rPr lang="de-DE" sz="2800" dirty="0"/>
-              <a:t>Fügen Sie eine passende Legende hinzu</a:t>
-            </a:r>
-          </a:p>
-          <a:p>
-            <a:pPr marL="457200" indent="-457200">
-              <a:lnSpc>
-                <a:spcPct val="150000"/>
-              </a:lnSpc>
-              <a:buFont typeface="+mj-lt"/>
-              <a:buAutoNum type="arabicPeriod"/>
-            </a:pPr>
-            <a:r>
-              <a:rPr lang="de-DE" sz="2800" dirty="0"/>
-              <a:t>Exportieren Sie den Plot als </a:t>
-            </a:r>
-            <a:r>
-              <a:rPr lang="de-DE" sz="2800" dirty="0" err="1"/>
-              <a:t>png</a:t>
-            </a:r>
-            <a:r>
-              <a:rPr lang="de-DE" sz="2800" dirty="0"/>
-              <a:t> Datei</a:t>
             </a:r>
           </a:p>
         </p:txBody>
@@ -14790,7 +13781,7 @@
         </p:nvSpPr>
         <p:spPr>
           <a:xfrm>
-            <a:off x="657224" y="499533"/>
+            <a:off x="709612" y="1138036"/>
             <a:ext cx="10772775" cy="978393"/>
           </a:xfrm>
         </p:spPr>
@@ -14801,95 +13792,6 @@
             <a:r>
               <a:rPr lang="de-DE" b="1" dirty="0"/>
               <a:t>Übung Boxplot</a:t>
-            </a:r>
-          </a:p>
-        </p:txBody>
-      </p:sp>
-      <p:sp>
-        <p:nvSpPr>
-          <p:cNvPr id="3" name="Inhaltsplatzhalter 2">
-            <a:extLst>
-              <a:ext uri="{FF2B5EF4-FFF2-40B4-BE49-F238E27FC236}">
-                <a16:creationId xmlns:a16="http://schemas.microsoft.com/office/drawing/2014/main" id="{6E9C5726-98EE-4E55-ACF4-D2405C5D031F}"/>
-              </a:ext>
-            </a:extLst>
-          </p:cNvPr>
-          <p:cNvSpPr>
-            <a:spLocks noGrp="1"/>
-          </p:cNvSpPr>
-          <p:nvPr>
-            <p:ph idx="1"/>
-          </p:nvPr>
-        </p:nvSpPr>
-        <p:spPr>
-          <a:xfrm>
-            <a:off x="676656" y="1584252"/>
-            <a:ext cx="10753725" cy="4193614"/>
-          </a:xfrm>
-        </p:spPr>
-        <p:txBody>
-          <a:bodyPr>
-            <a:normAutofit/>
-          </a:bodyPr>
-          <a:lstStyle/>
-          <a:p>
-            <a:pPr marL="457200" indent="-457200">
-              <a:lnSpc>
-                <a:spcPct val="150000"/>
-              </a:lnSpc>
-              <a:buFont typeface="+mj-lt"/>
-              <a:buAutoNum type="arabicPeriod"/>
-            </a:pPr>
-            <a:r>
-              <a:rPr lang="de-DE" sz="2800" dirty="0"/>
-              <a:t>Lesen Sie den MM.txt Datensatz ein</a:t>
-            </a:r>
-          </a:p>
-          <a:p>
-            <a:pPr marL="457200" indent="-457200">
-              <a:lnSpc>
-                <a:spcPct val="150000"/>
-              </a:lnSpc>
-              <a:buFont typeface="+mj-lt"/>
-              <a:buAutoNum type="arabicPeriod"/>
-            </a:pPr>
-            <a:r>
-              <a:rPr lang="de-DE" sz="2800" dirty="0"/>
-              <a:t>Erstellen Sie einen Boxplot der ausschließlich die Verteilung der M&amp;Ms nach Farbe darstellt. Passen Sie eventuell das </a:t>
-            </a:r>
-            <a:r>
-              <a:rPr lang="de-DE" sz="2800" i="1" dirty="0" err="1"/>
-              <a:t>outline</a:t>
-            </a:r>
-            <a:r>
-              <a:rPr lang="de-DE" sz="2800" dirty="0"/>
-              <a:t> Argument an</a:t>
-            </a:r>
-          </a:p>
-          <a:p>
-            <a:pPr marL="457200" indent="-457200">
-              <a:lnSpc>
-                <a:spcPct val="150000"/>
-              </a:lnSpc>
-              <a:buFont typeface="+mj-lt"/>
-              <a:buAutoNum type="arabicPeriod"/>
-            </a:pPr>
-            <a:r>
-              <a:rPr lang="de-DE" sz="2800" dirty="0"/>
-              <a:t>Färben Sie die Boxen entsprechend der M&amp;M Farben an</a:t>
-            </a:r>
-          </a:p>
-          <a:p>
-            <a:pPr marL="457200" indent="-457200">
-              <a:lnSpc>
-                <a:spcPct val="150000"/>
-              </a:lnSpc>
-              <a:buFont typeface="+mj-lt"/>
-              <a:buAutoNum type="arabicPeriod"/>
-            </a:pPr>
-            <a:r>
-              <a:rPr lang="de-DE" sz="2800" dirty="0"/>
-              <a:t>Exportieren Sie die Grafik</a:t>
             </a:r>
           </a:p>
         </p:txBody>
@@ -15042,7 +13944,7 @@
         </p:nvSpPr>
         <p:spPr>
           <a:xfrm>
-            <a:off x="657224" y="499533"/>
+            <a:off x="641458" y="893671"/>
             <a:ext cx="10772775" cy="994341"/>
           </a:xfrm>
         </p:spPr>
@@ -15054,123 +13956,6 @@
               <a:rPr lang="de-DE" b="1" dirty="0"/>
               <a:t>Übung Balkendiagramm</a:t>
             </a:r>
-          </a:p>
-        </p:txBody>
-      </p:sp>
-      <p:sp>
-        <p:nvSpPr>
-          <p:cNvPr id="3" name="Inhaltsplatzhalter 2">
-            <a:extLst>
-              <a:ext uri="{FF2B5EF4-FFF2-40B4-BE49-F238E27FC236}">
-                <a16:creationId xmlns:a16="http://schemas.microsoft.com/office/drawing/2014/main" id="{A75420BA-BAEC-4AB1-87D8-BF813BC3BFA7}"/>
-              </a:ext>
-            </a:extLst>
-          </p:cNvPr>
-          <p:cNvSpPr>
-            <a:spLocks noGrp="1"/>
-          </p:cNvSpPr>
-          <p:nvPr>
-            <p:ph idx="1"/>
-          </p:nvPr>
-        </p:nvSpPr>
-        <p:spPr>
-          <a:xfrm>
-            <a:off x="676656" y="1642730"/>
-            <a:ext cx="10753725" cy="4864396"/>
-          </a:xfrm>
-        </p:spPr>
-        <p:txBody>
-          <a:bodyPr>
-            <a:normAutofit/>
-          </a:bodyPr>
-          <a:lstStyle/>
-          <a:p>
-            <a:pPr marL="457200" indent="-457200">
-              <a:lnSpc>
-                <a:spcPct val="150000"/>
-              </a:lnSpc>
-              <a:buFont typeface="+mj-lt"/>
-              <a:buAutoNum type="arabicPeriod"/>
-            </a:pPr>
-            <a:r>
-              <a:rPr lang="de-DE" dirty="0"/>
-              <a:t>Lesen Sie den MM.txt Datensatz ein</a:t>
-            </a:r>
-          </a:p>
-          <a:p>
-            <a:pPr marL="457200" indent="-457200">
-              <a:lnSpc>
-                <a:spcPct val="100000"/>
-              </a:lnSpc>
-              <a:buFont typeface="+mj-lt"/>
-              <a:buAutoNum type="arabicPeriod"/>
-            </a:pPr>
-            <a:r>
-              <a:rPr lang="de-DE" dirty="0"/>
-              <a:t>Erstellen Sie einen </a:t>
-            </a:r>
-            <a:r>
-              <a:rPr lang="de-DE" dirty="0" err="1"/>
-              <a:t>Barplot</a:t>
-            </a:r>
-            <a:r>
-              <a:rPr lang="de-DE" dirty="0"/>
-              <a:t> der die Gesamtzahl M&amp;Ms pro Farbe zeigt. (Tipp: Finden Sie im Vorfeld eine geeignete Funktion, die die Summe pro Spalte berechnet)</a:t>
-            </a:r>
-          </a:p>
-          <a:p>
-            <a:pPr marL="457200" indent="-457200">
-              <a:lnSpc>
-                <a:spcPct val="110000"/>
-              </a:lnSpc>
-              <a:buFont typeface="+mj-lt"/>
-              <a:buAutoNum type="arabicPeriod"/>
-            </a:pPr>
-            <a:r>
-              <a:rPr lang="de-DE" dirty="0"/>
-              <a:t>Passen Sie gegebenenfalls die Ränder des Plot-Fensters und drehen Sie ggf. die Achsenbeschriftung um 90°</a:t>
-            </a:r>
-          </a:p>
-          <a:p>
-            <a:pPr marL="457200" indent="-457200">
-              <a:lnSpc>
-                <a:spcPct val="100000"/>
-              </a:lnSpc>
-              <a:buFont typeface="+mj-lt"/>
-              <a:buAutoNum type="arabicPeriod"/>
-            </a:pPr>
-            <a:r>
-              <a:rPr lang="de-DE" dirty="0"/>
-              <a:t>Färben Sie die Balken entsprechend der M&amp;M Farbe ein und fügen Sie einen Titel hinzu</a:t>
-            </a:r>
-          </a:p>
-          <a:p>
-            <a:pPr marL="457200" indent="-457200">
-              <a:lnSpc>
-                <a:spcPct val="150000"/>
-              </a:lnSpc>
-              <a:buFont typeface="+mj-lt"/>
-              <a:buAutoNum type="arabicPeriod"/>
-            </a:pPr>
-            <a:r>
-              <a:rPr lang="de-DE" dirty="0"/>
-              <a:t>Exportieren Sie die Grafik als </a:t>
-            </a:r>
-            <a:r>
-              <a:rPr lang="de-DE" dirty="0" err="1"/>
-              <a:t>png</a:t>
-            </a:r>
-            <a:r>
-              <a:rPr lang="de-DE" dirty="0"/>
-              <a:t> Datei</a:t>
-            </a:r>
-          </a:p>
-          <a:p>
-            <a:pPr marL="457200" indent="-457200">
-              <a:buFont typeface="+mj-lt"/>
-              <a:buAutoNum type="arabicPeriod"/>
-            </a:pPr>
-            <a:endParaRPr lang="de-DE" dirty="0"/>
           </a:p>
         </p:txBody>
       </p:sp>
@@ -15442,7 +14227,7 @@
         </p:nvSpPr>
         <p:spPr>
           <a:xfrm>
-            <a:off x="676656" y="122078"/>
+            <a:off x="653008" y="799995"/>
             <a:ext cx="10772775" cy="1105983"/>
           </a:xfrm>
         </p:spPr>
@@ -15453,137 +14238,6 @@
             <a:r>
               <a:rPr lang="de-DE" b="1" dirty="0"/>
               <a:t>Übung Scatterplot</a:t>
-            </a:r>
-          </a:p>
-        </p:txBody>
-      </p:sp>
-      <p:sp>
-        <p:nvSpPr>
-          <p:cNvPr id="3" name="Inhaltsplatzhalter 2">
-            <a:extLst>
-              <a:ext uri="{FF2B5EF4-FFF2-40B4-BE49-F238E27FC236}">
-                <a16:creationId xmlns:a16="http://schemas.microsoft.com/office/drawing/2014/main" id="{BB1AE5D9-AA34-4D6A-B607-A97AF39B932D}"/>
-              </a:ext>
-            </a:extLst>
-          </p:cNvPr>
-          <p:cNvSpPr>
-            <a:spLocks noGrp="1"/>
-          </p:cNvSpPr>
-          <p:nvPr>
-            <p:ph idx="1"/>
-          </p:nvPr>
-        </p:nvSpPr>
-        <p:spPr>
-          <a:xfrm>
-            <a:off x="676656" y="1164266"/>
-            <a:ext cx="10981944" cy="5427920"/>
-          </a:xfrm>
-        </p:spPr>
-        <p:txBody>
-          <a:bodyPr>
-            <a:normAutofit fontScale="85000" lnSpcReduction="20000"/>
-          </a:bodyPr>
-          <a:lstStyle/>
-          <a:p>
-            <a:pPr marL="457200" indent="-457200">
-              <a:lnSpc>
-                <a:spcPct val="120000"/>
-              </a:lnSpc>
-              <a:buFont typeface="+mj-lt"/>
-              <a:buAutoNum type="arabicPeriod"/>
-            </a:pPr>
-            <a:r>
-              <a:rPr lang="de-DE" sz="2800" dirty="0"/>
-              <a:t>Fügen Sie dem M&amp;M Datensatz eine Spalte hinzu in der die Gesamtanzahl M&amp;Ms pro Tüte gespeichert ist (Tipp: Es gibt eine Funktion die Summen pro Zeilen berechnet)</a:t>
-            </a:r>
-          </a:p>
-          <a:p>
-            <a:pPr marL="457200" indent="-457200">
-              <a:lnSpc>
-                <a:spcPct val="120000"/>
-              </a:lnSpc>
-              <a:buFont typeface="+mj-lt"/>
-              <a:buAutoNum type="arabicPeriod"/>
-            </a:pPr>
-            <a:r>
-              <a:rPr lang="de-DE" sz="2800" dirty="0"/>
-              <a:t>Erstellen Sie einen Scatterplot bei dem das Gewicht der Tüte im Verhältnis zu der Gesamtanzahl M&amp;Ms dargestellt ist</a:t>
-            </a:r>
-          </a:p>
-          <a:p>
-            <a:pPr marL="457200" indent="-457200">
-              <a:lnSpc>
-                <a:spcPct val="150000"/>
-              </a:lnSpc>
-              <a:buFont typeface="+mj-lt"/>
-              <a:buAutoNum type="arabicPeriod"/>
-            </a:pPr>
-            <a:r>
-              <a:rPr lang="de-DE" sz="2800" dirty="0"/>
-              <a:t>Passen Sie Titel, Achsenbeschriftung und ggf. das Punkt-Symbol an</a:t>
-            </a:r>
-          </a:p>
-          <a:p>
-            <a:pPr marL="457200" indent="-457200">
-              <a:lnSpc>
-                <a:spcPct val="150000"/>
-              </a:lnSpc>
-              <a:buFont typeface="+mj-lt"/>
-              <a:buAutoNum type="arabicPeriod"/>
-            </a:pPr>
-            <a:r>
-              <a:rPr lang="de-DE" sz="2800" dirty="0"/>
-              <a:t>Fügen Sie eine Trendlinie mittels </a:t>
-            </a:r>
-            <a:r>
-              <a:rPr lang="de-DE" sz="2800" dirty="0" err="1"/>
-              <a:t>line</a:t>
-            </a:r>
-            <a:r>
-              <a:rPr lang="de-DE" sz="2800" dirty="0"/>
-              <a:t>() und </a:t>
-            </a:r>
-            <a:r>
-              <a:rPr lang="de-DE" sz="2800" dirty="0" err="1"/>
-              <a:t>smooth.spline</a:t>
-            </a:r>
-            <a:r>
-              <a:rPr lang="de-DE" sz="2800" dirty="0"/>
-              <a:t>() hinzu</a:t>
-            </a:r>
-          </a:p>
-          <a:p>
-            <a:pPr marL="457200" indent="-457200">
-              <a:lnSpc>
-                <a:spcPct val="150000"/>
-              </a:lnSpc>
-              <a:buFont typeface="+mj-lt"/>
-              <a:buAutoNum type="arabicPeriod"/>
-            </a:pPr>
-            <a:r>
-              <a:rPr lang="de-DE" sz="2800" dirty="0"/>
-              <a:t>Berechnen Sie den Korrelationskoeffizienten nach Spearman und fügen Sie das Ergebnis dem Plot mittels </a:t>
-            </a:r>
-            <a:r>
-              <a:rPr lang="de-DE" sz="2800" dirty="0" err="1"/>
-              <a:t>text</a:t>
-            </a:r>
-            <a:r>
-              <a:rPr lang="de-DE" sz="2800" dirty="0"/>
-              <a:t>() hinzu</a:t>
-            </a:r>
-          </a:p>
-          <a:p>
-            <a:pPr marL="457200" indent="-457200">
-              <a:lnSpc>
-                <a:spcPct val="150000"/>
-              </a:lnSpc>
-              <a:buFont typeface="+mj-lt"/>
-              <a:buAutoNum type="arabicPeriod"/>
-            </a:pPr>
-            <a:r>
-              <a:rPr lang="de-DE" sz="2800" dirty="0"/>
-              <a:t>Exportieren Sie die Grafik</a:t>
             </a:r>
           </a:p>
         </p:txBody>
@@ -16890,7 +15544,7 @@
                   <a:schemeClr val="bg1"/>
                 </a:solidFill>
               </a:rPr>
-              <a:t>Visualisierungen:</a:t>
+              <a:t>Grafiken:</a:t>
             </a:r>
           </a:p>
           <a:p>

</xml_diff>